<commit_message>
docs: add Quick Reference cheat sheet slide (slide 9) to FPGA presentation
</commit_message>
<xml_diff>
--- a/docs/INT8_Transformer_FPGA_Presentation.pptx
+++ b/docs/INT8_Transformer_FPGA_Presentation.pptx
@@ -13,6 +13,7 @@
     <p:sldId id="261" r:id="rId12"/>
     <p:sldId id="262" r:id="rId13"/>
     <p:sldId id="263" r:id="rId14"/>
+    <p:sldId id="264" r:id="rId15"/>
   </p:sldIdLst>
   <p:sldSz cx="12188952" cy="6858000" type="screen4x3"/>
   <p:notesSz cx="6858000" cy="9144000"/>
@@ -13413,6 +13414,3071 @@
                 </a:solidFill>
               </a:rPr>
               <a:t>Thank You</a:t>
+            </a:r>
+          </a:p>
+        </p:txBody>
+      </p:sp>
+    </p:spTree>
+  </p:cSld>
+  <p:clrMapOvr>
+    <a:masterClrMapping/>
+  </p:clrMapOvr>
+</p:sld>
+</file>
+
+<file path=ppt/slides/slide9.xml><?xml version="1.0" encoding="utf-8"?>
+<p:sld xmlns:a="http://schemas.openxmlformats.org/drawingml/2006/main" xmlns:p="http://schemas.openxmlformats.org/presentationml/2006/main" xmlns:r="http://schemas.openxmlformats.org/officeDocument/2006/relationships">
+  <p:cSld>
+    <p:bg>
+      <p:bgPr>
+        <a:solidFill>
+          <a:srgbClr val="0D1B2A"/>
+        </a:solidFill>
+        <a:effectLst/>
+      </p:bgPr>
+    </p:bg>
+    <p:spTree>
+      <p:nvGrpSpPr>
+        <p:cNvPr id="1" name=""/>
+        <p:cNvGrpSpPr/>
+        <p:nvPr/>
+      </p:nvGrpSpPr>
+      <p:grpSpPr/>
+      <p:sp>
+        <p:nvSpPr>
+          <p:cNvPr id="2" name="Rectangle 1"/>
+          <p:cNvSpPr/>
+          <p:nvPr/>
+        </p:nvSpPr>
+        <p:spPr>
+          <a:xfrm>
+            <a:off x="0" y="0"/>
+            <a:ext cx="12188952" cy="73152"/>
+          </a:xfrm>
+          <a:prstGeom prst="rect">
+            <a:avLst/>
+          </a:prstGeom>
+          <a:solidFill>
+            <a:srgbClr val="00D4FF"/>
+          </a:solidFill>
+          <a:ln>
+            <a:noFill/>
+          </a:ln>
+        </p:spPr>
+        <p:style>
+          <a:lnRef idx="1">
+            <a:schemeClr val="accent1"/>
+          </a:lnRef>
+          <a:fillRef idx="3">
+            <a:schemeClr val="accent1"/>
+          </a:fillRef>
+          <a:effectRef idx="2">
+            <a:schemeClr val="accent1"/>
+          </a:effectRef>
+          <a:fontRef idx="minor">
+            <a:schemeClr val="lt1"/>
+          </a:fontRef>
+        </p:style>
+        <p:txBody>
+          <a:bodyPr rtlCol="0" anchor="ctr"/>
+          <a:lstStyle/>
+          <a:p>
+            <a:pPr algn="ctr"/>
+          </a:p>
+        </p:txBody>
+      </p:sp>
+      <p:sp>
+        <p:nvSpPr>
+          <p:cNvPr id="3" name="TextBox 2"/>
+          <p:cNvSpPr txBox="1"/>
+          <p:nvPr/>
+        </p:nvSpPr>
+        <p:spPr>
+          <a:xfrm>
+            <a:off x="365760" y="137160"/>
+            <a:ext cx="11430000" cy="502920"/>
+          </a:xfrm>
+          <a:prstGeom prst="rect">
+            <a:avLst/>
+          </a:prstGeom>
+          <a:noFill/>
+        </p:spPr>
+        <p:txBody>
+          <a:bodyPr wrap="square">
+            <a:spAutoFit/>
+          </a:bodyPr>
+          <a:lstStyle/>
+          <a:p>
+            <a:pPr algn="l"/>
+            <a:r>
+              <a:rPr sz="2400" b="1" i="0">
+                <a:solidFill>
+                  <a:srgbClr val="00D4FF"/>
+                </a:solidFill>
+              </a:rPr>
+              <a:t>Quick Reference — Board Demo Cheat Sheet</a:t>
+            </a:r>
+          </a:p>
+        </p:txBody>
+      </p:sp>
+      <p:sp>
+        <p:nvSpPr>
+          <p:cNvPr id="4" name="Rectangle 3"/>
+          <p:cNvSpPr/>
+          <p:nvPr/>
+        </p:nvSpPr>
+        <p:spPr>
+          <a:xfrm>
+            <a:off x="365760" y="658368"/>
+            <a:ext cx="11430000" cy="25400"/>
+          </a:xfrm>
+          <a:prstGeom prst="rect">
+            <a:avLst/>
+          </a:prstGeom>
+          <a:solidFill>
+            <a:srgbClr val="7C3AED"/>
+          </a:solidFill>
+          <a:ln>
+            <a:noFill/>
+          </a:ln>
+        </p:spPr>
+        <p:style>
+          <a:lnRef idx="1">
+            <a:schemeClr val="accent1"/>
+          </a:lnRef>
+          <a:fillRef idx="3">
+            <a:schemeClr val="accent1"/>
+          </a:fillRef>
+          <a:effectRef idx="2">
+            <a:schemeClr val="accent1"/>
+          </a:effectRef>
+          <a:fontRef idx="minor">
+            <a:schemeClr val="lt1"/>
+          </a:fontRef>
+        </p:style>
+        <p:txBody>
+          <a:bodyPr rtlCol="0" anchor="ctr"/>
+          <a:lstStyle/>
+          <a:p>
+            <a:pPr algn="ctr"/>
+          </a:p>
+        </p:txBody>
+      </p:sp>
+      <p:sp>
+        <p:nvSpPr>
+          <p:cNvPr id="5" name="Rectangle 4"/>
+          <p:cNvSpPr/>
+          <p:nvPr/>
+        </p:nvSpPr>
+        <p:spPr>
+          <a:xfrm>
+            <a:off x="274320" y="822960"/>
+            <a:ext cx="11640312" cy="3794760"/>
+          </a:xfrm>
+          <a:prstGeom prst="rect">
+            <a:avLst/>
+          </a:prstGeom>
+          <a:solidFill>
+            <a:srgbClr val="0F1E2E"/>
+          </a:solidFill>
+          <a:ln w="15240">
+            <a:solidFill>
+              <a:srgbClr val="00D4FF"/>
+            </a:solidFill>
+          </a:ln>
+        </p:spPr>
+        <p:style>
+          <a:lnRef idx="1">
+            <a:schemeClr val="accent1"/>
+          </a:lnRef>
+          <a:fillRef idx="3">
+            <a:schemeClr val="accent1"/>
+          </a:fillRef>
+          <a:effectRef idx="2">
+            <a:schemeClr val="accent1"/>
+          </a:effectRef>
+          <a:fontRef idx="minor">
+            <a:schemeClr val="lt1"/>
+          </a:fontRef>
+        </p:style>
+        <p:txBody>
+          <a:bodyPr rtlCol="0" anchor="ctr"/>
+          <a:lstStyle/>
+          <a:p>
+            <a:pPr algn="ctr"/>
+          </a:p>
+        </p:txBody>
+      </p:sp>
+      <p:sp>
+        <p:nvSpPr>
+          <p:cNvPr id="6" name="Rectangle 5"/>
+          <p:cNvSpPr/>
+          <p:nvPr/>
+        </p:nvSpPr>
+        <p:spPr>
+          <a:xfrm>
+            <a:off x="274320" y="822960"/>
+            <a:ext cx="11640312" cy="475488"/>
+          </a:xfrm>
+          <a:prstGeom prst="rect">
+            <a:avLst/>
+          </a:prstGeom>
+          <a:solidFill>
+            <a:srgbClr val="1A3A5C"/>
+          </a:solidFill>
+          <a:ln w="15240">
+            <a:solidFill>
+              <a:srgbClr val="00D4FF"/>
+            </a:solidFill>
+          </a:ln>
+        </p:spPr>
+        <p:style>
+          <a:lnRef idx="1">
+            <a:schemeClr val="accent1"/>
+          </a:lnRef>
+          <a:fillRef idx="3">
+            <a:schemeClr val="accent1"/>
+          </a:fillRef>
+          <a:effectRef idx="2">
+            <a:schemeClr val="accent1"/>
+          </a:effectRef>
+          <a:fontRef idx="minor">
+            <a:schemeClr val="lt1"/>
+          </a:fontRef>
+        </p:style>
+        <p:txBody>
+          <a:bodyPr rtlCol="0" anchor="ctr"/>
+          <a:lstStyle/>
+          <a:p>
+            <a:pPr algn="ctr"/>
+          </a:p>
+        </p:txBody>
+      </p:sp>
+      <p:sp>
+        <p:nvSpPr>
+          <p:cNvPr id="7" name="TextBox 6"/>
+          <p:cNvSpPr txBox="1"/>
+          <p:nvPr/>
+        </p:nvSpPr>
+        <p:spPr>
+          <a:xfrm>
+            <a:off x="347472" y="914400"/>
+            <a:ext cx="2011680" cy="320040"/>
+          </a:xfrm>
+          <a:prstGeom prst="rect">
+            <a:avLst/>
+          </a:prstGeom>
+          <a:noFill/>
+        </p:spPr>
+        <p:txBody>
+          <a:bodyPr wrap="square">
+            <a:spAutoFit/>
+          </a:bodyPr>
+          <a:lstStyle/>
+          <a:p>
+            <a:pPr algn="ctr"/>
+            <a:r>
+              <a:rPr sz="1200" b="1" i="0">
+                <a:solidFill>
+                  <a:srgbClr val="00D4FF"/>
+                </a:solidFill>
+              </a:rPr>
+              <a:t>Command</a:t>
+            </a:r>
+          </a:p>
+        </p:txBody>
+      </p:sp>
+      <p:sp>
+        <p:nvSpPr>
+          <p:cNvPr id="8" name="TextBox 7"/>
+          <p:cNvSpPr txBox="1"/>
+          <p:nvPr/>
+        </p:nvSpPr>
+        <p:spPr>
+          <a:xfrm>
+            <a:off x="2450591" y="914400"/>
+            <a:ext cx="658368" cy="320040"/>
+          </a:xfrm>
+          <a:prstGeom prst="rect">
+            <a:avLst/>
+          </a:prstGeom>
+          <a:noFill/>
+        </p:spPr>
+        <p:txBody>
+          <a:bodyPr wrap="square">
+            <a:spAutoFit/>
+          </a:bodyPr>
+          <a:lstStyle/>
+          <a:p>
+            <a:pPr algn="ctr"/>
+            <a:r>
+              <a:rPr sz="1200" b="1" i="0">
+                <a:solidFill>
+                  <a:srgbClr val="00D4FF"/>
+                </a:solidFill>
+              </a:rPr>
+              <a:t>SW4</a:t>
+            </a:r>
+          </a:p>
+        </p:txBody>
+      </p:sp>
+      <p:sp>
+        <p:nvSpPr>
+          <p:cNvPr id="9" name="TextBox 8"/>
+          <p:cNvSpPr txBox="1"/>
+          <p:nvPr/>
+        </p:nvSpPr>
+        <p:spPr>
+          <a:xfrm>
+            <a:off x="3182112" y="914400"/>
+            <a:ext cx="658368" cy="320040"/>
+          </a:xfrm>
+          <a:prstGeom prst="rect">
+            <a:avLst/>
+          </a:prstGeom>
+          <a:noFill/>
+        </p:spPr>
+        <p:txBody>
+          <a:bodyPr wrap="square">
+            <a:spAutoFit/>
+          </a:bodyPr>
+          <a:lstStyle/>
+          <a:p>
+            <a:pPr algn="ctr"/>
+            <a:r>
+              <a:rPr sz="1200" b="1" i="0">
+                <a:solidFill>
+                  <a:srgbClr val="00D4FF"/>
+                </a:solidFill>
+              </a:rPr>
+              <a:t>SW3</a:t>
+            </a:r>
+          </a:p>
+        </p:txBody>
+      </p:sp>
+      <p:sp>
+        <p:nvSpPr>
+          <p:cNvPr id="10" name="TextBox 9"/>
+          <p:cNvSpPr txBox="1"/>
+          <p:nvPr/>
+        </p:nvSpPr>
+        <p:spPr>
+          <a:xfrm>
+            <a:off x="3895344" y="914400"/>
+            <a:ext cx="658368" cy="320040"/>
+          </a:xfrm>
+          <a:prstGeom prst="rect">
+            <a:avLst/>
+          </a:prstGeom>
+          <a:noFill/>
+        </p:spPr>
+        <p:txBody>
+          <a:bodyPr wrap="square">
+            <a:spAutoFit/>
+          </a:bodyPr>
+          <a:lstStyle/>
+          <a:p>
+            <a:pPr algn="ctr"/>
+            <a:r>
+              <a:rPr sz="1200" b="1" i="0">
+                <a:solidFill>
+                  <a:srgbClr val="00D4FF"/>
+                </a:solidFill>
+              </a:rPr>
+              <a:t>SW2</a:t>
+            </a:r>
+          </a:p>
+        </p:txBody>
+      </p:sp>
+      <p:sp>
+        <p:nvSpPr>
+          <p:cNvPr id="11" name="TextBox 10"/>
+          <p:cNvSpPr txBox="1"/>
+          <p:nvPr/>
+        </p:nvSpPr>
+        <p:spPr>
+          <a:xfrm>
+            <a:off x="4645152" y="914400"/>
+            <a:ext cx="3017520" cy="320040"/>
+          </a:xfrm>
+          <a:prstGeom prst="rect">
+            <a:avLst/>
+          </a:prstGeom>
+          <a:noFill/>
+        </p:spPr>
+        <p:txBody>
+          <a:bodyPr wrap="square">
+            <a:spAutoFit/>
+          </a:bodyPr>
+          <a:lstStyle/>
+          <a:p>
+            <a:pPr algn="ctr"/>
+            <a:r>
+              <a:rPr sz="1200" b="1" i="0">
+                <a:solidFill>
+                  <a:srgbClr val="00D4FF"/>
+                </a:solidFill>
+              </a:rPr>
+              <a:t>Red LEDs (LEDR4-0)</a:t>
+            </a:r>
+          </a:p>
+        </p:txBody>
+      </p:sp>
+      <p:sp>
+        <p:nvSpPr>
+          <p:cNvPr id="12" name="TextBox 11"/>
+          <p:cNvSpPr txBox="1"/>
+          <p:nvPr/>
+        </p:nvSpPr>
+        <p:spPr>
+          <a:xfrm>
+            <a:off x="7790688" y="914400"/>
+            <a:ext cx="1005840" cy="320040"/>
+          </a:xfrm>
+          <a:prstGeom prst="rect">
+            <a:avLst/>
+          </a:prstGeom>
+          <a:noFill/>
+        </p:spPr>
+        <p:txBody>
+          <a:bodyPr wrap="square">
+            <a:spAutoFit/>
+          </a:bodyPr>
+          <a:lstStyle/>
+          <a:p>
+            <a:pPr algn="ctr"/>
+            <a:r>
+              <a:rPr sz="1200" b="1" i="0">
+                <a:solidFill>
+                  <a:srgbClr val="00D4FF"/>
+                </a:solidFill>
+              </a:rPr>
+              <a:t>HEX2</a:t>
+            </a:r>
+          </a:p>
+        </p:txBody>
+      </p:sp>
+      <p:sp>
+        <p:nvSpPr>
+          <p:cNvPr id="13" name="TextBox 12"/>
+          <p:cNvSpPr txBox="1"/>
+          <p:nvPr/>
+        </p:nvSpPr>
+        <p:spPr>
+          <a:xfrm>
+            <a:off x="8961120" y="914400"/>
+            <a:ext cx="914400" cy="320040"/>
+          </a:xfrm>
+          <a:prstGeom prst="rect">
+            <a:avLst/>
+          </a:prstGeom>
+          <a:noFill/>
+        </p:spPr>
+        <p:txBody>
+          <a:bodyPr wrap="square">
+            <a:spAutoFit/>
+          </a:bodyPr>
+          <a:lstStyle/>
+          <a:p>
+            <a:pPr algn="ctr"/>
+            <a:r>
+              <a:rPr sz="1200" b="1" i="0">
+                <a:solidFill>
+                  <a:srgbClr val="00D4FF"/>
+                </a:solidFill>
+              </a:rPr>
+              <a:t>HEX0</a:t>
+            </a:r>
+          </a:p>
+        </p:txBody>
+      </p:sp>
+      <p:sp>
+        <p:nvSpPr>
+          <p:cNvPr id="14" name="Rectangle 13"/>
+          <p:cNvSpPr/>
+          <p:nvPr/>
+        </p:nvSpPr>
+        <p:spPr>
+          <a:xfrm>
+            <a:off x="2377439" y="822960"/>
+            <a:ext cx="19050" cy="3794760"/>
+          </a:xfrm>
+          <a:prstGeom prst="rect">
+            <a:avLst/>
+          </a:prstGeom>
+          <a:solidFill>
+            <a:srgbClr val="00D4FF"/>
+          </a:solidFill>
+          <a:ln>
+            <a:noFill/>
+          </a:ln>
+        </p:spPr>
+        <p:style>
+          <a:lnRef idx="1">
+            <a:schemeClr val="accent1"/>
+          </a:lnRef>
+          <a:fillRef idx="3">
+            <a:schemeClr val="accent1"/>
+          </a:fillRef>
+          <a:effectRef idx="2">
+            <a:schemeClr val="accent1"/>
+          </a:effectRef>
+          <a:fontRef idx="minor">
+            <a:schemeClr val="lt1"/>
+          </a:fontRef>
+        </p:style>
+        <p:txBody>
+          <a:bodyPr rtlCol="0" anchor="ctr"/>
+          <a:lstStyle/>
+          <a:p>
+            <a:pPr algn="ctr"/>
+          </a:p>
+        </p:txBody>
+      </p:sp>
+      <p:sp>
+        <p:nvSpPr>
+          <p:cNvPr id="15" name="Rectangle 14"/>
+          <p:cNvSpPr/>
+          <p:nvPr/>
+        </p:nvSpPr>
+        <p:spPr>
+          <a:xfrm>
+            <a:off x="3108960" y="822960"/>
+            <a:ext cx="19050" cy="3794760"/>
+          </a:xfrm>
+          <a:prstGeom prst="rect">
+            <a:avLst/>
+          </a:prstGeom>
+          <a:solidFill>
+            <a:srgbClr val="00D4FF"/>
+          </a:solidFill>
+          <a:ln>
+            <a:noFill/>
+          </a:ln>
+        </p:spPr>
+        <p:style>
+          <a:lnRef idx="1">
+            <a:schemeClr val="accent1"/>
+          </a:lnRef>
+          <a:fillRef idx="3">
+            <a:schemeClr val="accent1"/>
+          </a:fillRef>
+          <a:effectRef idx="2">
+            <a:schemeClr val="accent1"/>
+          </a:effectRef>
+          <a:fontRef idx="minor">
+            <a:schemeClr val="lt1"/>
+          </a:fontRef>
+        </p:style>
+        <p:txBody>
+          <a:bodyPr rtlCol="0" anchor="ctr"/>
+          <a:lstStyle/>
+          <a:p>
+            <a:pPr algn="ctr"/>
+          </a:p>
+        </p:txBody>
+      </p:sp>
+      <p:sp>
+        <p:nvSpPr>
+          <p:cNvPr id="16" name="Rectangle 15"/>
+          <p:cNvSpPr/>
+          <p:nvPr/>
+        </p:nvSpPr>
+        <p:spPr>
+          <a:xfrm>
+            <a:off x="3822191" y="822960"/>
+            <a:ext cx="19050" cy="3794760"/>
+          </a:xfrm>
+          <a:prstGeom prst="rect">
+            <a:avLst/>
+          </a:prstGeom>
+          <a:solidFill>
+            <a:srgbClr val="00D4FF"/>
+          </a:solidFill>
+          <a:ln>
+            <a:noFill/>
+          </a:ln>
+        </p:spPr>
+        <p:style>
+          <a:lnRef idx="1">
+            <a:schemeClr val="accent1"/>
+          </a:lnRef>
+          <a:fillRef idx="3">
+            <a:schemeClr val="accent1"/>
+          </a:fillRef>
+          <a:effectRef idx="2">
+            <a:schemeClr val="accent1"/>
+          </a:effectRef>
+          <a:fontRef idx="minor">
+            <a:schemeClr val="lt1"/>
+          </a:fontRef>
+        </p:style>
+        <p:txBody>
+          <a:bodyPr rtlCol="0" anchor="ctr"/>
+          <a:lstStyle/>
+          <a:p>
+            <a:pPr algn="ctr"/>
+          </a:p>
+        </p:txBody>
+      </p:sp>
+      <p:sp>
+        <p:nvSpPr>
+          <p:cNvPr id="17" name="Rectangle 16"/>
+          <p:cNvSpPr/>
+          <p:nvPr/>
+        </p:nvSpPr>
+        <p:spPr>
+          <a:xfrm>
+            <a:off x="4572000" y="822960"/>
+            <a:ext cx="19050" cy="3794760"/>
+          </a:xfrm>
+          <a:prstGeom prst="rect">
+            <a:avLst/>
+          </a:prstGeom>
+          <a:solidFill>
+            <a:srgbClr val="00D4FF"/>
+          </a:solidFill>
+          <a:ln>
+            <a:noFill/>
+          </a:ln>
+        </p:spPr>
+        <p:style>
+          <a:lnRef idx="1">
+            <a:schemeClr val="accent1"/>
+          </a:lnRef>
+          <a:fillRef idx="3">
+            <a:schemeClr val="accent1"/>
+          </a:fillRef>
+          <a:effectRef idx="2">
+            <a:schemeClr val="accent1"/>
+          </a:effectRef>
+          <a:fontRef idx="minor">
+            <a:schemeClr val="lt1"/>
+          </a:fontRef>
+        </p:style>
+        <p:txBody>
+          <a:bodyPr rtlCol="0" anchor="ctr"/>
+          <a:lstStyle/>
+          <a:p>
+            <a:pPr algn="ctr"/>
+          </a:p>
+        </p:txBody>
+      </p:sp>
+      <p:sp>
+        <p:nvSpPr>
+          <p:cNvPr id="18" name="Rectangle 17"/>
+          <p:cNvSpPr/>
+          <p:nvPr/>
+        </p:nvSpPr>
+        <p:spPr>
+          <a:xfrm>
+            <a:off x="7717536" y="822960"/>
+            <a:ext cx="19050" cy="3794760"/>
+          </a:xfrm>
+          <a:prstGeom prst="rect">
+            <a:avLst/>
+          </a:prstGeom>
+          <a:solidFill>
+            <a:srgbClr val="00D4FF"/>
+          </a:solidFill>
+          <a:ln>
+            <a:noFill/>
+          </a:ln>
+        </p:spPr>
+        <p:style>
+          <a:lnRef idx="1">
+            <a:schemeClr val="accent1"/>
+          </a:lnRef>
+          <a:fillRef idx="3">
+            <a:schemeClr val="accent1"/>
+          </a:fillRef>
+          <a:effectRef idx="2">
+            <a:schemeClr val="accent1"/>
+          </a:effectRef>
+          <a:fontRef idx="minor">
+            <a:schemeClr val="lt1"/>
+          </a:fontRef>
+        </p:style>
+        <p:txBody>
+          <a:bodyPr rtlCol="0" anchor="ctr"/>
+          <a:lstStyle/>
+          <a:p>
+            <a:pPr algn="ctr"/>
+          </a:p>
+        </p:txBody>
+      </p:sp>
+      <p:sp>
+        <p:nvSpPr>
+          <p:cNvPr id="19" name="Rectangle 18"/>
+          <p:cNvSpPr/>
+          <p:nvPr/>
+        </p:nvSpPr>
+        <p:spPr>
+          <a:xfrm>
+            <a:off x="8887968" y="822960"/>
+            <a:ext cx="19050" cy="3794760"/>
+          </a:xfrm>
+          <a:prstGeom prst="rect">
+            <a:avLst/>
+          </a:prstGeom>
+          <a:solidFill>
+            <a:srgbClr val="00D4FF"/>
+          </a:solidFill>
+          <a:ln>
+            <a:noFill/>
+          </a:ln>
+        </p:spPr>
+        <p:style>
+          <a:lnRef idx="1">
+            <a:schemeClr val="accent1"/>
+          </a:lnRef>
+          <a:fillRef idx="3">
+            <a:schemeClr val="accent1"/>
+          </a:fillRef>
+          <a:effectRef idx="2">
+            <a:schemeClr val="accent1"/>
+          </a:effectRef>
+          <a:fontRef idx="minor">
+            <a:schemeClr val="lt1"/>
+          </a:fontRef>
+        </p:style>
+        <p:txBody>
+          <a:bodyPr rtlCol="0" anchor="ctr"/>
+          <a:lstStyle/>
+          <a:p>
+            <a:pPr algn="ctr"/>
+          </a:p>
+        </p:txBody>
+      </p:sp>
+      <p:sp>
+        <p:nvSpPr>
+          <p:cNvPr id="20" name="Rectangle 19"/>
+          <p:cNvSpPr/>
+          <p:nvPr/>
+        </p:nvSpPr>
+        <p:spPr>
+          <a:xfrm>
+            <a:off x="9948672" y="822960"/>
+            <a:ext cx="19050" cy="3794760"/>
+          </a:xfrm>
+          <a:prstGeom prst="rect">
+            <a:avLst/>
+          </a:prstGeom>
+          <a:solidFill>
+            <a:srgbClr val="00D4FF"/>
+          </a:solidFill>
+          <a:ln>
+            <a:noFill/>
+          </a:ln>
+        </p:spPr>
+        <p:style>
+          <a:lnRef idx="1">
+            <a:schemeClr val="accent1"/>
+          </a:lnRef>
+          <a:fillRef idx="3">
+            <a:schemeClr val="accent1"/>
+          </a:fillRef>
+          <a:effectRef idx="2">
+            <a:schemeClr val="accent1"/>
+          </a:effectRef>
+          <a:fontRef idx="minor">
+            <a:schemeClr val="lt1"/>
+          </a:fontRef>
+        </p:style>
+        <p:txBody>
+          <a:bodyPr rtlCol="0" anchor="ctr"/>
+          <a:lstStyle/>
+          <a:p>
+            <a:pPr algn="ctr"/>
+          </a:p>
+        </p:txBody>
+      </p:sp>
+      <p:sp>
+        <p:nvSpPr>
+          <p:cNvPr id="21" name="Rectangle 20"/>
+          <p:cNvSpPr/>
+          <p:nvPr/>
+        </p:nvSpPr>
+        <p:spPr>
+          <a:xfrm>
+            <a:off x="274320" y="1298448"/>
+            <a:ext cx="11640312" cy="25400"/>
+          </a:xfrm>
+          <a:prstGeom prst="rect">
+            <a:avLst/>
+          </a:prstGeom>
+          <a:solidFill>
+            <a:srgbClr val="00D4FF"/>
+          </a:solidFill>
+          <a:ln>
+            <a:noFill/>
+          </a:ln>
+        </p:spPr>
+        <p:style>
+          <a:lnRef idx="1">
+            <a:schemeClr val="accent1"/>
+          </a:lnRef>
+          <a:fillRef idx="3">
+            <a:schemeClr val="accent1"/>
+          </a:fillRef>
+          <a:effectRef idx="2">
+            <a:schemeClr val="accent1"/>
+          </a:effectRef>
+          <a:fontRef idx="minor">
+            <a:schemeClr val="lt1"/>
+          </a:fontRef>
+        </p:style>
+        <p:txBody>
+          <a:bodyPr rtlCol="0" anchor="ctr"/>
+          <a:lstStyle/>
+          <a:p>
+            <a:pPr algn="ctr"/>
+          </a:p>
+        </p:txBody>
+      </p:sp>
+      <p:sp>
+        <p:nvSpPr>
+          <p:cNvPr id="22" name="Rectangle 21"/>
+          <p:cNvSpPr/>
+          <p:nvPr/>
+        </p:nvSpPr>
+        <p:spPr>
+          <a:xfrm>
+            <a:off x="274320" y="1298448"/>
+            <a:ext cx="11640312" cy="539496"/>
+          </a:xfrm>
+          <a:prstGeom prst="rect">
+            <a:avLst/>
+          </a:prstGeom>
+          <a:solidFill>
+            <a:srgbClr val="0A2216"/>
+          </a:solidFill>
+          <a:ln>
+            <a:noFill/>
+          </a:ln>
+        </p:spPr>
+        <p:style>
+          <a:lnRef idx="1">
+            <a:schemeClr val="accent1"/>
+          </a:lnRef>
+          <a:fillRef idx="3">
+            <a:schemeClr val="accent1"/>
+          </a:fillRef>
+          <a:effectRef idx="2">
+            <a:schemeClr val="accent1"/>
+          </a:effectRef>
+          <a:fontRef idx="minor">
+            <a:schemeClr val="lt1"/>
+          </a:fontRef>
+        </p:style>
+        <p:txBody>
+          <a:bodyPr rtlCol="0" anchor="ctr"/>
+          <a:lstStyle/>
+          <a:p>
+            <a:pPr algn="ctr"/>
+          </a:p>
+        </p:txBody>
+      </p:sp>
+      <p:sp>
+        <p:nvSpPr>
+          <p:cNvPr id="23" name="Rectangle 22"/>
+          <p:cNvSpPr/>
+          <p:nvPr/>
+        </p:nvSpPr>
+        <p:spPr>
+          <a:xfrm>
+            <a:off x="274320" y="1837943"/>
+            <a:ext cx="11640312" cy="25400"/>
+          </a:xfrm>
+          <a:prstGeom prst="rect">
+            <a:avLst/>
+          </a:prstGeom>
+          <a:solidFill>
+            <a:srgbClr val="1A3555"/>
+          </a:solidFill>
+          <a:ln>
+            <a:noFill/>
+          </a:ln>
+        </p:spPr>
+        <p:style>
+          <a:lnRef idx="1">
+            <a:schemeClr val="accent1"/>
+          </a:lnRef>
+          <a:fillRef idx="3">
+            <a:schemeClr val="accent1"/>
+          </a:fillRef>
+          <a:effectRef idx="2">
+            <a:schemeClr val="accent1"/>
+          </a:effectRef>
+          <a:fontRef idx="minor">
+            <a:schemeClr val="lt1"/>
+          </a:fontRef>
+        </p:style>
+        <p:txBody>
+          <a:bodyPr rtlCol="0" anchor="ctr"/>
+          <a:lstStyle/>
+          <a:p>
+            <a:pPr algn="ctr"/>
+          </a:p>
+        </p:txBody>
+      </p:sp>
+      <p:sp>
+        <p:nvSpPr>
+          <p:cNvPr id="24" name="TextBox 23"/>
+          <p:cNvSpPr txBox="1"/>
+          <p:nvPr/>
+        </p:nvSpPr>
+        <p:spPr>
+          <a:xfrm>
+            <a:off x="347472" y="1417319"/>
+            <a:ext cx="2011680" cy="347472"/>
+          </a:xfrm>
+          <a:prstGeom prst="rect">
+            <a:avLst/>
+          </a:prstGeom>
+          <a:noFill/>
+        </p:spPr>
+        <p:txBody>
+          <a:bodyPr wrap="square">
+            <a:spAutoFit/>
+          </a:bodyPr>
+          <a:lstStyle/>
+          <a:p>
+            <a:pPr algn="ctr"/>
+            <a:r>
+              <a:rPr sz="1300" b="1" i="0">
+                <a:solidFill>
+                  <a:srgbClr val="00E576"/>
+                </a:solidFill>
+              </a:rPr>
+              <a:t>Lights ON</a:t>
+            </a:r>
+          </a:p>
+        </p:txBody>
+      </p:sp>
+      <p:sp>
+        <p:nvSpPr>
+          <p:cNvPr id="25" name="TextBox 24"/>
+          <p:cNvSpPr txBox="1"/>
+          <p:nvPr/>
+        </p:nvSpPr>
+        <p:spPr>
+          <a:xfrm>
+            <a:off x="2450591" y="1417319"/>
+            <a:ext cx="658368" cy="347472"/>
+          </a:xfrm>
+          <a:prstGeom prst="rect">
+            <a:avLst/>
+          </a:prstGeom>
+          <a:noFill/>
+        </p:spPr>
+        <p:txBody>
+          <a:bodyPr wrap="square">
+            <a:spAutoFit/>
+          </a:bodyPr>
+          <a:lstStyle/>
+          <a:p>
+            <a:pPr algn="ctr"/>
+            <a:r>
+              <a:rPr sz="1300" b="1" i="0">
+                <a:solidFill>
+                  <a:srgbClr val="FF355E"/>
+                </a:solidFill>
+              </a:rPr>
+              <a:t>↓</a:t>
+            </a:r>
+          </a:p>
+        </p:txBody>
+      </p:sp>
+      <p:sp>
+        <p:nvSpPr>
+          <p:cNvPr id="26" name="TextBox 25"/>
+          <p:cNvSpPr txBox="1"/>
+          <p:nvPr/>
+        </p:nvSpPr>
+        <p:spPr>
+          <a:xfrm>
+            <a:off x="3182112" y="1417319"/>
+            <a:ext cx="658368" cy="347472"/>
+          </a:xfrm>
+          <a:prstGeom prst="rect">
+            <a:avLst/>
+          </a:prstGeom>
+          <a:noFill/>
+        </p:spPr>
+        <p:txBody>
+          <a:bodyPr wrap="square">
+            <a:spAutoFit/>
+          </a:bodyPr>
+          <a:lstStyle/>
+          <a:p>
+            <a:pPr algn="ctr"/>
+            <a:r>
+              <a:rPr sz="1300" b="1" i="0">
+                <a:solidFill>
+                  <a:srgbClr val="FF355E"/>
+                </a:solidFill>
+              </a:rPr>
+              <a:t>↓</a:t>
+            </a:r>
+          </a:p>
+        </p:txBody>
+      </p:sp>
+      <p:sp>
+        <p:nvSpPr>
+          <p:cNvPr id="27" name="TextBox 26"/>
+          <p:cNvSpPr txBox="1"/>
+          <p:nvPr/>
+        </p:nvSpPr>
+        <p:spPr>
+          <a:xfrm>
+            <a:off x="3895344" y="1417319"/>
+            <a:ext cx="658368" cy="347472"/>
+          </a:xfrm>
+          <a:prstGeom prst="rect">
+            <a:avLst/>
+          </a:prstGeom>
+          <a:noFill/>
+        </p:spPr>
+        <p:txBody>
+          <a:bodyPr wrap="square">
+            <a:spAutoFit/>
+          </a:bodyPr>
+          <a:lstStyle/>
+          <a:p>
+            <a:pPr algn="ctr"/>
+            <a:r>
+              <a:rPr sz="1300" b="1" i="0">
+                <a:solidFill>
+                  <a:srgbClr val="FF355E"/>
+                </a:solidFill>
+              </a:rPr>
+              <a:t>↓</a:t>
+            </a:r>
+          </a:p>
+        </p:txBody>
+      </p:sp>
+      <p:sp>
+        <p:nvSpPr>
+          <p:cNvPr id="28" name="TextBox 27"/>
+          <p:cNvSpPr txBox="1"/>
+          <p:nvPr/>
+        </p:nvSpPr>
+        <p:spPr>
+          <a:xfrm>
+            <a:off x="4645152" y="1417319"/>
+            <a:ext cx="3017520" cy="347472"/>
+          </a:xfrm>
+          <a:prstGeom prst="rect">
+            <a:avLst/>
+          </a:prstGeom>
+          <a:noFill/>
+        </p:spPr>
+        <p:txBody>
+          <a:bodyPr wrap="square">
+            <a:spAutoFit/>
+          </a:bodyPr>
+          <a:lstStyle/>
+          <a:p>
+            <a:pPr algn="ctr"/>
+            <a:r>
+              <a:rPr sz="1300" b="1" i="0">
+                <a:solidFill>
+                  <a:srgbClr val="B0C8E0"/>
+                </a:solidFill>
+              </a:rPr>
+              <a:t>OFF  OFF  OFF  OFF  OFF</a:t>
+            </a:r>
+          </a:p>
+        </p:txBody>
+      </p:sp>
+      <p:sp>
+        <p:nvSpPr>
+          <p:cNvPr id="29" name="TextBox 28"/>
+          <p:cNvSpPr txBox="1"/>
+          <p:nvPr/>
+        </p:nvSpPr>
+        <p:spPr>
+          <a:xfrm>
+            <a:off x="7790688" y="1417319"/>
+            <a:ext cx="1005840" cy="347472"/>
+          </a:xfrm>
+          <a:prstGeom prst="rect">
+            <a:avLst/>
+          </a:prstGeom>
+          <a:noFill/>
+        </p:spPr>
+        <p:txBody>
+          <a:bodyPr wrap="square">
+            <a:spAutoFit/>
+          </a:bodyPr>
+          <a:lstStyle/>
+          <a:p>
+            <a:pPr algn="ctr"/>
+            <a:r>
+              <a:rPr sz="1300" b="1" i="0">
+                <a:solidFill>
+                  <a:srgbClr val="FFE030"/>
+                </a:solidFill>
+              </a:rPr>
+              <a:t>0</a:t>
+            </a:r>
+          </a:p>
+        </p:txBody>
+      </p:sp>
+      <p:sp>
+        <p:nvSpPr>
+          <p:cNvPr id="30" name="TextBox 29"/>
+          <p:cNvSpPr txBox="1"/>
+          <p:nvPr/>
+        </p:nvSpPr>
+        <p:spPr>
+          <a:xfrm>
+            <a:off x="8961120" y="1417319"/>
+            <a:ext cx="914400" cy="347472"/>
+          </a:xfrm>
+          <a:prstGeom prst="rect">
+            <a:avLst/>
+          </a:prstGeom>
+          <a:noFill/>
+        </p:spPr>
+        <p:txBody>
+          <a:bodyPr wrap="square">
+            <a:spAutoFit/>
+          </a:bodyPr>
+          <a:lstStyle/>
+          <a:p>
+            <a:pPr algn="ctr"/>
+            <a:r>
+              <a:rPr sz="1300" b="1" i="0">
+                <a:solidFill>
+                  <a:srgbClr val="00E576"/>
+                </a:solidFill>
+              </a:rPr>
+              <a:t>0</a:t>
+            </a:r>
+          </a:p>
+        </p:txBody>
+      </p:sp>
+      <p:sp>
+        <p:nvSpPr>
+          <p:cNvPr id="31" name="Rectangle 30"/>
+          <p:cNvSpPr/>
+          <p:nvPr/>
+        </p:nvSpPr>
+        <p:spPr>
+          <a:xfrm>
+            <a:off x="274320" y="1837943"/>
+            <a:ext cx="11640312" cy="539496"/>
+          </a:xfrm>
+          <a:prstGeom prst="rect">
+            <a:avLst/>
+          </a:prstGeom>
+          <a:solidFill>
+            <a:srgbClr val="112338"/>
+          </a:solidFill>
+          <a:ln>
+            <a:noFill/>
+          </a:ln>
+        </p:spPr>
+        <p:style>
+          <a:lnRef idx="1">
+            <a:schemeClr val="accent1"/>
+          </a:lnRef>
+          <a:fillRef idx="3">
+            <a:schemeClr val="accent1"/>
+          </a:fillRef>
+          <a:effectRef idx="2">
+            <a:schemeClr val="accent1"/>
+          </a:effectRef>
+          <a:fontRef idx="minor">
+            <a:schemeClr val="lt1"/>
+          </a:fontRef>
+        </p:style>
+        <p:txBody>
+          <a:bodyPr rtlCol="0" anchor="ctr"/>
+          <a:lstStyle/>
+          <a:p>
+            <a:pPr algn="ctr"/>
+          </a:p>
+        </p:txBody>
+      </p:sp>
+      <p:sp>
+        <p:nvSpPr>
+          <p:cNvPr id="32" name="Rectangle 31"/>
+          <p:cNvSpPr/>
+          <p:nvPr/>
+        </p:nvSpPr>
+        <p:spPr>
+          <a:xfrm>
+            <a:off x="274320" y="2377439"/>
+            <a:ext cx="11640312" cy="25400"/>
+          </a:xfrm>
+          <a:prstGeom prst="rect">
+            <a:avLst/>
+          </a:prstGeom>
+          <a:solidFill>
+            <a:srgbClr val="1A3555"/>
+          </a:solidFill>
+          <a:ln>
+            <a:noFill/>
+          </a:ln>
+        </p:spPr>
+        <p:style>
+          <a:lnRef idx="1">
+            <a:schemeClr val="accent1"/>
+          </a:lnRef>
+          <a:fillRef idx="3">
+            <a:schemeClr val="accent1"/>
+          </a:fillRef>
+          <a:effectRef idx="2">
+            <a:schemeClr val="accent1"/>
+          </a:effectRef>
+          <a:fontRef idx="minor">
+            <a:schemeClr val="lt1"/>
+          </a:fontRef>
+        </p:style>
+        <p:txBody>
+          <a:bodyPr rtlCol="0" anchor="ctr"/>
+          <a:lstStyle/>
+          <a:p>
+            <a:pPr algn="ctr"/>
+          </a:p>
+        </p:txBody>
+      </p:sp>
+      <p:sp>
+        <p:nvSpPr>
+          <p:cNvPr id="33" name="TextBox 32"/>
+          <p:cNvSpPr txBox="1"/>
+          <p:nvPr/>
+        </p:nvSpPr>
+        <p:spPr>
+          <a:xfrm>
+            <a:off x="347472" y="1956815"/>
+            <a:ext cx="2011680" cy="347472"/>
+          </a:xfrm>
+          <a:prstGeom prst="rect">
+            <a:avLst/>
+          </a:prstGeom>
+          <a:noFill/>
+        </p:spPr>
+        <p:txBody>
+          <a:bodyPr wrap="square">
+            <a:spAutoFit/>
+          </a:bodyPr>
+          <a:lstStyle/>
+          <a:p>
+            <a:pPr algn="ctr"/>
+            <a:r>
+              <a:rPr sz="1300" b="0" i="0">
+                <a:solidFill>
+                  <a:srgbClr val="B0C8E0"/>
+                </a:solidFill>
+              </a:rPr>
+              <a:t>Lights OFF</a:t>
+            </a:r>
+          </a:p>
+        </p:txBody>
+      </p:sp>
+      <p:sp>
+        <p:nvSpPr>
+          <p:cNvPr id="34" name="TextBox 33"/>
+          <p:cNvSpPr txBox="1"/>
+          <p:nvPr/>
+        </p:nvSpPr>
+        <p:spPr>
+          <a:xfrm>
+            <a:off x="2450591" y="1956815"/>
+            <a:ext cx="658368" cy="347472"/>
+          </a:xfrm>
+          <a:prstGeom prst="rect">
+            <a:avLst/>
+          </a:prstGeom>
+          <a:noFill/>
+        </p:spPr>
+        <p:txBody>
+          <a:bodyPr wrap="square">
+            <a:spAutoFit/>
+          </a:bodyPr>
+          <a:lstStyle/>
+          <a:p>
+            <a:pPr algn="ctr"/>
+            <a:r>
+              <a:rPr sz="1300" b="0" i="0">
+                <a:solidFill>
+                  <a:srgbClr val="FF355E"/>
+                </a:solidFill>
+              </a:rPr>
+              <a:t>↓</a:t>
+            </a:r>
+          </a:p>
+        </p:txBody>
+      </p:sp>
+      <p:sp>
+        <p:nvSpPr>
+          <p:cNvPr id="35" name="TextBox 34"/>
+          <p:cNvSpPr txBox="1"/>
+          <p:nvPr/>
+        </p:nvSpPr>
+        <p:spPr>
+          <a:xfrm>
+            <a:off x="3182112" y="1956815"/>
+            <a:ext cx="658368" cy="347472"/>
+          </a:xfrm>
+          <a:prstGeom prst="rect">
+            <a:avLst/>
+          </a:prstGeom>
+          <a:noFill/>
+        </p:spPr>
+        <p:txBody>
+          <a:bodyPr wrap="square">
+            <a:spAutoFit/>
+          </a:bodyPr>
+          <a:lstStyle/>
+          <a:p>
+            <a:pPr algn="ctr"/>
+            <a:r>
+              <a:rPr sz="1300" b="0" i="0">
+                <a:solidFill>
+                  <a:srgbClr val="FF355E"/>
+                </a:solidFill>
+              </a:rPr>
+              <a:t>↓</a:t>
+            </a:r>
+          </a:p>
+        </p:txBody>
+      </p:sp>
+      <p:sp>
+        <p:nvSpPr>
+          <p:cNvPr id="36" name="TextBox 35"/>
+          <p:cNvSpPr txBox="1"/>
+          <p:nvPr/>
+        </p:nvSpPr>
+        <p:spPr>
+          <a:xfrm>
+            <a:off x="3895344" y="1956815"/>
+            <a:ext cx="658368" cy="347472"/>
+          </a:xfrm>
+          <a:prstGeom prst="rect">
+            <a:avLst/>
+          </a:prstGeom>
+          <a:noFill/>
+        </p:spPr>
+        <p:txBody>
+          <a:bodyPr wrap="square">
+            <a:spAutoFit/>
+          </a:bodyPr>
+          <a:lstStyle/>
+          <a:p>
+            <a:pPr algn="ctr"/>
+            <a:r>
+              <a:rPr sz="1300" b="0" i="0">
+                <a:solidFill>
+                  <a:srgbClr val="00E576"/>
+                </a:solidFill>
+              </a:rPr>
+              <a:t>↑</a:t>
+            </a:r>
+          </a:p>
+        </p:txBody>
+      </p:sp>
+      <p:sp>
+        <p:nvSpPr>
+          <p:cNvPr id="37" name="TextBox 36"/>
+          <p:cNvSpPr txBox="1"/>
+          <p:nvPr/>
+        </p:nvSpPr>
+        <p:spPr>
+          <a:xfrm>
+            <a:off x="4645152" y="1956815"/>
+            <a:ext cx="3017520" cy="347472"/>
+          </a:xfrm>
+          <a:prstGeom prst="rect">
+            <a:avLst/>
+          </a:prstGeom>
+          <a:noFill/>
+        </p:spPr>
+        <p:txBody>
+          <a:bodyPr wrap="square">
+            <a:spAutoFit/>
+          </a:bodyPr>
+          <a:lstStyle/>
+          <a:p>
+            <a:pPr algn="ctr"/>
+            <a:r>
+              <a:rPr sz="1300" b="0" i="0">
+                <a:solidFill>
+                  <a:srgbClr val="B0C8E0"/>
+                </a:solidFill>
+              </a:rPr>
+              <a:t>OFF  OFF  ON   OFF  OFF</a:t>
+            </a:r>
+          </a:p>
+        </p:txBody>
+      </p:sp>
+      <p:sp>
+        <p:nvSpPr>
+          <p:cNvPr id="38" name="TextBox 37"/>
+          <p:cNvSpPr txBox="1"/>
+          <p:nvPr/>
+        </p:nvSpPr>
+        <p:spPr>
+          <a:xfrm>
+            <a:off x="7790688" y="1956815"/>
+            <a:ext cx="1005840" cy="347472"/>
+          </a:xfrm>
+          <a:prstGeom prst="rect">
+            <a:avLst/>
+          </a:prstGeom>
+          <a:noFill/>
+        </p:spPr>
+        <p:txBody>
+          <a:bodyPr wrap="square">
+            <a:spAutoFit/>
+          </a:bodyPr>
+          <a:lstStyle/>
+          <a:p>
+            <a:pPr algn="ctr"/>
+            <a:r>
+              <a:rPr sz="1300" b="0" i="0">
+                <a:solidFill>
+                  <a:srgbClr val="FFE030"/>
+                </a:solidFill>
+              </a:rPr>
+              <a:t>1</a:t>
+            </a:r>
+          </a:p>
+        </p:txBody>
+      </p:sp>
+      <p:sp>
+        <p:nvSpPr>
+          <p:cNvPr id="39" name="TextBox 38"/>
+          <p:cNvSpPr txBox="1"/>
+          <p:nvPr/>
+        </p:nvSpPr>
+        <p:spPr>
+          <a:xfrm>
+            <a:off x="8961120" y="1956815"/>
+            <a:ext cx="914400" cy="347472"/>
+          </a:xfrm>
+          <a:prstGeom prst="rect">
+            <a:avLst/>
+          </a:prstGeom>
+          <a:noFill/>
+        </p:spPr>
+        <p:txBody>
+          <a:bodyPr wrap="square">
+            <a:spAutoFit/>
+          </a:bodyPr>
+          <a:lstStyle/>
+          <a:p>
+            <a:pPr algn="ctr"/>
+            <a:r>
+              <a:rPr sz="1300" b="0" i="0">
+                <a:solidFill>
+                  <a:srgbClr val="FFE030"/>
+                </a:solidFill>
+              </a:rPr>
+              <a:t>1</a:t>
+            </a:r>
+          </a:p>
+        </p:txBody>
+      </p:sp>
+      <p:sp>
+        <p:nvSpPr>
+          <p:cNvPr id="40" name="Rectangle 39"/>
+          <p:cNvSpPr/>
+          <p:nvPr/>
+        </p:nvSpPr>
+        <p:spPr>
+          <a:xfrm>
+            <a:off x="274320" y="2377439"/>
+            <a:ext cx="11640312" cy="539496"/>
+          </a:xfrm>
+          <a:prstGeom prst="rect">
+            <a:avLst/>
+          </a:prstGeom>
+          <a:solidFill>
+            <a:srgbClr val="0F1E2E"/>
+          </a:solidFill>
+          <a:ln>
+            <a:noFill/>
+          </a:ln>
+        </p:spPr>
+        <p:style>
+          <a:lnRef idx="1">
+            <a:schemeClr val="accent1"/>
+          </a:lnRef>
+          <a:fillRef idx="3">
+            <a:schemeClr val="accent1"/>
+          </a:fillRef>
+          <a:effectRef idx="2">
+            <a:schemeClr val="accent1"/>
+          </a:effectRef>
+          <a:fontRef idx="minor">
+            <a:schemeClr val="lt1"/>
+          </a:fontRef>
+        </p:style>
+        <p:txBody>
+          <a:bodyPr rtlCol="0" anchor="ctr"/>
+          <a:lstStyle/>
+          <a:p>
+            <a:pPr algn="ctr"/>
+          </a:p>
+        </p:txBody>
+      </p:sp>
+      <p:sp>
+        <p:nvSpPr>
+          <p:cNvPr id="41" name="Rectangle 40"/>
+          <p:cNvSpPr/>
+          <p:nvPr/>
+        </p:nvSpPr>
+        <p:spPr>
+          <a:xfrm>
+            <a:off x="274320" y="2916935"/>
+            <a:ext cx="11640312" cy="25400"/>
+          </a:xfrm>
+          <a:prstGeom prst="rect">
+            <a:avLst/>
+          </a:prstGeom>
+          <a:solidFill>
+            <a:srgbClr val="1A3555"/>
+          </a:solidFill>
+          <a:ln>
+            <a:noFill/>
+          </a:ln>
+        </p:spPr>
+        <p:style>
+          <a:lnRef idx="1">
+            <a:schemeClr val="accent1"/>
+          </a:lnRef>
+          <a:fillRef idx="3">
+            <a:schemeClr val="accent1"/>
+          </a:fillRef>
+          <a:effectRef idx="2">
+            <a:schemeClr val="accent1"/>
+          </a:effectRef>
+          <a:fontRef idx="minor">
+            <a:schemeClr val="lt1"/>
+          </a:fontRef>
+        </p:style>
+        <p:txBody>
+          <a:bodyPr rtlCol="0" anchor="ctr"/>
+          <a:lstStyle/>
+          <a:p>
+            <a:pPr algn="ctr"/>
+          </a:p>
+        </p:txBody>
+      </p:sp>
+      <p:sp>
+        <p:nvSpPr>
+          <p:cNvPr id="42" name="TextBox 41"/>
+          <p:cNvSpPr txBox="1"/>
+          <p:nvPr/>
+        </p:nvSpPr>
+        <p:spPr>
+          <a:xfrm>
+            <a:off x="347472" y="2496311"/>
+            <a:ext cx="2011680" cy="347472"/>
+          </a:xfrm>
+          <a:prstGeom prst="rect">
+            <a:avLst/>
+          </a:prstGeom>
+          <a:noFill/>
+        </p:spPr>
+        <p:txBody>
+          <a:bodyPr wrap="square">
+            <a:spAutoFit/>
+          </a:bodyPr>
+          <a:lstStyle/>
+          <a:p>
+            <a:pPr algn="ctr"/>
+            <a:r>
+              <a:rPr sz="1300" b="0" i="0">
+                <a:solidFill>
+                  <a:srgbClr val="B0C8E0"/>
+                </a:solidFill>
+              </a:rPr>
+              <a:t>Vol UP</a:t>
+            </a:r>
+          </a:p>
+        </p:txBody>
+      </p:sp>
+      <p:sp>
+        <p:nvSpPr>
+          <p:cNvPr id="43" name="TextBox 42"/>
+          <p:cNvSpPr txBox="1"/>
+          <p:nvPr/>
+        </p:nvSpPr>
+        <p:spPr>
+          <a:xfrm>
+            <a:off x="2450591" y="2496311"/>
+            <a:ext cx="658368" cy="347472"/>
+          </a:xfrm>
+          <a:prstGeom prst="rect">
+            <a:avLst/>
+          </a:prstGeom>
+          <a:noFill/>
+        </p:spPr>
+        <p:txBody>
+          <a:bodyPr wrap="square">
+            <a:spAutoFit/>
+          </a:bodyPr>
+          <a:lstStyle/>
+          <a:p>
+            <a:pPr algn="ctr"/>
+            <a:r>
+              <a:rPr sz="1300" b="0" i="0">
+                <a:solidFill>
+                  <a:srgbClr val="FF355E"/>
+                </a:solidFill>
+              </a:rPr>
+              <a:t>↓</a:t>
+            </a:r>
+          </a:p>
+        </p:txBody>
+      </p:sp>
+      <p:sp>
+        <p:nvSpPr>
+          <p:cNvPr id="44" name="TextBox 43"/>
+          <p:cNvSpPr txBox="1"/>
+          <p:nvPr/>
+        </p:nvSpPr>
+        <p:spPr>
+          <a:xfrm>
+            <a:off x="3182112" y="2496311"/>
+            <a:ext cx="658368" cy="347472"/>
+          </a:xfrm>
+          <a:prstGeom prst="rect">
+            <a:avLst/>
+          </a:prstGeom>
+          <a:noFill/>
+        </p:spPr>
+        <p:txBody>
+          <a:bodyPr wrap="square">
+            <a:spAutoFit/>
+          </a:bodyPr>
+          <a:lstStyle/>
+          <a:p>
+            <a:pPr algn="ctr"/>
+            <a:r>
+              <a:rPr sz="1300" b="0" i="0">
+                <a:solidFill>
+                  <a:srgbClr val="00E576"/>
+                </a:solidFill>
+              </a:rPr>
+              <a:t>↑</a:t>
+            </a:r>
+          </a:p>
+        </p:txBody>
+      </p:sp>
+      <p:sp>
+        <p:nvSpPr>
+          <p:cNvPr id="45" name="TextBox 44"/>
+          <p:cNvSpPr txBox="1"/>
+          <p:nvPr/>
+        </p:nvSpPr>
+        <p:spPr>
+          <a:xfrm>
+            <a:off x="3895344" y="2496311"/>
+            <a:ext cx="658368" cy="347472"/>
+          </a:xfrm>
+          <a:prstGeom prst="rect">
+            <a:avLst/>
+          </a:prstGeom>
+          <a:noFill/>
+        </p:spPr>
+        <p:txBody>
+          <a:bodyPr wrap="square">
+            <a:spAutoFit/>
+          </a:bodyPr>
+          <a:lstStyle/>
+          <a:p>
+            <a:pPr algn="ctr"/>
+            <a:r>
+              <a:rPr sz="1300" b="0" i="0">
+                <a:solidFill>
+                  <a:srgbClr val="FF355E"/>
+                </a:solidFill>
+              </a:rPr>
+              <a:t>↓</a:t>
+            </a:r>
+          </a:p>
+        </p:txBody>
+      </p:sp>
+      <p:sp>
+        <p:nvSpPr>
+          <p:cNvPr id="46" name="TextBox 45"/>
+          <p:cNvSpPr txBox="1"/>
+          <p:nvPr/>
+        </p:nvSpPr>
+        <p:spPr>
+          <a:xfrm>
+            <a:off x="4645152" y="2496311"/>
+            <a:ext cx="3017520" cy="347472"/>
+          </a:xfrm>
+          <a:prstGeom prst="rect">
+            <a:avLst/>
+          </a:prstGeom>
+          <a:noFill/>
+        </p:spPr>
+        <p:txBody>
+          <a:bodyPr wrap="square">
+            <a:spAutoFit/>
+          </a:bodyPr>
+          <a:lstStyle/>
+          <a:p>
+            <a:pPr algn="ctr"/>
+            <a:r>
+              <a:rPr sz="1300" b="0" i="0">
+                <a:solidFill>
+                  <a:srgbClr val="B0C8E0"/>
+                </a:solidFill>
+              </a:rPr>
+              <a:t>OFF  ON   OFF  OFF  OFF</a:t>
+            </a:r>
+          </a:p>
+        </p:txBody>
+      </p:sp>
+      <p:sp>
+        <p:nvSpPr>
+          <p:cNvPr id="47" name="TextBox 46"/>
+          <p:cNvSpPr txBox="1"/>
+          <p:nvPr/>
+        </p:nvSpPr>
+        <p:spPr>
+          <a:xfrm>
+            <a:off x="7790688" y="2496311"/>
+            <a:ext cx="1005840" cy="347472"/>
+          </a:xfrm>
+          <a:prstGeom prst="rect">
+            <a:avLst/>
+          </a:prstGeom>
+          <a:noFill/>
+        </p:spPr>
+        <p:txBody>
+          <a:bodyPr wrap="square">
+            <a:spAutoFit/>
+          </a:bodyPr>
+          <a:lstStyle/>
+          <a:p>
+            <a:pPr algn="ctr"/>
+            <a:r>
+              <a:rPr sz="1300" b="0" i="0">
+                <a:solidFill>
+                  <a:srgbClr val="FFE030"/>
+                </a:solidFill>
+              </a:rPr>
+              <a:t>2</a:t>
+            </a:r>
+          </a:p>
+        </p:txBody>
+      </p:sp>
+      <p:sp>
+        <p:nvSpPr>
+          <p:cNvPr id="48" name="TextBox 47"/>
+          <p:cNvSpPr txBox="1"/>
+          <p:nvPr/>
+        </p:nvSpPr>
+        <p:spPr>
+          <a:xfrm>
+            <a:off x="8961120" y="2496311"/>
+            <a:ext cx="914400" cy="347472"/>
+          </a:xfrm>
+          <a:prstGeom prst="rect">
+            <a:avLst/>
+          </a:prstGeom>
+          <a:noFill/>
+        </p:spPr>
+        <p:txBody>
+          <a:bodyPr wrap="square">
+            <a:spAutoFit/>
+          </a:bodyPr>
+          <a:lstStyle/>
+          <a:p>
+            <a:pPr algn="ctr"/>
+            <a:r>
+              <a:rPr sz="1300" b="0" i="0">
+                <a:solidFill>
+                  <a:srgbClr val="FFE030"/>
+                </a:solidFill>
+              </a:rPr>
+              <a:t>2</a:t>
+            </a:r>
+          </a:p>
+        </p:txBody>
+      </p:sp>
+      <p:sp>
+        <p:nvSpPr>
+          <p:cNvPr id="49" name="Rectangle 48"/>
+          <p:cNvSpPr/>
+          <p:nvPr/>
+        </p:nvSpPr>
+        <p:spPr>
+          <a:xfrm>
+            <a:off x="274320" y="2916936"/>
+            <a:ext cx="11640312" cy="539496"/>
+          </a:xfrm>
+          <a:prstGeom prst="rect">
+            <a:avLst/>
+          </a:prstGeom>
+          <a:solidFill>
+            <a:srgbClr val="112338"/>
+          </a:solidFill>
+          <a:ln>
+            <a:noFill/>
+          </a:ln>
+        </p:spPr>
+        <p:style>
+          <a:lnRef idx="1">
+            <a:schemeClr val="accent1"/>
+          </a:lnRef>
+          <a:fillRef idx="3">
+            <a:schemeClr val="accent1"/>
+          </a:fillRef>
+          <a:effectRef idx="2">
+            <a:schemeClr val="accent1"/>
+          </a:effectRef>
+          <a:fontRef idx="minor">
+            <a:schemeClr val="lt1"/>
+          </a:fontRef>
+        </p:style>
+        <p:txBody>
+          <a:bodyPr rtlCol="0" anchor="ctr"/>
+          <a:lstStyle/>
+          <a:p>
+            <a:pPr algn="ctr"/>
+          </a:p>
+        </p:txBody>
+      </p:sp>
+      <p:sp>
+        <p:nvSpPr>
+          <p:cNvPr id="50" name="Rectangle 49"/>
+          <p:cNvSpPr/>
+          <p:nvPr/>
+        </p:nvSpPr>
+        <p:spPr>
+          <a:xfrm>
+            <a:off x="274320" y="3456432"/>
+            <a:ext cx="11640312" cy="25400"/>
+          </a:xfrm>
+          <a:prstGeom prst="rect">
+            <a:avLst/>
+          </a:prstGeom>
+          <a:solidFill>
+            <a:srgbClr val="1A3555"/>
+          </a:solidFill>
+          <a:ln>
+            <a:noFill/>
+          </a:ln>
+        </p:spPr>
+        <p:style>
+          <a:lnRef idx="1">
+            <a:schemeClr val="accent1"/>
+          </a:lnRef>
+          <a:fillRef idx="3">
+            <a:schemeClr val="accent1"/>
+          </a:fillRef>
+          <a:effectRef idx="2">
+            <a:schemeClr val="accent1"/>
+          </a:effectRef>
+          <a:fontRef idx="minor">
+            <a:schemeClr val="lt1"/>
+          </a:fontRef>
+        </p:style>
+        <p:txBody>
+          <a:bodyPr rtlCol="0" anchor="ctr"/>
+          <a:lstStyle/>
+          <a:p>
+            <a:pPr algn="ctr"/>
+          </a:p>
+        </p:txBody>
+      </p:sp>
+      <p:sp>
+        <p:nvSpPr>
+          <p:cNvPr id="51" name="TextBox 50"/>
+          <p:cNvSpPr txBox="1"/>
+          <p:nvPr/>
+        </p:nvSpPr>
+        <p:spPr>
+          <a:xfrm>
+            <a:off x="347472" y="3035808"/>
+            <a:ext cx="2011680" cy="347472"/>
+          </a:xfrm>
+          <a:prstGeom prst="rect">
+            <a:avLst/>
+          </a:prstGeom>
+          <a:noFill/>
+        </p:spPr>
+        <p:txBody>
+          <a:bodyPr wrap="square">
+            <a:spAutoFit/>
+          </a:bodyPr>
+          <a:lstStyle/>
+          <a:p>
+            <a:pPr algn="ctr"/>
+            <a:r>
+              <a:rPr sz="1300" b="0" i="0">
+                <a:solidFill>
+                  <a:srgbClr val="B0C8E0"/>
+                </a:solidFill>
+              </a:rPr>
+              <a:t>Vol DOWN</a:t>
+            </a:r>
+          </a:p>
+        </p:txBody>
+      </p:sp>
+      <p:sp>
+        <p:nvSpPr>
+          <p:cNvPr id="52" name="TextBox 51"/>
+          <p:cNvSpPr txBox="1"/>
+          <p:nvPr/>
+        </p:nvSpPr>
+        <p:spPr>
+          <a:xfrm>
+            <a:off x="2450591" y="3035808"/>
+            <a:ext cx="658368" cy="347472"/>
+          </a:xfrm>
+          <a:prstGeom prst="rect">
+            <a:avLst/>
+          </a:prstGeom>
+          <a:noFill/>
+        </p:spPr>
+        <p:txBody>
+          <a:bodyPr wrap="square">
+            <a:spAutoFit/>
+          </a:bodyPr>
+          <a:lstStyle/>
+          <a:p>
+            <a:pPr algn="ctr"/>
+            <a:r>
+              <a:rPr sz="1300" b="0" i="0">
+                <a:solidFill>
+                  <a:srgbClr val="FF355E"/>
+                </a:solidFill>
+              </a:rPr>
+              <a:t>↓</a:t>
+            </a:r>
+          </a:p>
+        </p:txBody>
+      </p:sp>
+      <p:sp>
+        <p:nvSpPr>
+          <p:cNvPr id="53" name="TextBox 52"/>
+          <p:cNvSpPr txBox="1"/>
+          <p:nvPr/>
+        </p:nvSpPr>
+        <p:spPr>
+          <a:xfrm>
+            <a:off x="3182112" y="3035808"/>
+            <a:ext cx="658368" cy="347472"/>
+          </a:xfrm>
+          <a:prstGeom prst="rect">
+            <a:avLst/>
+          </a:prstGeom>
+          <a:noFill/>
+        </p:spPr>
+        <p:txBody>
+          <a:bodyPr wrap="square">
+            <a:spAutoFit/>
+          </a:bodyPr>
+          <a:lstStyle/>
+          <a:p>
+            <a:pPr algn="ctr"/>
+            <a:r>
+              <a:rPr sz="1300" b="0" i="0">
+                <a:solidFill>
+                  <a:srgbClr val="00E576"/>
+                </a:solidFill>
+              </a:rPr>
+              <a:t>↑</a:t>
+            </a:r>
+          </a:p>
+        </p:txBody>
+      </p:sp>
+      <p:sp>
+        <p:nvSpPr>
+          <p:cNvPr id="54" name="TextBox 53"/>
+          <p:cNvSpPr txBox="1"/>
+          <p:nvPr/>
+        </p:nvSpPr>
+        <p:spPr>
+          <a:xfrm>
+            <a:off x="3895344" y="3035808"/>
+            <a:ext cx="658368" cy="347472"/>
+          </a:xfrm>
+          <a:prstGeom prst="rect">
+            <a:avLst/>
+          </a:prstGeom>
+          <a:noFill/>
+        </p:spPr>
+        <p:txBody>
+          <a:bodyPr wrap="square">
+            <a:spAutoFit/>
+          </a:bodyPr>
+          <a:lstStyle/>
+          <a:p>
+            <a:pPr algn="ctr"/>
+            <a:r>
+              <a:rPr sz="1300" b="0" i="0">
+                <a:solidFill>
+                  <a:srgbClr val="00E576"/>
+                </a:solidFill>
+              </a:rPr>
+              <a:t>↑</a:t>
+            </a:r>
+          </a:p>
+        </p:txBody>
+      </p:sp>
+      <p:sp>
+        <p:nvSpPr>
+          <p:cNvPr id="55" name="TextBox 54"/>
+          <p:cNvSpPr txBox="1"/>
+          <p:nvPr/>
+        </p:nvSpPr>
+        <p:spPr>
+          <a:xfrm>
+            <a:off x="4645152" y="3035808"/>
+            <a:ext cx="3017520" cy="347472"/>
+          </a:xfrm>
+          <a:prstGeom prst="rect">
+            <a:avLst/>
+          </a:prstGeom>
+          <a:noFill/>
+        </p:spPr>
+        <p:txBody>
+          <a:bodyPr wrap="square">
+            <a:spAutoFit/>
+          </a:bodyPr>
+          <a:lstStyle/>
+          <a:p>
+            <a:pPr algn="ctr"/>
+            <a:r>
+              <a:rPr sz="1300" b="0" i="0">
+                <a:solidFill>
+                  <a:srgbClr val="B0C8E0"/>
+                </a:solidFill>
+              </a:rPr>
+              <a:t>OFF  ON   ON   OFF  OFF</a:t>
+            </a:r>
+          </a:p>
+        </p:txBody>
+      </p:sp>
+      <p:sp>
+        <p:nvSpPr>
+          <p:cNvPr id="56" name="TextBox 55"/>
+          <p:cNvSpPr txBox="1"/>
+          <p:nvPr/>
+        </p:nvSpPr>
+        <p:spPr>
+          <a:xfrm>
+            <a:off x="7790688" y="3035808"/>
+            <a:ext cx="1005840" cy="347472"/>
+          </a:xfrm>
+          <a:prstGeom prst="rect">
+            <a:avLst/>
+          </a:prstGeom>
+          <a:noFill/>
+        </p:spPr>
+        <p:txBody>
+          <a:bodyPr wrap="square">
+            <a:spAutoFit/>
+          </a:bodyPr>
+          <a:lstStyle/>
+          <a:p>
+            <a:pPr algn="ctr"/>
+            <a:r>
+              <a:rPr sz="1300" b="0" i="0">
+                <a:solidFill>
+                  <a:srgbClr val="FFE030"/>
+                </a:solidFill>
+              </a:rPr>
+              <a:t>3</a:t>
+            </a:r>
+          </a:p>
+        </p:txBody>
+      </p:sp>
+      <p:sp>
+        <p:nvSpPr>
+          <p:cNvPr id="57" name="TextBox 56"/>
+          <p:cNvSpPr txBox="1"/>
+          <p:nvPr/>
+        </p:nvSpPr>
+        <p:spPr>
+          <a:xfrm>
+            <a:off x="8961120" y="3035808"/>
+            <a:ext cx="914400" cy="347472"/>
+          </a:xfrm>
+          <a:prstGeom prst="rect">
+            <a:avLst/>
+          </a:prstGeom>
+          <a:noFill/>
+        </p:spPr>
+        <p:txBody>
+          <a:bodyPr wrap="square">
+            <a:spAutoFit/>
+          </a:bodyPr>
+          <a:lstStyle/>
+          <a:p>
+            <a:pPr algn="ctr"/>
+            <a:r>
+              <a:rPr sz="1300" b="0" i="0">
+                <a:solidFill>
+                  <a:srgbClr val="FFE030"/>
+                </a:solidFill>
+              </a:rPr>
+              <a:t>3</a:t>
+            </a:r>
+          </a:p>
+        </p:txBody>
+      </p:sp>
+      <p:sp>
+        <p:nvSpPr>
+          <p:cNvPr id="58" name="Rectangle 57"/>
+          <p:cNvSpPr/>
+          <p:nvPr/>
+        </p:nvSpPr>
+        <p:spPr>
+          <a:xfrm>
+            <a:off x="274320" y="3456432"/>
+            <a:ext cx="11640312" cy="539496"/>
+          </a:xfrm>
+          <a:prstGeom prst="rect">
+            <a:avLst/>
+          </a:prstGeom>
+          <a:solidFill>
+            <a:srgbClr val="0F1E2E"/>
+          </a:solidFill>
+          <a:ln>
+            <a:noFill/>
+          </a:ln>
+        </p:spPr>
+        <p:style>
+          <a:lnRef idx="1">
+            <a:schemeClr val="accent1"/>
+          </a:lnRef>
+          <a:fillRef idx="3">
+            <a:schemeClr val="accent1"/>
+          </a:fillRef>
+          <a:effectRef idx="2">
+            <a:schemeClr val="accent1"/>
+          </a:effectRef>
+          <a:fontRef idx="minor">
+            <a:schemeClr val="lt1"/>
+          </a:fontRef>
+        </p:style>
+        <p:txBody>
+          <a:bodyPr rtlCol="0" anchor="ctr"/>
+          <a:lstStyle/>
+          <a:p>
+            <a:pPr algn="ctr"/>
+          </a:p>
+        </p:txBody>
+      </p:sp>
+      <p:sp>
+        <p:nvSpPr>
+          <p:cNvPr id="59" name="Rectangle 58"/>
+          <p:cNvSpPr/>
+          <p:nvPr/>
+        </p:nvSpPr>
+        <p:spPr>
+          <a:xfrm>
+            <a:off x="274320" y="3995928"/>
+            <a:ext cx="11640312" cy="25400"/>
+          </a:xfrm>
+          <a:prstGeom prst="rect">
+            <a:avLst/>
+          </a:prstGeom>
+          <a:solidFill>
+            <a:srgbClr val="1A3555"/>
+          </a:solidFill>
+          <a:ln>
+            <a:noFill/>
+          </a:ln>
+        </p:spPr>
+        <p:style>
+          <a:lnRef idx="1">
+            <a:schemeClr val="accent1"/>
+          </a:lnRef>
+          <a:fillRef idx="3">
+            <a:schemeClr val="accent1"/>
+          </a:fillRef>
+          <a:effectRef idx="2">
+            <a:schemeClr val="accent1"/>
+          </a:effectRef>
+          <a:fontRef idx="minor">
+            <a:schemeClr val="lt1"/>
+          </a:fontRef>
+        </p:style>
+        <p:txBody>
+          <a:bodyPr rtlCol="0" anchor="ctr"/>
+          <a:lstStyle/>
+          <a:p>
+            <a:pPr algn="ctr"/>
+          </a:p>
+        </p:txBody>
+      </p:sp>
+      <p:sp>
+        <p:nvSpPr>
+          <p:cNvPr id="60" name="TextBox 59"/>
+          <p:cNvSpPr txBox="1"/>
+          <p:nvPr/>
+        </p:nvSpPr>
+        <p:spPr>
+          <a:xfrm>
+            <a:off x="347472" y="3575303"/>
+            <a:ext cx="2011680" cy="347472"/>
+          </a:xfrm>
+          <a:prstGeom prst="rect">
+            <a:avLst/>
+          </a:prstGeom>
+          <a:noFill/>
+        </p:spPr>
+        <p:txBody>
+          <a:bodyPr wrap="square">
+            <a:spAutoFit/>
+          </a:bodyPr>
+          <a:lstStyle/>
+          <a:p>
+            <a:pPr algn="ctr"/>
+            <a:r>
+              <a:rPr sz="1300" b="0" i="0">
+                <a:solidFill>
+                  <a:srgbClr val="B0C8E0"/>
+                </a:solidFill>
+              </a:rPr>
+              <a:t>Heat ON</a:t>
+            </a:r>
+          </a:p>
+        </p:txBody>
+      </p:sp>
+      <p:sp>
+        <p:nvSpPr>
+          <p:cNvPr id="61" name="TextBox 60"/>
+          <p:cNvSpPr txBox="1"/>
+          <p:nvPr/>
+        </p:nvSpPr>
+        <p:spPr>
+          <a:xfrm>
+            <a:off x="2450591" y="3575303"/>
+            <a:ext cx="658368" cy="347472"/>
+          </a:xfrm>
+          <a:prstGeom prst="rect">
+            <a:avLst/>
+          </a:prstGeom>
+          <a:noFill/>
+        </p:spPr>
+        <p:txBody>
+          <a:bodyPr wrap="square">
+            <a:spAutoFit/>
+          </a:bodyPr>
+          <a:lstStyle/>
+          <a:p>
+            <a:pPr algn="ctr"/>
+            <a:r>
+              <a:rPr sz="1300" b="0" i="0">
+                <a:solidFill>
+                  <a:srgbClr val="00E576"/>
+                </a:solidFill>
+              </a:rPr>
+              <a:t>↑</a:t>
+            </a:r>
+          </a:p>
+        </p:txBody>
+      </p:sp>
+      <p:sp>
+        <p:nvSpPr>
+          <p:cNvPr id="62" name="TextBox 61"/>
+          <p:cNvSpPr txBox="1"/>
+          <p:nvPr/>
+        </p:nvSpPr>
+        <p:spPr>
+          <a:xfrm>
+            <a:off x="3182112" y="3575303"/>
+            <a:ext cx="658368" cy="347472"/>
+          </a:xfrm>
+          <a:prstGeom prst="rect">
+            <a:avLst/>
+          </a:prstGeom>
+          <a:noFill/>
+        </p:spPr>
+        <p:txBody>
+          <a:bodyPr wrap="square">
+            <a:spAutoFit/>
+          </a:bodyPr>
+          <a:lstStyle/>
+          <a:p>
+            <a:pPr algn="ctr"/>
+            <a:r>
+              <a:rPr sz="1300" b="0" i="0">
+                <a:solidFill>
+                  <a:srgbClr val="FF355E"/>
+                </a:solidFill>
+              </a:rPr>
+              <a:t>↓</a:t>
+            </a:r>
+          </a:p>
+        </p:txBody>
+      </p:sp>
+      <p:sp>
+        <p:nvSpPr>
+          <p:cNvPr id="63" name="TextBox 62"/>
+          <p:cNvSpPr txBox="1"/>
+          <p:nvPr/>
+        </p:nvSpPr>
+        <p:spPr>
+          <a:xfrm>
+            <a:off x="3895344" y="3575303"/>
+            <a:ext cx="658368" cy="347472"/>
+          </a:xfrm>
+          <a:prstGeom prst="rect">
+            <a:avLst/>
+          </a:prstGeom>
+          <a:noFill/>
+        </p:spPr>
+        <p:txBody>
+          <a:bodyPr wrap="square">
+            <a:spAutoFit/>
+          </a:bodyPr>
+          <a:lstStyle/>
+          <a:p>
+            <a:pPr algn="ctr"/>
+            <a:r>
+              <a:rPr sz="1300" b="0" i="0">
+                <a:solidFill>
+                  <a:srgbClr val="FF355E"/>
+                </a:solidFill>
+              </a:rPr>
+              <a:t>↓</a:t>
+            </a:r>
+          </a:p>
+        </p:txBody>
+      </p:sp>
+      <p:sp>
+        <p:nvSpPr>
+          <p:cNvPr id="64" name="TextBox 63"/>
+          <p:cNvSpPr txBox="1"/>
+          <p:nvPr/>
+        </p:nvSpPr>
+        <p:spPr>
+          <a:xfrm>
+            <a:off x="4645152" y="3575303"/>
+            <a:ext cx="3017520" cy="347472"/>
+          </a:xfrm>
+          <a:prstGeom prst="rect">
+            <a:avLst/>
+          </a:prstGeom>
+          <a:noFill/>
+        </p:spPr>
+        <p:txBody>
+          <a:bodyPr wrap="square">
+            <a:spAutoFit/>
+          </a:bodyPr>
+          <a:lstStyle/>
+          <a:p>
+            <a:pPr algn="ctr"/>
+            <a:r>
+              <a:rPr sz="1300" b="0" i="0">
+                <a:solidFill>
+                  <a:srgbClr val="B0C8E0"/>
+                </a:solidFill>
+              </a:rPr>
+              <a:t>ON   OFF  OFF  OFF  OFF</a:t>
+            </a:r>
+          </a:p>
+        </p:txBody>
+      </p:sp>
+      <p:sp>
+        <p:nvSpPr>
+          <p:cNvPr id="65" name="TextBox 64"/>
+          <p:cNvSpPr txBox="1"/>
+          <p:nvPr/>
+        </p:nvSpPr>
+        <p:spPr>
+          <a:xfrm>
+            <a:off x="7790688" y="3575303"/>
+            <a:ext cx="1005840" cy="347472"/>
+          </a:xfrm>
+          <a:prstGeom prst="rect">
+            <a:avLst/>
+          </a:prstGeom>
+          <a:noFill/>
+        </p:spPr>
+        <p:txBody>
+          <a:bodyPr wrap="square">
+            <a:spAutoFit/>
+          </a:bodyPr>
+          <a:lstStyle/>
+          <a:p>
+            <a:pPr algn="ctr"/>
+            <a:r>
+              <a:rPr sz="1300" b="0" i="0">
+                <a:solidFill>
+                  <a:srgbClr val="FFE030"/>
+                </a:solidFill>
+              </a:rPr>
+              <a:t>4</a:t>
+            </a:r>
+          </a:p>
+        </p:txBody>
+      </p:sp>
+      <p:sp>
+        <p:nvSpPr>
+          <p:cNvPr id="66" name="TextBox 65"/>
+          <p:cNvSpPr txBox="1"/>
+          <p:nvPr/>
+        </p:nvSpPr>
+        <p:spPr>
+          <a:xfrm>
+            <a:off x="8961120" y="3575303"/>
+            <a:ext cx="914400" cy="347472"/>
+          </a:xfrm>
+          <a:prstGeom prst="rect">
+            <a:avLst/>
+          </a:prstGeom>
+          <a:noFill/>
+        </p:spPr>
+        <p:txBody>
+          <a:bodyPr wrap="square">
+            <a:spAutoFit/>
+          </a:bodyPr>
+          <a:lstStyle/>
+          <a:p>
+            <a:pPr algn="ctr"/>
+            <a:r>
+              <a:rPr sz="1300" b="0" i="0">
+                <a:solidFill>
+                  <a:srgbClr val="FFE030"/>
+                </a:solidFill>
+              </a:rPr>
+              <a:t>4</a:t>
+            </a:r>
+          </a:p>
+        </p:txBody>
+      </p:sp>
+      <p:sp>
+        <p:nvSpPr>
+          <p:cNvPr id="67" name="Rectangle 66"/>
+          <p:cNvSpPr/>
+          <p:nvPr/>
+        </p:nvSpPr>
+        <p:spPr>
+          <a:xfrm>
+            <a:off x="274320" y="3995927"/>
+            <a:ext cx="11640312" cy="539496"/>
+          </a:xfrm>
+          <a:prstGeom prst="rect">
+            <a:avLst/>
+          </a:prstGeom>
+          <a:solidFill>
+            <a:srgbClr val="112338"/>
+          </a:solidFill>
+          <a:ln>
+            <a:noFill/>
+          </a:ln>
+        </p:spPr>
+        <p:style>
+          <a:lnRef idx="1">
+            <a:schemeClr val="accent1"/>
+          </a:lnRef>
+          <a:fillRef idx="3">
+            <a:schemeClr val="accent1"/>
+          </a:fillRef>
+          <a:effectRef idx="2">
+            <a:schemeClr val="accent1"/>
+          </a:effectRef>
+          <a:fontRef idx="minor">
+            <a:schemeClr val="lt1"/>
+          </a:fontRef>
+        </p:style>
+        <p:txBody>
+          <a:bodyPr rtlCol="0" anchor="ctr"/>
+          <a:lstStyle/>
+          <a:p>
+            <a:pPr algn="ctr"/>
+          </a:p>
+        </p:txBody>
+      </p:sp>
+      <p:sp>
+        <p:nvSpPr>
+          <p:cNvPr id="68" name="Rectangle 67"/>
+          <p:cNvSpPr/>
+          <p:nvPr/>
+        </p:nvSpPr>
+        <p:spPr>
+          <a:xfrm>
+            <a:off x="274320" y="4535423"/>
+            <a:ext cx="11640312" cy="25400"/>
+          </a:xfrm>
+          <a:prstGeom prst="rect">
+            <a:avLst/>
+          </a:prstGeom>
+          <a:solidFill>
+            <a:srgbClr val="1A3555"/>
+          </a:solidFill>
+          <a:ln>
+            <a:noFill/>
+          </a:ln>
+        </p:spPr>
+        <p:style>
+          <a:lnRef idx="1">
+            <a:schemeClr val="accent1"/>
+          </a:lnRef>
+          <a:fillRef idx="3">
+            <a:schemeClr val="accent1"/>
+          </a:fillRef>
+          <a:effectRef idx="2">
+            <a:schemeClr val="accent1"/>
+          </a:effectRef>
+          <a:fontRef idx="minor">
+            <a:schemeClr val="lt1"/>
+          </a:fontRef>
+        </p:style>
+        <p:txBody>
+          <a:bodyPr rtlCol="0" anchor="ctr"/>
+          <a:lstStyle/>
+          <a:p>
+            <a:pPr algn="ctr"/>
+          </a:p>
+        </p:txBody>
+      </p:sp>
+      <p:sp>
+        <p:nvSpPr>
+          <p:cNvPr id="69" name="TextBox 68"/>
+          <p:cNvSpPr txBox="1"/>
+          <p:nvPr/>
+        </p:nvSpPr>
+        <p:spPr>
+          <a:xfrm>
+            <a:off x="347472" y="4114799"/>
+            <a:ext cx="2011680" cy="347472"/>
+          </a:xfrm>
+          <a:prstGeom prst="rect">
+            <a:avLst/>
+          </a:prstGeom>
+          <a:noFill/>
+        </p:spPr>
+        <p:txBody>
+          <a:bodyPr wrap="square">
+            <a:spAutoFit/>
+          </a:bodyPr>
+          <a:lstStyle/>
+          <a:p>
+            <a:pPr algn="ctr"/>
+            <a:r>
+              <a:rPr sz="1300" b="0" i="0">
+                <a:solidFill>
+                  <a:srgbClr val="B0C8E0"/>
+                </a:solidFill>
+              </a:rPr>
+              <a:t>Heat OFF</a:t>
+            </a:r>
+          </a:p>
+        </p:txBody>
+      </p:sp>
+      <p:sp>
+        <p:nvSpPr>
+          <p:cNvPr id="70" name="TextBox 69"/>
+          <p:cNvSpPr txBox="1"/>
+          <p:nvPr/>
+        </p:nvSpPr>
+        <p:spPr>
+          <a:xfrm>
+            <a:off x="2450591" y="4114799"/>
+            <a:ext cx="658368" cy="347472"/>
+          </a:xfrm>
+          <a:prstGeom prst="rect">
+            <a:avLst/>
+          </a:prstGeom>
+          <a:noFill/>
+        </p:spPr>
+        <p:txBody>
+          <a:bodyPr wrap="square">
+            <a:spAutoFit/>
+          </a:bodyPr>
+          <a:lstStyle/>
+          <a:p>
+            <a:pPr algn="ctr"/>
+            <a:r>
+              <a:rPr sz="1300" b="0" i="0">
+                <a:solidFill>
+                  <a:srgbClr val="00E576"/>
+                </a:solidFill>
+              </a:rPr>
+              <a:t>↑</a:t>
+            </a:r>
+          </a:p>
+        </p:txBody>
+      </p:sp>
+      <p:sp>
+        <p:nvSpPr>
+          <p:cNvPr id="71" name="TextBox 70"/>
+          <p:cNvSpPr txBox="1"/>
+          <p:nvPr/>
+        </p:nvSpPr>
+        <p:spPr>
+          <a:xfrm>
+            <a:off x="3182112" y="4114799"/>
+            <a:ext cx="658368" cy="347472"/>
+          </a:xfrm>
+          <a:prstGeom prst="rect">
+            <a:avLst/>
+          </a:prstGeom>
+          <a:noFill/>
+        </p:spPr>
+        <p:txBody>
+          <a:bodyPr wrap="square">
+            <a:spAutoFit/>
+          </a:bodyPr>
+          <a:lstStyle/>
+          <a:p>
+            <a:pPr algn="ctr"/>
+            <a:r>
+              <a:rPr sz="1300" b="0" i="0">
+                <a:solidFill>
+                  <a:srgbClr val="FF355E"/>
+                </a:solidFill>
+              </a:rPr>
+              <a:t>↓</a:t>
+            </a:r>
+          </a:p>
+        </p:txBody>
+      </p:sp>
+      <p:sp>
+        <p:nvSpPr>
+          <p:cNvPr id="72" name="TextBox 71"/>
+          <p:cNvSpPr txBox="1"/>
+          <p:nvPr/>
+        </p:nvSpPr>
+        <p:spPr>
+          <a:xfrm>
+            <a:off x="3895344" y="4114799"/>
+            <a:ext cx="658368" cy="347472"/>
+          </a:xfrm>
+          <a:prstGeom prst="rect">
+            <a:avLst/>
+          </a:prstGeom>
+          <a:noFill/>
+        </p:spPr>
+        <p:txBody>
+          <a:bodyPr wrap="square">
+            <a:spAutoFit/>
+          </a:bodyPr>
+          <a:lstStyle/>
+          <a:p>
+            <a:pPr algn="ctr"/>
+            <a:r>
+              <a:rPr sz="1300" b="0" i="0">
+                <a:solidFill>
+                  <a:srgbClr val="00E576"/>
+                </a:solidFill>
+              </a:rPr>
+              <a:t>↑</a:t>
+            </a:r>
+          </a:p>
+        </p:txBody>
+      </p:sp>
+      <p:sp>
+        <p:nvSpPr>
+          <p:cNvPr id="73" name="TextBox 72"/>
+          <p:cNvSpPr txBox="1"/>
+          <p:nvPr/>
+        </p:nvSpPr>
+        <p:spPr>
+          <a:xfrm>
+            <a:off x="4645152" y="4114799"/>
+            <a:ext cx="3017520" cy="347472"/>
+          </a:xfrm>
+          <a:prstGeom prst="rect">
+            <a:avLst/>
+          </a:prstGeom>
+          <a:noFill/>
+        </p:spPr>
+        <p:txBody>
+          <a:bodyPr wrap="square">
+            <a:spAutoFit/>
+          </a:bodyPr>
+          <a:lstStyle/>
+          <a:p>
+            <a:pPr algn="ctr"/>
+            <a:r>
+              <a:rPr sz="1300" b="0" i="0">
+                <a:solidFill>
+                  <a:srgbClr val="B0C8E0"/>
+                </a:solidFill>
+              </a:rPr>
+              <a:t>ON   OFF  ON   OFF  OFF</a:t>
+            </a:r>
+          </a:p>
+        </p:txBody>
+      </p:sp>
+      <p:sp>
+        <p:nvSpPr>
+          <p:cNvPr id="74" name="TextBox 73"/>
+          <p:cNvSpPr txBox="1"/>
+          <p:nvPr/>
+        </p:nvSpPr>
+        <p:spPr>
+          <a:xfrm>
+            <a:off x="7790688" y="4114799"/>
+            <a:ext cx="1005840" cy="347472"/>
+          </a:xfrm>
+          <a:prstGeom prst="rect">
+            <a:avLst/>
+          </a:prstGeom>
+          <a:noFill/>
+        </p:spPr>
+        <p:txBody>
+          <a:bodyPr wrap="square">
+            <a:spAutoFit/>
+          </a:bodyPr>
+          <a:lstStyle/>
+          <a:p>
+            <a:pPr algn="ctr"/>
+            <a:r>
+              <a:rPr sz="1300" b="0" i="0">
+                <a:solidFill>
+                  <a:srgbClr val="FFE030"/>
+                </a:solidFill>
+              </a:rPr>
+              <a:t>5</a:t>
+            </a:r>
+          </a:p>
+        </p:txBody>
+      </p:sp>
+      <p:sp>
+        <p:nvSpPr>
+          <p:cNvPr id="75" name="TextBox 74"/>
+          <p:cNvSpPr txBox="1"/>
+          <p:nvPr/>
+        </p:nvSpPr>
+        <p:spPr>
+          <a:xfrm>
+            <a:off x="8961120" y="4114799"/>
+            <a:ext cx="914400" cy="347472"/>
+          </a:xfrm>
+          <a:prstGeom prst="rect">
+            <a:avLst/>
+          </a:prstGeom>
+          <a:noFill/>
+        </p:spPr>
+        <p:txBody>
+          <a:bodyPr wrap="square">
+            <a:spAutoFit/>
+          </a:bodyPr>
+          <a:lstStyle/>
+          <a:p>
+            <a:pPr algn="ctr"/>
+            <a:r>
+              <a:rPr sz="1300" b="0" i="0">
+                <a:solidFill>
+                  <a:srgbClr val="FFE030"/>
+                </a:solidFill>
+              </a:rPr>
+              <a:t>5</a:t>
+            </a:r>
+          </a:p>
+        </p:txBody>
+      </p:sp>
+      <p:sp>
+        <p:nvSpPr>
+          <p:cNvPr id="76" name="Rectangle 75"/>
+          <p:cNvSpPr/>
+          <p:nvPr/>
+        </p:nvSpPr>
+        <p:spPr>
+          <a:xfrm>
+            <a:off x="274320" y="4754880"/>
+            <a:ext cx="11640312" cy="1051560"/>
+          </a:xfrm>
+          <a:prstGeom prst="rect">
+            <a:avLst/>
+          </a:prstGeom>
+          <a:solidFill>
+            <a:srgbClr val="0D1E35"/>
+          </a:solidFill>
+          <a:ln w="15240">
+            <a:solidFill>
+              <a:srgbClr val="7C3AED"/>
+            </a:solidFill>
+          </a:ln>
+        </p:spPr>
+        <p:style>
+          <a:lnRef idx="1">
+            <a:schemeClr val="accent1"/>
+          </a:lnRef>
+          <a:fillRef idx="3">
+            <a:schemeClr val="accent1"/>
+          </a:fillRef>
+          <a:effectRef idx="2">
+            <a:schemeClr val="accent1"/>
+          </a:effectRef>
+          <a:fontRef idx="minor">
+            <a:schemeClr val="lt1"/>
+          </a:fontRef>
+        </p:style>
+        <p:txBody>
+          <a:bodyPr rtlCol="0" anchor="ctr"/>
+          <a:lstStyle/>
+          <a:p>
+            <a:pPr algn="ctr"/>
+          </a:p>
+        </p:txBody>
+      </p:sp>
+      <p:sp>
+        <p:nvSpPr>
+          <p:cNvPr id="77" name="Rectangle 76"/>
+          <p:cNvSpPr/>
+          <p:nvPr/>
+        </p:nvSpPr>
+        <p:spPr>
+          <a:xfrm>
+            <a:off x="274320" y="4754880"/>
+            <a:ext cx="11640312" cy="25400"/>
+          </a:xfrm>
+          <a:prstGeom prst="rect">
+            <a:avLst/>
+          </a:prstGeom>
+          <a:solidFill>
+            <a:srgbClr val="7C3AED"/>
+          </a:solidFill>
+          <a:ln>
+            <a:noFill/>
+          </a:ln>
+        </p:spPr>
+        <p:style>
+          <a:lnRef idx="1">
+            <a:schemeClr val="accent1"/>
+          </a:lnRef>
+          <a:fillRef idx="3">
+            <a:schemeClr val="accent1"/>
+          </a:fillRef>
+          <a:effectRef idx="2">
+            <a:schemeClr val="accent1"/>
+          </a:effectRef>
+          <a:fontRef idx="minor">
+            <a:schemeClr val="lt1"/>
+          </a:fontRef>
+        </p:style>
+        <p:txBody>
+          <a:bodyPr rtlCol="0" anchor="ctr"/>
+          <a:lstStyle/>
+          <a:p>
+            <a:pPr algn="ctr"/>
+          </a:p>
+        </p:txBody>
+      </p:sp>
+      <p:sp>
+        <p:nvSpPr>
+          <p:cNvPr id="78" name="TextBox 77"/>
+          <p:cNvSpPr txBox="1"/>
+          <p:nvPr/>
+        </p:nvSpPr>
+        <p:spPr>
+          <a:xfrm>
+            <a:off x="502920" y="4828032"/>
+            <a:ext cx="11274552" cy="292608"/>
+          </a:xfrm>
+          <a:prstGeom prst="rect">
+            <a:avLst/>
+          </a:prstGeom>
+          <a:noFill/>
+        </p:spPr>
+        <p:txBody>
+          <a:bodyPr wrap="square">
+            <a:spAutoFit/>
+          </a:bodyPr>
+          <a:lstStyle/>
+          <a:p>
+            <a:pPr algn="l"/>
+            <a:r>
+              <a:rPr sz="1300" b="0" i="0">
+                <a:solidFill>
+                  <a:srgbClr val="00E576"/>
+                </a:solidFill>
+              </a:rPr>
+              <a:t>MODE switches  -&gt;  SW1=↓  SW0=↓   -&gt;   HEX1 = 0,  cycles = 15b8  (Tier 0)</a:t>
+            </a:r>
+          </a:p>
+        </p:txBody>
+      </p:sp>
+      <p:sp>
+        <p:nvSpPr>
+          <p:cNvPr id="79" name="TextBox 78"/>
+          <p:cNvSpPr txBox="1"/>
+          <p:nvPr/>
+        </p:nvSpPr>
+        <p:spPr>
+          <a:xfrm>
+            <a:off x="502920" y="5129784"/>
+            <a:ext cx="11274552" cy="292608"/>
+          </a:xfrm>
+          <a:prstGeom prst="rect">
+            <a:avLst/>
+          </a:prstGeom>
+          <a:noFill/>
+        </p:spPr>
+        <p:txBody>
+          <a:bodyPr wrap="square">
+            <a:spAutoFit/>
+          </a:bodyPr>
+          <a:lstStyle/>
+          <a:p>
+            <a:pPr algn="l"/>
+            <a:r>
+              <a:rPr sz="1300" b="0" i="0">
+                <a:solidFill>
+                  <a:srgbClr val="00D4FF"/>
+                </a:solidFill>
+              </a:rPr>
+              <a:t>               -&gt;  SW1=↓  SW0=↑   -&gt;   HEX1 = 1,  cycles = 15b8  (Tier 1)</a:t>
+            </a:r>
+          </a:p>
+        </p:txBody>
+      </p:sp>
+      <p:sp>
+        <p:nvSpPr>
+          <p:cNvPr id="80" name="TextBox 79"/>
+          <p:cNvSpPr txBox="1"/>
+          <p:nvPr/>
+        </p:nvSpPr>
+        <p:spPr>
+          <a:xfrm>
+            <a:off x="502920" y="5431536"/>
+            <a:ext cx="11274552" cy="292608"/>
+          </a:xfrm>
+          <a:prstGeom prst="rect">
+            <a:avLst/>
+          </a:prstGeom>
+          <a:noFill/>
+        </p:spPr>
+        <p:txBody>
+          <a:bodyPr wrap="square">
+            <a:spAutoFit/>
+          </a:bodyPr>
+          <a:lstStyle/>
+          <a:p>
+            <a:pPr algn="l"/>
+            <a:r>
+              <a:rPr sz="1300" b="0" i="0">
+                <a:solidFill>
+                  <a:srgbClr val="FF355E"/>
+                </a:solidFill>
+              </a:rPr>
+              <a:t>               -&gt;  SW1=↑  SW0=↓   -&gt;   HEX1 = A,  cycles = 1638  (Version A)</a:t>
+            </a:r>
+          </a:p>
+        </p:txBody>
+      </p:sp>
+      <p:sp>
+        <p:nvSpPr>
+          <p:cNvPr id="81" name="Rectangle 80"/>
+          <p:cNvSpPr/>
+          <p:nvPr/>
+        </p:nvSpPr>
+        <p:spPr>
+          <a:xfrm>
+            <a:off x="274320" y="5897880"/>
+            <a:ext cx="11640312" cy="566928"/>
+          </a:xfrm>
+          <a:prstGeom prst="rect">
+            <a:avLst/>
+          </a:prstGeom>
+          <a:solidFill>
+            <a:srgbClr val="102210"/>
+          </a:solidFill>
+          <a:ln w="15240">
+            <a:solidFill>
+              <a:srgbClr val="00E576"/>
+            </a:solidFill>
+          </a:ln>
+        </p:spPr>
+        <p:style>
+          <a:lnRef idx="1">
+            <a:schemeClr val="accent1"/>
+          </a:lnRef>
+          <a:fillRef idx="3">
+            <a:schemeClr val="accent1"/>
+          </a:fillRef>
+          <a:effectRef idx="2">
+            <a:schemeClr val="accent1"/>
+          </a:effectRef>
+          <a:fontRef idx="minor">
+            <a:schemeClr val="lt1"/>
+          </a:fontRef>
+        </p:style>
+        <p:txBody>
+          <a:bodyPr rtlCol="0" anchor="ctr"/>
+          <a:lstStyle/>
+          <a:p>
+            <a:pPr algn="ctr"/>
+          </a:p>
+        </p:txBody>
+      </p:sp>
+      <p:sp>
+        <p:nvSpPr>
+          <p:cNvPr id="82" name="TextBox 81"/>
+          <p:cNvSpPr txBox="1"/>
+          <p:nvPr/>
+        </p:nvSpPr>
+        <p:spPr>
+          <a:xfrm>
+            <a:off x="457200" y="5989320"/>
+            <a:ext cx="11274552" cy="411480"/>
+          </a:xfrm>
+          <a:prstGeom prst="rect">
+            <a:avLst/>
+          </a:prstGeom>
+          <a:noFill/>
+        </p:spPr>
+        <p:txBody>
+          <a:bodyPr wrap="square">
+            <a:spAutoFit/>
+          </a:bodyPr>
+          <a:lstStyle/>
+          <a:p>
+            <a:pPr algn="ctr"/>
+            <a:r>
+              <a:rPr sz="1350" b="1" i="0">
+                <a:solidFill>
+                  <a:srgbClr val="00E576"/>
+                </a:solidFill>
+              </a:rPr>
+              <a:t>LEDG0 = blink briefly (BUSY)          LEDG1 = stays ON (DONE)          LEDG2 = heartbeat (always blinks 1.5 Hz)</a:t>
+            </a:r>
+          </a:p>
+        </p:txBody>
+      </p:sp>
+      <p:sp>
+        <p:nvSpPr>
+          <p:cNvPr id="83" name="TextBox 82"/>
+          <p:cNvSpPr txBox="1"/>
+          <p:nvPr/>
+        </p:nvSpPr>
+        <p:spPr>
+          <a:xfrm>
+            <a:off x="274320" y="6556248"/>
+            <a:ext cx="11640312" cy="347472"/>
+          </a:xfrm>
+          <a:prstGeom prst="rect">
+            <a:avLst/>
+          </a:prstGeom>
+          <a:noFill/>
+        </p:spPr>
+        <p:txBody>
+          <a:bodyPr wrap="square">
+            <a:spAutoFit/>
+          </a:bodyPr>
+          <a:lstStyle/>
+          <a:p>
+            <a:pPr algn="ctr"/>
+            <a:r>
+              <a:rPr sz="1150" b="0" i="1">
+                <a:solidFill>
+                  <a:srgbClr val="FFE030"/>
+                </a:solidFill>
+              </a:rPr>
+              <a:t>KEY[0] = Reset board     |     KEY[1] = Manually re-trigger inference     |     HEX0 must always equal HEX2 =&gt; 100% accuracy</a:t>
             </a:r>
           </a:p>
         </p:txBody>

</xml_diff>

<commit_message>
docs: add Tier 0 vs Version A comparison chart slide (slide 10) with 6-panel performance analysis
</commit_message>
<xml_diff>
--- a/docs/INT8_Transformer_FPGA_Presentation.pptx
+++ b/docs/INT8_Transformer_FPGA_Presentation.pptx
@@ -14,6 +14,7 @@
     <p:sldId id="262" r:id="rId13"/>
     <p:sldId id="263" r:id="rId14"/>
     <p:sldId id="264" r:id="rId15"/>
+    <p:sldId id="265" r:id="rId16"/>
   </p:sldIdLst>
   <p:sldSz cx="12188952" cy="6858000" type="screen4x3"/>
   <p:notesSz cx="6858000" cy="9144000"/>
@@ -3504,6 +3505,176 @@
           </a:p>
         </p:txBody>
       </p:sp>
+    </p:spTree>
+  </p:cSld>
+  <p:clrMapOvr>
+    <a:masterClrMapping/>
+  </p:clrMapOvr>
+</p:sld>
+</file>
+
+<file path=ppt/slides/slide10.xml><?xml version="1.0" encoding="utf-8"?>
+<p:sld xmlns:a="http://schemas.openxmlformats.org/drawingml/2006/main" xmlns:p="http://schemas.openxmlformats.org/presentationml/2006/main" xmlns:r="http://schemas.openxmlformats.org/officeDocument/2006/relationships">
+  <p:cSld>
+    <p:bg>
+      <p:bgPr>
+        <a:solidFill>
+          <a:srgbClr val="0D1B2A"/>
+        </a:solidFill>
+        <a:effectLst/>
+      </p:bgPr>
+    </p:bg>
+    <p:spTree>
+      <p:nvGrpSpPr>
+        <p:cNvPr id="1" name=""/>
+        <p:cNvGrpSpPr/>
+        <p:nvPr/>
+      </p:nvGrpSpPr>
+      <p:grpSpPr/>
+      <p:sp>
+        <p:nvSpPr>
+          <p:cNvPr id="2" name="Rectangle 1"/>
+          <p:cNvSpPr/>
+          <p:nvPr/>
+        </p:nvSpPr>
+        <p:spPr>
+          <a:xfrm>
+            <a:off x="0" y="0"/>
+            <a:ext cx="12188952" cy="63500"/>
+          </a:xfrm>
+          <a:prstGeom prst="rect">
+            <a:avLst/>
+          </a:prstGeom>
+          <a:solidFill>
+            <a:srgbClr val="00D4FF"/>
+          </a:solidFill>
+          <a:ln>
+            <a:noFill/>
+          </a:ln>
+        </p:spPr>
+        <p:style>
+          <a:lnRef idx="1">
+            <a:schemeClr val="accent1"/>
+          </a:lnRef>
+          <a:fillRef idx="3">
+            <a:schemeClr val="accent1"/>
+          </a:fillRef>
+          <a:effectRef idx="2">
+            <a:schemeClr val="accent1"/>
+          </a:effectRef>
+          <a:fontRef idx="minor">
+            <a:schemeClr val="lt1"/>
+          </a:fontRef>
+        </p:style>
+        <p:txBody>
+          <a:bodyPr rtlCol="0" anchor="ctr"/>
+          <a:lstStyle/>
+          <a:p>
+            <a:pPr algn="ctr"/>
+          </a:p>
+        </p:txBody>
+      </p:sp>
+      <p:sp>
+        <p:nvSpPr>
+          <p:cNvPr id="3" name="TextBox 2"/>
+          <p:cNvSpPr txBox="1"/>
+          <p:nvPr/>
+        </p:nvSpPr>
+        <p:spPr>
+          <a:xfrm>
+            <a:off x="365760" y="109728"/>
+            <a:ext cx="11430000" cy="502920"/>
+          </a:xfrm>
+          <a:prstGeom prst="rect">
+            <a:avLst/>
+          </a:prstGeom>
+          <a:noFill/>
+        </p:spPr>
+        <p:txBody>
+          <a:bodyPr wrap="square">
+            <a:spAutoFit/>
+          </a:bodyPr>
+          <a:lstStyle/>
+          <a:p>
+            <a:pPr algn="l"/>
+            <a:r>
+              <a:rPr sz="2400" b="1">
+                <a:solidFill>
+                  <a:srgbClr val="00D4FF"/>
+                </a:solidFill>
+              </a:rPr>
+              <a:t>Performance Comparison: Tier 0 vs Version A</a:t>
+            </a:r>
+          </a:p>
+        </p:txBody>
+      </p:sp>
+      <p:sp>
+        <p:nvSpPr>
+          <p:cNvPr id="4" name="Rectangle 3"/>
+          <p:cNvSpPr/>
+          <p:nvPr/>
+        </p:nvSpPr>
+        <p:spPr>
+          <a:xfrm>
+            <a:off x="365760" y="658368"/>
+            <a:ext cx="11430000" cy="25400"/>
+          </a:xfrm>
+          <a:prstGeom prst="rect">
+            <a:avLst/>
+          </a:prstGeom>
+          <a:solidFill>
+            <a:srgbClr val="7C3AED"/>
+          </a:solidFill>
+          <a:ln>
+            <a:noFill/>
+          </a:ln>
+        </p:spPr>
+        <p:style>
+          <a:lnRef idx="1">
+            <a:schemeClr val="accent1"/>
+          </a:lnRef>
+          <a:fillRef idx="3">
+            <a:schemeClr val="accent1"/>
+          </a:fillRef>
+          <a:effectRef idx="2">
+            <a:schemeClr val="accent1"/>
+          </a:effectRef>
+          <a:fontRef idx="minor">
+            <a:schemeClr val="lt1"/>
+          </a:fontRef>
+        </p:style>
+        <p:txBody>
+          <a:bodyPr rtlCol="0" anchor="ctr"/>
+          <a:lstStyle/>
+          <a:p>
+            <a:pPr algn="ctr"/>
+          </a:p>
+        </p:txBody>
+      </p:sp>
+      <p:pic>
+        <p:nvPicPr>
+          <p:cNvPr id="5" name="Picture 4" descr="comparison_chart.png"/>
+          <p:cNvPicPr>
+            <a:picLocks noChangeAspect="1"/>
+          </p:cNvPicPr>
+          <p:nvPr/>
+        </p:nvPicPr>
+        <p:blipFill>
+          <a:blip r:embed="rId2"/>
+          <a:stretch>
+            <a:fillRect/>
+          </a:stretch>
+        </p:blipFill>
+        <p:spPr>
+          <a:xfrm>
+            <a:off x="137160" y="749808"/>
+            <a:ext cx="10972800" cy="5806440"/>
+          </a:xfrm>
+          <a:prstGeom prst="rect">
+            <a:avLst/>
+          </a:prstGeom>
+        </p:spPr>
+      </p:pic>
     </p:spTree>
   </p:cSld>
   <p:clrMapOvr>

</xml_diff>

<commit_message>
docs: add formula slide e^z=2^(z*log2(e)) to PPT and update uart_rx with metastability filter
</commit_message>
<xml_diff>
--- a/docs/INT8_Transformer_FPGA_Presentation.pptx
+++ b/docs/INT8_Transformer_FPGA_Presentation.pptx
@@ -4,19 +4,22 @@
   <p:sldMasterIdLst>
     <p:sldMasterId id="2147483648" r:id="rId1"/>
   </p:sldMasterIdLst>
+  <p:notesMasterIdLst>
+    <p:notesMasterId r:id="rId12"/>
+  </p:notesMasterIdLst>
   <p:sldIdLst>
-    <p:sldId id="256" r:id="rId7"/>
-    <p:sldId id="257" r:id="rId8"/>
-    <p:sldId id="258" r:id="rId9"/>
-    <p:sldId id="259" r:id="rId10"/>
-    <p:sldId id="260" r:id="rId11"/>
-    <p:sldId id="261" r:id="rId12"/>
-    <p:sldId id="262" r:id="rId13"/>
-    <p:sldId id="263" r:id="rId14"/>
-    <p:sldId id="264" r:id="rId15"/>
-    <p:sldId id="265" r:id="rId16"/>
+    <p:sldId id="256" r:id="rId2"/>
+    <p:sldId id="257" r:id="rId3"/>
+    <p:sldId id="258" r:id="rId4"/>
+    <p:sldId id="259" r:id="rId5"/>
+    <p:sldId id="260" r:id="rId6"/>
+    <p:sldId id="261" r:id="rId7"/>
+    <p:sldId id="262" r:id="rId8"/>
+    <p:sldId id="263" r:id="rId9"/>
+    <p:sldId id="264" r:id="rId10"/>
+    <p:sldId id="265" r:id="rId11"/>
   </p:sldIdLst>
-  <p:sldSz cx="12188952" cy="6858000" type="screen4x3"/>
+  <p:sldSz cx="12188825" cy="6858000"/>
   <p:notesSz cx="6858000" cy="9144000"/>
   <p:defaultTextStyle>
     <a:defPPr>
@@ -113,7 +116,510 @@
       </a:defRPr>
     </a:lvl9pPr>
   </p:defaultTextStyle>
+  <p:extLst>
+    <p:ext uri="{EFAFB233-063F-42B5-8137-9DF3F51BA10A}">
+      <p15:sldGuideLst xmlns:p15="http://schemas.microsoft.com/office/powerpoint/2012/main">
+        <p15:guide id="1" orient="horz" pos="2160">
+          <p15:clr>
+            <a:srgbClr val="A4A3A4"/>
+          </p15:clr>
+        </p15:guide>
+        <p15:guide id="2" pos="2880">
+          <p15:clr>
+            <a:srgbClr val="A4A3A4"/>
+          </p15:clr>
+        </p15:guide>
+      </p15:sldGuideLst>
+    </p:ext>
+  </p:extLst>
 </p:presentation>
+</file>
+
+<file path=ppt/changesInfos/changesInfo1.xml><?xml version="1.0" encoding="utf-8"?>
+<pc:chgInfo xmlns:a="http://schemas.openxmlformats.org/drawingml/2006/main" xmlns:r="http://schemas.openxmlformats.org/officeDocument/2006/relationships" xmlns:ac="http://schemas.microsoft.com/office/drawing/2013/main/command" xmlns:pc="http://schemas.microsoft.com/office/powerpoint/2013/main/command">
+  <pc:docChgLst>
+    <pc:chgData name="shailesh a" userId="43c82f3c7150fcad" providerId="LiveId" clId="{9E4A3FBD-179F-45D1-B6F9-47A518B5881E}"/>
+    <pc:docChg chg="undo custSel modSld">
+      <pc:chgData name="shailesh a" userId="43c82f3c7150fcad" providerId="LiveId" clId="{9E4A3FBD-179F-45D1-B6F9-47A518B5881E}" dt="2026-09-07T09:50:22.594" v="4" actId="1076"/>
+      <pc:docMkLst>
+        <pc:docMk/>
+      </pc:docMkLst>
+      <pc:sldChg chg="modSp mod">
+        <pc:chgData name="shailesh a" userId="43c82f3c7150fcad" providerId="LiveId" clId="{9E4A3FBD-179F-45D1-B6F9-47A518B5881E}" dt="2026-09-07T09:50:22.594" v="4" actId="1076"/>
+        <pc:sldMkLst>
+          <pc:docMk/>
+          <pc:sldMk cId="0" sldId="261"/>
+        </pc:sldMkLst>
+        <pc:spChg chg="mod">
+          <ac:chgData name="shailesh a" userId="43c82f3c7150fcad" providerId="LiveId" clId="{9E4A3FBD-179F-45D1-B6F9-47A518B5881E}" dt="2026-09-07T09:50:16.579" v="2" actId="1076"/>
+          <ac:spMkLst>
+            <pc:docMk/>
+            <pc:sldMk cId="0" sldId="261"/>
+            <ac:spMk id="10" creationId="{00000000-0000-0000-0000-000000000000}"/>
+          </ac:spMkLst>
+        </pc:spChg>
+        <pc:spChg chg="mod">
+          <ac:chgData name="shailesh a" userId="43c82f3c7150fcad" providerId="LiveId" clId="{9E4A3FBD-179F-45D1-B6F9-47A518B5881E}" dt="2026-09-07T09:50:19.615" v="3" actId="1076"/>
+          <ac:spMkLst>
+            <pc:docMk/>
+            <pc:sldMk cId="0" sldId="261"/>
+            <ac:spMk id="11" creationId="{00000000-0000-0000-0000-000000000000}"/>
+          </ac:spMkLst>
+        </pc:spChg>
+        <pc:spChg chg="mod">
+          <ac:chgData name="shailesh a" userId="43c82f3c7150fcad" providerId="LiveId" clId="{9E4A3FBD-179F-45D1-B6F9-47A518B5881E}" dt="2026-09-07T09:50:22.594" v="4" actId="1076"/>
+          <ac:spMkLst>
+            <pc:docMk/>
+            <pc:sldMk cId="0" sldId="261"/>
+            <ac:spMk id="12" creationId="{00000000-0000-0000-0000-000000000000}"/>
+          </ac:spMkLst>
+        </pc:spChg>
+        <pc:spChg chg="mod">
+          <ac:chgData name="shailesh a" userId="43c82f3c7150fcad" providerId="LiveId" clId="{9E4A3FBD-179F-45D1-B6F9-47A518B5881E}" dt="2026-09-07T09:50:13.138" v="1" actId="1076"/>
+          <ac:spMkLst>
+            <pc:docMk/>
+            <pc:sldMk cId="0" sldId="261"/>
+            <ac:spMk id="13" creationId="{00000000-0000-0000-0000-000000000000}"/>
+          </ac:spMkLst>
+        </pc:spChg>
+      </pc:sldChg>
+    </pc:docChg>
+  </pc:docChgLst>
+</pc:chgInfo>
+</file>
+
+<file path=ppt/notesMasters/notesMaster1.xml><?xml version="1.0" encoding="utf-8"?>
+<p:notesMaster xmlns:a="http://schemas.openxmlformats.org/drawingml/2006/main" xmlns:r="http://schemas.openxmlformats.org/officeDocument/2006/relationships" xmlns:p="http://schemas.openxmlformats.org/presentationml/2006/main">
+  <p:cSld>
+    <p:bg>
+      <p:bgRef idx="1001">
+        <a:schemeClr val="bg1"/>
+      </p:bgRef>
+    </p:bg>
+    <p:spTree>
+      <p:nvGrpSpPr>
+        <p:cNvPr id="1" name=""/>
+        <p:cNvGrpSpPr/>
+        <p:nvPr/>
+      </p:nvGrpSpPr>
+      <p:grpSpPr>
+        <a:xfrm>
+          <a:off x="0" y="0"/>
+          <a:ext cx="0" cy="0"/>
+          <a:chOff x="0" y="0"/>
+          <a:chExt cx="0" cy="0"/>
+        </a:xfrm>
+      </p:grpSpPr>
+      <p:sp>
+        <p:nvSpPr>
+          <p:cNvPr id="2" name="Header Placeholder 1"/>
+          <p:cNvSpPr>
+            <a:spLocks noGrp="1"/>
+          </p:cNvSpPr>
+          <p:nvPr>
+            <p:ph type="hdr" sz="quarter"/>
+          </p:nvPr>
+        </p:nvSpPr>
+        <p:spPr>
+          <a:xfrm>
+            <a:off x="0" y="0"/>
+            <a:ext cx="2971800" cy="458788"/>
+          </a:xfrm>
+          <a:prstGeom prst="rect">
+            <a:avLst/>
+          </a:prstGeom>
+        </p:spPr>
+        <p:txBody>
+          <a:bodyPr vert="horz" lIns="91440" tIns="45720" rIns="91440" bIns="45720" rtlCol="0"/>
+          <a:lstStyle>
+            <a:lvl1pPr algn="l">
+              <a:defRPr sz="1200"/>
+            </a:lvl1pPr>
+          </a:lstStyle>
+          <a:p>
+            <a:endParaRPr lang="en-IN"/>
+          </a:p>
+        </p:txBody>
+      </p:sp>
+      <p:sp>
+        <p:nvSpPr>
+          <p:cNvPr id="3" name="Date Placeholder 2"/>
+          <p:cNvSpPr>
+            <a:spLocks noGrp="1"/>
+          </p:cNvSpPr>
+          <p:nvPr>
+            <p:ph type="dt" idx="1"/>
+          </p:nvPr>
+        </p:nvSpPr>
+        <p:spPr>
+          <a:xfrm>
+            <a:off x="3884613" y="0"/>
+            <a:ext cx="2971800" cy="458788"/>
+          </a:xfrm>
+          <a:prstGeom prst="rect">
+            <a:avLst/>
+          </a:prstGeom>
+        </p:spPr>
+        <p:txBody>
+          <a:bodyPr vert="horz" lIns="91440" tIns="45720" rIns="91440" bIns="45720" rtlCol="0"/>
+          <a:lstStyle>
+            <a:lvl1pPr algn="r">
+              <a:defRPr sz="1200"/>
+            </a:lvl1pPr>
+          </a:lstStyle>
+          <a:p>
+            <a:fld id="{05EBEF71-D543-4FDB-BA2A-ACF5AC80E615}" type="datetimeFigureOut">
+              <a:rPr lang="en-IN" smtClean="0"/>
+              <a:t>07-09-2026</a:t>
+            </a:fld>
+            <a:endParaRPr lang="en-IN"/>
+          </a:p>
+        </p:txBody>
+      </p:sp>
+      <p:sp>
+        <p:nvSpPr>
+          <p:cNvPr id="4" name="Slide Image Placeholder 3"/>
+          <p:cNvSpPr>
+            <a:spLocks noGrp="1" noRot="1" noChangeAspect="1"/>
+          </p:cNvSpPr>
+          <p:nvPr>
+            <p:ph type="sldImg" idx="2"/>
+          </p:nvPr>
+        </p:nvSpPr>
+        <p:spPr>
+          <a:xfrm>
+            <a:off x="685800" y="1143000"/>
+            <a:ext cx="5486400" cy="3086100"/>
+          </a:xfrm>
+          <a:prstGeom prst="rect">
+            <a:avLst/>
+          </a:prstGeom>
+          <a:noFill/>
+          <a:ln w="12700">
+            <a:solidFill>
+              <a:prstClr val="black"/>
+            </a:solidFill>
+          </a:ln>
+        </p:spPr>
+        <p:txBody>
+          <a:bodyPr vert="horz" lIns="91440" tIns="45720" rIns="91440" bIns="45720" rtlCol="0" anchor="ctr"/>
+          <a:lstStyle/>
+          <a:p>
+            <a:endParaRPr lang="en-IN"/>
+          </a:p>
+        </p:txBody>
+      </p:sp>
+      <p:sp>
+        <p:nvSpPr>
+          <p:cNvPr id="5" name="Notes Placeholder 4"/>
+          <p:cNvSpPr>
+            <a:spLocks noGrp="1"/>
+          </p:cNvSpPr>
+          <p:nvPr>
+            <p:ph type="body" sz="quarter" idx="3"/>
+          </p:nvPr>
+        </p:nvSpPr>
+        <p:spPr>
+          <a:xfrm>
+            <a:off x="685800" y="4400550"/>
+            <a:ext cx="5486400" cy="3600450"/>
+          </a:xfrm>
+          <a:prstGeom prst="rect">
+            <a:avLst/>
+          </a:prstGeom>
+        </p:spPr>
+        <p:txBody>
+          <a:bodyPr vert="horz" lIns="91440" tIns="45720" rIns="91440" bIns="45720" rtlCol="0"/>
+          <a:lstStyle/>
+          <a:p>
+            <a:pPr lvl="0"/>
+            <a:r>
+              <a:rPr lang="en-US"/>
+              <a:t>Click to edit Master text styles</a:t>
+            </a:r>
+          </a:p>
+          <a:p>
+            <a:pPr lvl="1"/>
+            <a:r>
+              <a:rPr lang="en-US"/>
+              <a:t>Second level</a:t>
+            </a:r>
+          </a:p>
+          <a:p>
+            <a:pPr lvl="2"/>
+            <a:r>
+              <a:rPr lang="en-US"/>
+              <a:t>Third level</a:t>
+            </a:r>
+          </a:p>
+          <a:p>
+            <a:pPr lvl="3"/>
+            <a:r>
+              <a:rPr lang="en-US"/>
+              <a:t>Fourth level</a:t>
+            </a:r>
+          </a:p>
+          <a:p>
+            <a:pPr lvl="4"/>
+            <a:r>
+              <a:rPr lang="en-US"/>
+              <a:t>Fifth level</a:t>
+            </a:r>
+            <a:endParaRPr lang="en-IN"/>
+          </a:p>
+        </p:txBody>
+      </p:sp>
+      <p:sp>
+        <p:nvSpPr>
+          <p:cNvPr id="6" name="Footer Placeholder 5"/>
+          <p:cNvSpPr>
+            <a:spLocks noGrp="1"/>
+          </p:cNvSpPr>
+          <p:nvPr>
+            <p:ph type="ftr" sz="quarter" idx="4"/>
+          </p:nvPr>
+        </p:nvSpPr>
+        <p:spPr>
+          <a:xfrm>
+            <a:off x="0" y="8685213"/>
+            <a:ext cx="2971800" cy="458787"/>
+          </a:xfrm>
+          <a:prstGeom prst="rect">
+            <a:avLst/>
+          </a:prstGeom>
+        </p:spPr>
+        <p:txBody>
+          <a:bodyPr vert="horz" lIns="91440" tIns="45720" rIns="91440" bIns="45720" rtlCol="0" anchor="b"/>
+          <a:lstStyle>
+            <a:lvl1pPr algn="l">
+              <a:defRPr sz="1200"/>
+            </a:lvl1pPr>
+          </a:lstStyle>
+          <a:p>
+            <a:endParaRPr lang="en-IN"/>
+          </a:p>
+        </p:txBody>
+      </p:sp>
+      <p:sp>
+        <p:nvSpPr>
+          <p:cNvPr id="7" name="Slide Number Placeholder 6"/>
+          <p:cNvSpPr>
+            <a:spLocks noGrp="1"/>
+          </p:cNvSpPr>
+          <p:nvPr>
+            <p:ph type="sldNum" sz="quarter" idx="5"/>
+          </p:nvPr>
+        </p:nvSpPr>
+        <p:spPr>
+          <a:xfrm>
+            <a:off x="3884613" y="8685213"/>
+            <a:ext cx="2971800" cy="458787"/>
+          </a:xfrm>
+          <a:prstGeom prst="rect">
+            <a:avLst/>
+          </a:prstGeom>
+        </p:spPr>
+        <p:txBody>
+          <a:bodyPr vert="horz" lIns="91440" tIns="45720" rIns="91440" bIns="45720" rtlCol="0" anchor="b"/>
+          <a:lstStyle>
+            <a:lvl1pPr algn="r">
+              <a:defRPr sz="1200"/>
+            </a:lvl1pPr>
+          </a:lstStyle>
+          <a:p>
+            <a:fld id="{30C6527B-8440-4E4C-B1CA-67F9B4A2EA14}" type="slidenum">
+              <a:rPr lang="en-IN" smtClean="0"/>
+              <a:t>‹#›</a:t>
+            </a:fld>
+            <a:endParaRPr lang="en-IN"/>
+          </a:p>
+        </p:txBody>
+      </p:sp>
+    </p:spTree>
+    <p:extLst>
+      <p:ext uri="{BB962C8B-B14F-4D97-AF65-F5344CB8AC3E}">
+        <p14:creationId xmlns:p14="http://schemas.microsoft.com/office/powerpoint/2010/main" val="3228589302"/>
+      </p:ext>
+    </p:extLst>
+  </p:cSld>
+  <p:clrMap bg1="lt1" tx1="dk1" bg2="lt2" tx2="dk2" accent1="accent1" accent2="accent2" accent3="accent3" accent4="accent4" accent5="accent5" accent6="accent6" hlink="hlink" folHlink="folHlink"/>
+  <p:notesStyle>
+    <a:lvl1pPr marL="0" algn="l" defTabSz="914400" rtl="0" eaLnBrk="1" latinLnBrk="0" hangingPunct="1">
+      <a:defRPr sz="1200" kern="1200">
+        <a:solidFill>
+          <a:schemeClr val="tx1"/>
+        </a:solidFill>
+        <a:latin typeface="+mn-lt"/>
+        <a:ea typeface="+mn-ea"/>
+        <a:cs typeface="+mn-cs"/>
+      </a:defRPr>
+    </a:lvl1pPr>
+    <a:lvl2pPr marL="457200" algn="l" defTabSz="914400" rtl="0" eaLnBrk="1" latinLnBrk="0" hangingPunct="1">
+      <a:defRPr sz="1200" kern="1200">
+        <a:solidFill>
+          <a:schemeClr val="tx1"/>
+        </a:solidFill>
+        <a:latin typeface="+mn-lt"/>
+        <a:ea typeface="+mn-ea"/>
+        <a:cs typeface="+mn-cs"/>
+      </a:defRPr>
+    </a:lvl2pPr>
+    <a:lvl3pPr marL="914400" algn="l" defTabSz="914400" rtl="0" eaLnBrk="1" latinLnBrk="0" hangingPunct="1">
+      <a:defRPr sz="1200" kern="1200">
+        <a:solidFill>
+          <a:schemeClr val="tx1"/>
+        </a:solidFill>
+        <a:latin typeface="+mn-lt"/>
+        <a:ea typeface="+mn-ea"/>
+        <a:cs typeface="+mn-cs"/>
+      </a:defRPr>
+    </a:lvl3pPr>
+    <a:lvl4pPr marL="1371600" algn="l" defTabSz="914400" rtl="0" eaLnBrk="1" latinLnBrk="0" hangingPunct="1">
+      <a:defRPr sz="1200" kern="1200">
+        <a:solidFill>
+          <a:schemeClr val="tx1"/>
+        </a:solidFill>
+        <a:latin typeface="+mn-lt"/>
+        <a:ea typeface="+mn-ea"/>
+        <a:cs typeface="+mn-cs"/>
+      </a:defRPr>
+    </a:lvl4pPr>
+    <a:lvl5pPr marL="1828800" algn="l" defTabSz="914400" rtl="0" eaLnBrk="1" latinLnBrk="0" hangingPunct="1">
+      <a:defRPr sz="1200" kern="1200">
+        <a:solidFill>
+          <a:schemeClr val="tx1"/>
+        </a:solidFill>
+        <a:latin typeface="+mn-lt"/>
+        <a:ea typeface="+mn-ea"/>
+        <a:cs typeface="+mn-cs"/>
+      </a:defRPr>
+    </a:lvl5pPr>
+    <a:lvl6pPr marL="2286000" algn="l" defTabSz="914400" rtl="0" eaLnBrk="1" latinLnBrk="0" hangingPunct="1">
+      <a:defRPr sz="1200" kern="1200">
+        <a:solidFill>
+          <a:schemeClr val="tx1"/>
+        </a:solidFill>
+        <a:latin typeface="+mn-lt"/>
+        <a:ea typeface="+mn-ea"/>
+        <a:cs typeface="+mn-cs"/>
+      </a:defRPr>
+    </a:lvl6pPr>
+    <a:lvl7pPr marL="2743200" algn="l" defTabSz="914400" rtl="0" eaLnBrk="1" latinLnBrk="0" hangingPunct="1">
+      <a:defRPr sz="1200" kern="1200">
+        <a:solidFill>
+          <a:schemeClr val="tx1"/>
+        </a:solidFill>
+        <a:latin typeface="+mn-lt"/>
+        <a:ea typeface="+mn-ea"/>
+        <a:cs typeface="+mn-cs"/>
+      </a:defRPr>
+    </a:lvl7pPr>
+    <a:lvl8pPr marL="3200400" algn="l" defTabSz="914400" rtl="0" eaLnBrk="1" latinLnBrk="0" hangingPunct="1">
+      <a:defRPr sz="1200" kern="1200">
+        <a:solidFill>
+          <a:schemeClr val="tx1"/>
+        </a:solidFill>
+        <a:latin typeface="+mn-lt"/>
+        <a:ea typeface="+mn-ea"/>
+        <a:cs typeface="+mn-cs"/>
+      </a:defRPr>
+    </a:lvl8pPr>
+    <a:lvl9pPr marL="3657600" algn="l" defTabSz="914400" rtl="0" eaLnBrk="1" latinLnBrk="0" hangingPunct="1">
+      <a:defRPr sz="1200" kern="1200">
+        <a:solidFill>
+          <a:schemeClr val="tx1"/>
+        </a:solidFill>
+        <a:latin typeface="+mn-lt"/>
+        <a:ea typeface="+mn-ea"/>
+        <a:cs typeface="+mn-cs"/>
+      </a:defRPr>
+    </a:lvl9pPr>
+  </p:notesStyle>
+</p:notesMaster>
+</file>
+
+<file path=ppt/notesSlides/notesSlide1.xml><?xml version="1.0" encoding="utf-8"?>
+<p:notes xmlns:a="http://schemas.openxmlformats.org/drawingml/2006/main" xmlns:r="http://schemas.openxmlformats.org/officeDocument/2006/relationships" xmlns:p="http://schemas.openxmlformats.org/presentationml/2006/main">
+  <p:cSld>
+    <p:spTree>
+      <p:nvGrpSpPr>
+        <p:cNvPr id="1" name=""/>
+        <p:cNvGrpSpPr/>
+        <p:nvPr/>
+      </p:nvGrpSpPr>
+      <p:grpSpPr>
+        <a:xfrm>
+          <a:off x="0" y="0"/>
+          <a:ext cx="0" cy="0"/>
+          <a:chOff x="0" y="0"/>
+          <a:chExt cx="0" cy="0"/>
+        </a:xfrm>
+      </p:grpSpPr>
+      <p:sp>
+        <p:nvSpPr>
+          <p:cNvPr id="2" name="Slide Image Placeholder 1"/>
+          <p:cNvSpPr>
+            <a:spLocks noGrp="1" noRot="1" noChangeAspect="1"/>
+          </p:cNvSpPr>
+          <p:nvPr>
+            <p:ph type="sldImg"/>
+          </p:nvPr>
+        </p:nvSpPr>
+        <p:spPr/>
+      </p:sp>
+      <p:sp>
+        <p:nvSpPr>
+          <p:cNvPr id="3" name="Notes Placeholder 2"/>
+          <p:cNvSpPr>
+            <a:spLocks noGrp="1"/>
+          </p:cNvSpPr>
+          <p:nvPr>
+            <p:ph type="body" idx="1"/>
+          </p:nvPr>
+        </p:nvSpPr>
+        <p:spPr/>
+        <p:txBody>
+          <a:bodyPr/>
+          <a:lstStyle/>
+          <a:p>
+            <a:endParaRPr lang="en-IN" dirty="0"/>
+          </a:p>
+        </p:txBody>
+      </p:sp>
+      <p:sp>
+        <p:nvSpPr>
+          <p:cNvPr id="4" name="Slide Number Placeholder 3"/>
+          <p:cNvSpPr>
+            <a:spLocks noGrp="1"/>
+          </p:cNvSpPr>
+          <p:nvPr>
+            <p:ph type="sldNum" sz="quarter" idx="5"/>
+          </p:nvPr>
+        </p:nvSpPr>
+        <p:spPr/>
+        <p:txBody>
+          <a:bodyPr/>
+          <a:lstStyle/>
+          <a:p>
+            <a:fld id="{30C6527B-8440-4E4C-B1CA-67F9B4A2EA14}" type="slidenum">
+              <a:rPr lang="en-IN" smtClean="0"/>
+              <a:t>6</a:t>
+            </a:fld>
+            <a:endParaRPr lang="en-IN"/>
+          </a:p>
+        </p:txBody>
+      </p:sp>
+    </p:spTree>
+    <p:extLst>
+      <p:ext uri="{BB962C8B-B14F-4D97-AF65-F5344CB8AC3E}">
+        <p14:creationId xmlns:p14="http://schemas.microsoft.com/office/powerpoint/2010/main" val="2584971811"/>
+      </p:ext>
+    </p:extLst>
+  </p:cSld>
+  <p:clrMapOvr>
+    <a:masterClrMapping/>
+  </p:clrMapOvr>
+</p:notes>
 </file>
 
 <file path=ppt/slideLayouts/slideLayout1.xml><?xml version="1.0" encoding="utf-8"?>
@@ -154,10 +660,9 @@
           <a:lstStyle/>
           <a:p>
             <a:r>
-              <a:rPr lang="en-US" smtClean="0"/>
+              <a:rPr lang="en-US"/>
               <a:t>Click to edit Master title style</a:t>
             </a:r>
-            <a:endParaRPr lang="en-US"/>
           </a:p>
         </p:txBody>
       </p:sp>
@@ -273,10 +778,9 @@
           </a:lstStyle>
           <a:p>
             <a:r>
-              <a:rPr lang="en-US" smtClean="0"/>
+              <a:rPr lang="en-US"/>
               <a:t>Click to edit Master subtitle style</a:t>
             </a:r>
-            <a:endParaRPr lang="en-US"/>
           </a:p>
         </p:txBody>
       </p:sp>
@@ -297,7 +801,7 @@
           <a:p>
             <a:fld id="{5BCAD085-E8A6-8845-BD4E-CB4CCA059FC4}" type="datetimeFigureOut">
               <a:rPr lang="en-US" smtClean="0"/>
-              <a:t>1/27/13</a:t>
+              <a:t>9/7/2026</a:t>
             </a:fld>
             <a:endParaRPr lang="en-US"/>
           </a:p>
@@ -391,10 +895,9 @@
           <a:lstStyle/>
           <a:p>
             <a:r>
-              <a:rPr lang="en-US" smtClean="0"/>
+              <a:rPr lang="en-US"/>
               <a:t>Click to edit Master title style</a:t>
             </a:r>
-            <a:endParaRPr lang="en-US"/>
           </a:p>
         </p:txBody>
       </p:sp>
@@ -415,38 +918,37 @@
           <a:p>
             <a:pPr lvl="0"/>
             <a:r>
-              <a:rPr lang="en-US" smtClean="0"/>
+              <a:rPr lang="en-US"/>
               <a:t>Click to edit Master text styles</a:t>
             </a:r>
           </a:p>
           <a:p>
             <a:pPr lvl="1"/>
             <a:r>
-              <a:rPr lang="en-US" smtClean="0"/>
+              <a:rPr lang="en-US"/>
               <a:t>Second level</a:t>
             </a:r>
           </a:p>
           <a:p>
             <a:pPr lvl="2"/>
             <a:r>
-              <a:rPr lang="en-US" smtClean="0"/>
+              <a:rPr lang="en-US"/>
               <a:t>Third level</a:t>
             </a:r>
           </a:p>
           <a:p>
             <a:pPr lvl="3"/>
             <a:r>
-              <a:rPr lang="en-US" smtClean="0"/>
+              <a:rPr lang="en-US"/>
               <a:t>Fourth level</a:t>
             </a:r>
           </a:p>
           <a:p>
             <a:pPr lvl="4"/>
             <a:r>
-              <a:rPr lang="en-US" smtClean="0"/>
+              <a:rPr lang="en-US"/>
               <a:t>Fifth level</a:t>
             </a:r>
-            <a:endParaRPr lang="en-US"/>
           </a:p>
         </p:txBody>
       </p:sp>
@@ -467,7 +969,7 @@
           <a:p>
             <a:fld id="{5BCAD085-E8A6-8845-BD4E-CB4CCA059FC4}" type="datetimeFigureOut">
               <a:rPr lang="en-US" smtClean="0"/>
-              <a:t>1/27/13</a:t>
+              <a:t>9/7/2026</a:t>
             </a:fld>
             <a:endParaRPr lang="en-US"/>
           </a:p>
@@ -566,10 +1068,9 @@
           <a:lstStyle/>
           <a:p>
             <a:r>
-              <a:rPr lang="en-US" smtClean="0"/>
+              <a:rPr lang="en-US"/>
               <a:t>Click to edit Master title style</a:t>
             </a:r>
-            <a:endParaRPr lang="en-US"/>
           </a:p>
         </p:txBody>
       </p:sp>
@@ -595,38 +1096,37 @@
           <a:p>
             <a:pPr lvl="0"/>
             <a:r>
-              <a:rPr lang="en-US" smtClean="0"/>
+              <a:rPr lang="en-US"/>
               <a:t>Click to edit Master text styles</a:t>
             </a:r>
           </a:p>
           <a:p>
             <a:pPr lvl="1"/>
             <a:r>
-              <a:rPr lang="en-US" smtClean="0"/>
+              <a:rPr lang="en-US"/>
               <a:t>Second level</a:t>
             </a:r>
           </a:p>
           <a:p>
             <a:pPr lvl="2"/>
             <a:r>
-              <a:rPr lang="en-US" smtClean="0"/>
+              <a:rPr lang="en-US"/>
               <a:t>Third level</a:t>
             </a:r>
           </a:p>
           <a:p>
             <a:pPr lvl="3"/>
             <a:r>
-              <a:rPr lang="en-US" smtClean="0"/>
+              <a:rPr lang="en-US"/>
               <a:t>Fourth level</a:t>
             </a:r>
           </a:p>
           <a:p>
             <a:pPr lvl="4"/>
             <a:r>
-              <a:rPr lang="en-US" smtClean="0"/>
+              <a:rPr lang="en-US"/>
               <a:t>Fifth level</a:t>
             </a:r>
-            <a:endParaRPr lang="en-US"/>
           </a:p>
         </p:txBody>
       </p:sp>
@@ -647,7 +1147,7 @@
           <a:p>
             <a:fld id="{5BCAD085-E8A6-8845-BD4E-CB4CCA059FC4}" type="datetimeFigureOut">
               <a:rPr lang="en-US" smtClean="0"/>
-              <a:t>1/27/13</a:t>
+              <a:t>9/7/2026</a:t>
             </a:fld>
             <a:endParaRPr lang="en-US"/>
           </a:p>
@@ -741,10 +1241,9 @@
           <a:lstStyle/>
           <a:p>
             <a:r>
-              <a:rPr lang="en-US" smtClean="0"/>
+              <a:rPr lang="en-US"/>
               <a:t>Click to edit Master title style</a:t>
             </a:r>
-            <a:endParaRPr lang="en-US"/>
           </a:p>
         </p:txBody>
       </p:sp>
@@ -765,38 +1264,37 @@
           <a:p>
             <a:pPr lvl="0"/>
             <a:r>
-              <a:rPr lang="en-US" smtClean="0"/>
+              <a:rPr lang="en-US"/>
               <a:t>Click to edit Master text styles</a:t>
             </a:r>
           </a:p>
           <a:p>
             <a:pPr lvl="1"/>
             <a:r>
-              <a:rPr lang="en-US" smtClean="0"/>
+              <a:rPr lang="en-US"/>
               <a:t>Second level</a:t>
             </a:r>
           </a:p>
           <a:p>
             <a:pPr lvl="2"/>
             <a:r>
-              <a:rPr lang="en-US" smtClean="0"/>
+              <a:rPr lang="en-US"/>
               <a:t>Third level</a:t>
             </a:r>
           </a:p>
           <a:p>
             <a:pPr lvl="3"/>
             <a:r>
-              <a:rPr lang="en-US" smtClean="0"/>
+              <a:rPr lang="en-US"/>
               <a:t>Fourth level</a:t>
             </a:r>
           </a:p>
           <a:p>
             <a:pPr lvl="4"/>
             <a:r>
-              <a:rPr lang="en-US" smtClean="0"/>
+              <a:rPr lang="en-US"/>
               <a:t>Fifth level</a:t>
             </a:r>
-            <a:endParaRPr lang="en-US"/>
           </a:p>
         </p:txBody>
       </p:sp>
@@ -817,7 +1315,7 @@
           <a:p>
             <a:fld id="{5BCAD085-E8A6-8845-BD4E-CB4CCA059FC4}" type="datetimeFigureOut">
               <a:rPr lang="en-US" smtClean="0"/>
-              <a:t>1/27/13</a:t>
+              <a:t>9/7/2026</a:t>
             </a:fld>
             <a:endParaRPr lang="en-US"/>
           </a:p>
@@ -920,10 +1418,9 @@
           </a:lstStyle>
           <a:p>
             <a:r>
-              <a:rPr lang="en-US" smtClean="0"/>
+              <a:rPr lang="en-US"/>
               <a:t>Click to edit Master title style</a:t>
             </a:r>
-            <a:endParaRPr lang="en-US"/>
           </a:p>
         </p:txBody>
       </p:sp>
@@ -1040,7 +1537,7 @@
           <a:p>
             <a:pPr lvl="0"/>
             <a:r>
-              <a:rPr lang="en-US" smtClean="0"/>
+              <a:rPr lang="en-US"/>
               <a:t>Click to edit Master text styles</a:t>
             </a:r>
           </a:p>
@@ -1063,7 +1560,7 @@
           <a:p>
             <a:fld id="{5BCAD085-E8A6-8845-BD4E-CB4CCA059FC4}" type="datetimeFigureOut">
               <a:rPr lang="en-US" smtClean="0"/>
-              <a:t>1/27/13</a:t>
+              <a:t>9/7/2026</a:t>
             </a:fld>
             <a:endParaRPr lang="en-US"/>
           </a:p>
@@ -1157,10 +1654,9 @@
           <a:lstStyle/>
           <a:p>
             <a:r>
-              <a:rPr lang="en-US" smtClean="0"/>
+              <a:rPr lang="en-US"/>
               <a:t>Click to edit Master title style</a:t>
             </a:r>
-            <a:endParaRPr lang="en-US"/>
           </a:p>
         </p:txBody>
       </p:sp>
@@ -1214,38 +1710,37 @@
           <a:p>
             <a:pPr lvl="0"/>
             <a:r>
-              <a:rPr lang="en-US" smtClean="0"/>
+              <a:rPr lang="en-US"/>
               <a:t>Click to edit Master text styles</a:t>
             </a:r>
           </a:p>
           <a:p>
             <a:pPr lvl="1"/>
             <a:r>
-              <a:rPr lang="en-US" smtClean="0"/>
+              <a:rPr lang="en-US"/>
               <a:t>Second level</a:t>
             </a:r>
           </a:p>
           <a:p>
             <a:pPr lvl="2"/>
             <a:r>
-              <a:rPr lang="en-US" smtClean="0"/>
+              <a:rPr lang="en-US"/>
               <a:t>Third level</a:t>
             </a:r>
           </a:p>
           <a:p>
             <a:pPr lvl="3"/>
             <a:r>
-              <a:rPr lang="en-US" smtClean="0"/>
+              <a:rPr lang="en-US"/>
               <a:t>Fourth level</a:t>
             </a:r>
           </a:p>
           <a:p>
             <a:pPr lvl="4"/>
             <a:r>
-              <a:rPr lang="en-US" smtClean="0"/>
+              <a:rPr lang="en-US"/>
               <a:t>Fifth level</a:t>
             </a:r>
-            <a:endParaRPr lang="en-US"/>
           </a:p>
         </p:txBody>
       </p:sp>
@@ -1299,38 +1794,37 @@
           <a:p>
             <a:pPr lvl="0"/>
             <a:r>
-              <a:rPr lang="en-US" smtClean="0"/>
+              <a:rPr lang="en-US"/>
               <a:t>Click to edit Master text styles</a:t>
             </a:r>
           </a:p>
           <a:p>
             <a:pPr lvl="1"/>
             <a:r>
-              <a:rPr lang="en-US" smtClean="0"/>
+              <a:rPr lang="en-US"/>
               <a:t>Second level</a:t>
             </a:r>
           </a:p>
           <a:p>
             <a:pPr lvl="2"/>
             <a:r>
-              <a:rPr lang="en-US" smtClean="0"/>
+              <a:rPr lang="en-US"/>
               <a:t>Third level</a:t>
             </a:r>
           </a:p>
           <a:p>
             <a:pPr lvl="3"/>
             <a:r>
-              <a:rPr lang="en-US" smtClean="0"/>
+              <a:rPr lang="en-US"/>
               <a:t>Fourth level</a:t>
             </a:r>
           </a:p>
           <a:p>
             <a:pPr lvl="4"/>
             <a:r>
-              <a:rPr lang="en-US" smtClean="0"/>
+              <a:rPr lang="en-US"/>
               <a:t>Fifth level</a:t>
             </a:r>
-            <a:endParaRPr lang="en-US"/>
           </a:p>
         </p:txBody>
       </p:sp>
@@ -1351,7 +1845,7 @@
           <a:p>
             <a:fld id="{5BCAD085-E8A6-8845-BD4E-CB4CCA059FC4}" type="datetimeFigureOut">
               <a:rPr lang="en-US" smtClean="0"/>
-              <a:t>1/27/13</a:t>
+              <a:t>9/7/2026</a:t>
             </a:fld>
             <a:endParaRPr lang="en-US"/>
           </a:p>
@@ -1449,10 +1943,9 @@
           </a:lstStyle>
           <a:p>
             <a:r>
-              <a:rPr lang="en-US" smtClean="0"/>
+              <a:rPr lang="en-US"/>
               <a:t>Click to edit Master title style</a:t>
             </a:r>
-            <a:endParaRPr lang="en-US"/>
           </a:p>
         </p:txBody>
       </p:sp>
@@ -1515,7 +2008,7 @@
           <a:p>
             <a:pPr lvl="0"/>
             <a:r>
-              <a:rPr lang="en-US" smtClean="0"/>
+              <a:rPr lang="en-US"/>
               <a:t>Click to edit Master text styles</a:t>
             </a:r>
           </a:p>
@@ -1571,38 +2064,37 @@
           <a:p>
             <a:pPr lvl="0"/>
             <a:r>
-              <a:rPr lang="en-US" smtClean="0"/>
+              <a:rPr lang="en-US"/>
               <a:t>Click to edit Master text styles</a:t>
             </a:r>
           </a:p>
           <a:p>
             <a:pPr lvl="1"/>
             <a:r>
-              <a:rPr lang="en-US" smtClean="0"/>
+              <a:rPr lang="en-US"/>
               <a:t>Second level</a:t>
             </a:r>
           </a:p>
           <a:p>
             <a:pPr lvl="2"/>
             <a:r>
-              <a:rPr lang="en-US" smtClean="0"/>
+              <a:rPr lang="en-US"/>
               <a:t>Third level</a:t>
             </a:r>
           </a:p>
           <a:p>
             <a:pPr lvl="3"/>
             <a:r>
-              <a:rPr lang="en-US" smtClean="0"/>
+              <a:rPr lang="en-US"/>
               <a:t>Fourth level</a:t>
             </a:r>
           </a:p>
           <a:p>
             <a:pPr lvl="4"/>
             <a:r>
-              <a:rPr lang="en-US" smtClean="0"/>
+              <a:rPr lang="en-US"/>
               <a:t>Fifth level</a:t>
             </a:r>
-            <a:endParaRPr lang="en-US"/>
           </a:p>
         </p:txBody>
       </p:sp>
@@ -1665,7 +2157,7 @@
           <a:p>
             <a:pPr lvl="0"/>
             <a:r>
-              <a:rPr lang="en-US" smtClean="0"/>
+              <a:rPr lang="en-US"/>
               <a:t>Click to edit Master text styles</a:t>
             </a:r>
           </a:p>
@@ -1721,38 +2213,37 @@
           <a:p>
             <a:pPr lvl="0"/>
             <a:r>
-              <a:rPr lang="en-US" smtClean="0"/>
+              <a:rPr lang="en-US"/>
               <a:t>Click to edit Master text styles</a:t>
             </a:r>
           </a:p>
           <a:p>
             <a:pPr lvl="1"/>
             <a:r>
-              <a:rPr lang="en-US" smtClean="0"/>
+              <a:rPr lang="en-US"/>
               <a:t>Second level</a:t>
             </a:r>
           </a:p>
           <a:p>
             <a:pPr lvl="2"/>
             <a:r>
-              <a:rPr lang="en-US" smtClean="0"/>
+              <a:rPr lang="en-US"/>
               <a:t>Third level</a:t>
             </a:r>
           </a:p>
           <a:p>
             <a:pPr lvl="3"/>
             <a:r>
-              <a:rPr lang="en-US" smtClean="0"/>
+              <a:rPr lang="en-US"/>
               <a:t>Fourth level</a:t>
             </a:r>
           </a:p>
           <a:p>
             <a:pPr lvl="4"/>
             <a:r>
-              <a:rPr lang="en-US" smtClean="0"/>
+              <a:rPr lang="en-US"/>
               <a:t>Fifth level</a:t>
             </a:r>
-            <a:endParaRPr lang="en-US"/>
           </a:p>
         </p:txBody>
       </p:sp>
@@ -1773,7 +2264,7 @@
           <a:p>
             <a:fld id="{5BCAD085-E8A6-8845-BD4E-CB4CCA059FC4}" type="datetimeFigureOut">
               <a:rPr lang="en-US" smtClean="0"/>
-              <a:t>1/27/13</a:t>
+              <a:t>9/7/2026</a:t>
             </a:fld>
             <a:endParaRPr lang="en-US"/>
           </a:p>
@@ -1867,10 +2358,9 @@
           <a:lstStyle/>
           <a:p>
             <a:r>
-              <a:rPr lang="en-US" smtClean="0"/>
+              <a:rPr lang="en-US"/>
               <a:t>Click to edit Master title style</a:t>
             </a:r>
-            <a:endParaRPr lang="en-US"/>
           </a:p>
         </p:txBody>
       </p:sp>
@@ -1891,7 +2381,7 @@
           <a:p>
             <a:fld id="{5BCAD085-E8A6-8845-BD4E-CB4CCA059FC4}" type="datetimeFigureOut">
               <a:rPr lang="en-US" smtClean="0"/>
-              <a:t>1/27/13</a:t>
+              <a:t>9/7/2026</a:t>
             </a:fld>
             <a:endParaRPr lang="en-US"/>
           </a:p>
@@ -1986,7 +2476,7 @@
           <a:p>
             <a:fld id="{5BCAD085-E8A6-8845-BD4E-CB4CCA059FC4}" type="datetimeFigureOut">
               <a:rPr lang="en-US" smtClean="0"/>
-              <a:t>1/27/13</a:t>
+              <a:t>9/7/2026</a:t>
             </a:fld>
             <a:endParaRPr lang="en-US"/>
           </a:p>
@@ -2089,10 +2579,9 @@
           </a:lstStyle>
           <a:p>
             <a:r>
-              <a:rPr lang="en-US" smtClean="0"/>
+              <a:rPr lang="en-US"/>
               <a:t>Click to edit Master title style</a:t>
             </a:r>
-            <a:endParaRPr lang="en-US"/>
           </a:p>
         </p:txBody>
       </p:sp>
@@ -2146,38 +2635,37 @@
           <a:p>
             <a:pPr lvl="0"/>
             <a:r>
-              <a:rPr lang="en-US" smtClean="0"/>
+              <a:rPr lang="en-US"/>
               <a:t>Click to edit Master text styles</a:t>
             </a:r>
           </a:p>
           <a:p>
             <a:pPr lvl="1"/>
             <a:r>
-              <a:rPr lang="en-US" smtClean="0"/>
+              <a:rPr lang="en-US"/>
               <a:t>Second level</a:t>
             </a:r>
           </a:p>
           <a:p>
             <a:pPr lvl="2"/>
             <a:r>
-              <a:rPr lang="en-US" smtClean="0"/>
+              <a:rPr lang="en-US"/>
               <a:t>Third level</a:t>
             </a:r>
           </a:p>
           <a:p>
             <a:pPr lvl="3"/>
             <a:r>
-              <a:rPr lang="en-US" smtClean="0"/>
+              <a:rPr lang="en-US"/>
               <a:t>Fourth level</a:t>
             </a:r>
           </a:p>
           <a:p>
             <a:pPr lvl="4"/>
             <a:r>
-              <a:rPr lang="en-US" smtClean="0"/>
+              <a:rPr lang="en-US"/>
               <a:t>Fifth level</a:t>
             </a:r>
-            <a:endParaRPr lang="en-US"/>
           </a:p>
         </p:txBody>
       </p:sp>
@@ -2240,7 +2728,7 @@
           <a:p>
             <a:pPr lvl="0"/>
             <a:r>
-              <a:rPr lang="en-US" smtClean="0"/>
+              <a:rPr lang="en-US"/>
               <a:t>Click to edit Master text styles</a:t>
             </a:r>
           </a:p>
@@ -2263,7 +2751,7 @@
           <a:p>
             <a:fld id="{5BCAD085-E8A6-8845-BD4E-CB4CCA059FC4}" type="datetimeFigureOut">
               <a:rPr lang="en-US" smtClean="0"/>
-              <a:t>1/27/13</a:t>
+              <a:t>9/7/2026</a:t>
             </a:fld>
             <a:endParaRPr lang="en-US"/>
           </a:p>
@@ -2366,10 +2854,9 @@
           </a:lstStyle>
           <a:p>
             <a:r>
-              <a:rPr lang="en-US" smtClean="0"/>
+              <a:rPr lang="en-US"/>
               <a:t>Click to edit Master title style</a:t>
             </a:r>
-            <a:endParaRPr lang="en-US"/>
           </a:p>
         </p:txBody>
       </p:sp>
@@ -2493,7 +2980,7 @@
           <a:p>
             <a:pPr lvl="0"/>
             <a:r>
-              <a:rPr lang="en-US" smtClean="0"/>
+              <a:rPr lang="en-US"/>
               <a:t>Click to edit Master text styles</a:t>
             </a:r>
           </a:p>
@@ -2516,7 +3003,7 @@
           <a:p>
             <a:fld id="{5BCAD085-E8A6-8845-BD4E-CB4CCA059FC4}" type="datetimeFigureOut">
               <a:rPr lang="en-US" smtClean="0"/>
-              <a:t>1/27/13</a:t>
+              <a:t>9/7/2026</a:t>
             </a:fld>
             <a:endParaRPr lang="en-US"/>
           </a:p>
@@ -2625,10 +3112,9 @@
           <a:lstStyle/>
           <a:p>
             <a:r>
-              <a:rPr lang="en-US" smtClean="0"/>
+              <a:rPr lang="en-US"/>
               <a:t>Click to edit Master title style</a:t>
             </a:r>
-            <a:endParaRPr lang="en-US"/>
           </a:p>
         </p:txBody>
       </p:sp>
@@ -2659,38 +3145,37 @@
           <a:p>
             <a:pPr lvl="0"/>
             <a:r>
-              <a:rPr lang="en-US" smtClean="0"/>
+              <a:rPr lang="en-US"/>
               <a:t>Click to edit Master text styles</a:t>
             </a:r>
           </a:p>
           <a:p>
             <a:pPr lvl="1"/>
             <a:r>
-              <a:rPr lang="en-US" smtClean="0"/>
+              <a:rPr lang="en-US"/>
               <a:t>Second level</a:t>
             </a:r>
           </a:p>
           <a:p>
             <a:pPr lvl="2"/>
             <a:r>
-              <a:rPr lang="en-US" smtClean="0"/>
+              <a:rPr lang="en-US"/>
               <a:t>Third level</a:t>
             </a:r>
           </a:p>
           <a:p>
             <a:pPr lvl="3"/>
             <a:r>
-              <a:rPr lang="en-US" smtClean="0"/>
+              <a:rPr lang="en-US"/>
               <a:t>Fourth level</a:t>
             </a:r>
           </a:p>
           <a:p>
             <a:pPr lvl="4"/>
             <a:r>
-              <a:rPr lang="en-US" smtClean="0"/>
+              <a:rPr lang="en-US"/>
               <a:t>Fifth level</a:t>
             </a:r>
-            <a:endParaRPr lang="en-US"/>
           </a:p>
         </p:txBody>
       </p:sp>
@@ -2729,7 +3214,7 @@
           <a:p>
             <a:fld id="{5BCAD085-E8A6-8845-BD4E-CB4CCA059FC4}" type="datetimeFigureOut">
               <a:rPr lang="en-US" smtClean="0"/>
-              <a:t>1/27/13</a:t>
+              <a:t>9/7/2026</a:t>
             </a:fld>
             <a:endParaRPr lang="en-US"/>
           </a:p>
@@ -3088,7 +3573,7 @@
 </file>
 
 <file path=ppt/slides/slide1.xml><?xml version="1.0" encoding="utf-8"?>
-<p:sld xmlns:a="http://schemas.openxmlformats.org/drawingml/2006/main" xmlns:p="http://schemas.openxmlformats.org/presentationml/2006/main" xmlns:r="http://schemas.openxmlformats.org/officeDocument/2006/relationships">
+<p:sld xmlns:a="http://schemas.openxmlformats.org/drawingml/2006/main" xmlns:r="http://schemas.openxmlformats.org/officeDocument/2006/relationships" xmlns:p="http://schemas.openxmlformats.org/presentationml/2006/main">
   <p:cSld>
     <p:bg>
       <p:bgPr>
@@ -3104,7 +3589,14 @@
         <p:cNvGrpSpPr/>
         <p:nvPr/>
       </p:nvGrpSpPr>
-      <p:grpSpPr/>
+      <p:grpSpPr>
+        <a:xfrm>
+          <a:off x="0" y="0"/>
+          <a:ext cx="0" cy="0"/>
+          <a:chOff x="0" y="0"/>
+          <a:chExt cx="0" cy="0"/>
+        </a:xfrm>
+      </p:grpSpPr>
       <p:sp>
         <p:nvSpPr>
           <p:cNvPr id="2" name="Rectangle 1"/>
@@ -3145,6 +3637,7 @@
           <a:lstStyle/>
           <a:p>
             <a:pPr algn="ctr"/>
+            <a:endParaRPr/>
           </a:p>
         </p:txBody>
       </p:sp>
@@ -3188,6 +3681,7 @@
           <a:lstStyle/>
           <a:p>
             <a:pPr algn="ctr"/>
+            <a:endParaRPr/>
           </a:p>
         </p:txBody>
       </p:sp>
@@ -3233,6 +3727,7 @@
           <a:lstStyle/>
           <a:p>
             <a:pPr algn="ctr"/>
+            <a:endParaRPr/>
           </a:p>
         </p:txBody>
       </p:sp>
@@ -3344,6 +3839,7 @@
           <a:lstStyle/>
           <a:p>
             <a:pPr algn="ctr"/>
+            <a:endParaRPr/>
           </a:p>
         </p:txBody>
       </p:sp>
@@ -3514,7 +4010,7 @@
 </file>
 
 <file path=ppt/slides/slide10.xml><?xml version="1.0" encoding="utf-8"?>
-<p:sld xmlns:a="http://schemas.openxmlformats.org/drawingml/2006/main" xmlns:p="http://schemas.openxmlformats.org/presentationml/2006/main" xmlns:r="http://schemas.openxmlformats.org/officeDocument/2006/relationships">
+<p:sld xmlns:a="http://schemas.openxmlformats.org/drawingml/2006/main" xmlns:r="http://schemas.openxmlformats.org/officeDocument/2006/relationships" xmlns:p="http://schemas.openxmlformats.org/presentationml/2006/main">
   <p:cSld>
     <p:bg>
       <p:bgPr>
@@ -3530,7 +4026,14 @@
         <p:cNvGrpSpPr/>
         <p:nvPr/>
       </p:nvGrpSpPr>
-      <p:grpSpPr/>
+      <p:grpSpPr>
+        <a:xfrm>
+          <a:off x="0" y="0"/>
+          <a:ext cx="0" cy="0"/>
+          <a:chOff x="0" y="0"/>
+          <a:chExt cx="0" cy="0"/>
+        </a:xfrm>
+      </p:grpSpPr>
       <p:sp>
         <p:nvSpPr>
           <p:cNvPr id="2" name="Rectangle 1"/>
@@ -3571,6 +4074,7 @@
           <a:lstStyle/>
           <a:p>
             <a:pPr algn="ctr"/>
+            <a:endParaRPr/>
           </a:p>
         </p:txBody>
       </p:sp>
@@ -3648,6 +4152,7 @@
           <a:lstStyle/>
           <a:p>
             <a:pPr algn="ctr"/>
+            <a:endParaRPr/>
           </a:p>
         </p:txBody>
       </p:sp>
@@ -3684,7 +4189,7 @@
 </file>
 
 <file path=ppt/slides/slide2.xml><?xml version="1.0" encoding="utf-8"?>
-<p:sld xmlns:a="http://schemas.openxmlformats.org/drawingml/2006/main" xmlns:p="http://schemas.openxmlformats.org/presentationml/2006/main" xmlns:r="http://schemas.openxmlformats.org/officeDocument/2006/relationships">
+<p:sld xmlns:a="http://schemas.openxmlformats.org/drawingml/2006/main" xmlns:r="http://schemas.openxmlformats.org/officeDocument/2006/relationships" xmlns:p="http://schemas.openxmlformats.org/presentationml/2006/main">
   <p:cSld>
     <p:bg>
       <p:bgPr>
@@ -3700,7 +4205,14 @@
         <p:cNvGrpSpPr/>
         <p:nvPr/>
       </p:nvGrpSpPr>
-      <p:grpSpPr/>
+      <p:grpSpPr>
+        <a:xfrm>
+          <a:off x="0" y="0"/>
+          <a:ext cx="0" cy="0"/>
+          <a:chOff x="0" y="0"/>
+          <a:chExt cx="0" cy="0"/>
+        </a:xfrm>
+      </p:grpSpPr>
       <p:sp>
         <p:nvSpPr>
           <p:cNvPr id="2" name="Rectangle 1"/>
@@ -3741,6 +4253,7 @@
           <a:lstStyle/>
           <a:p>
             <a:pPr algn="ctr"/>
+            <a:endParaRPr/>
           </a:p>
         </p:txBody>
       </p:sp>
@@ -3818,6 +4331,7 @@
           <a:lstStyle/>
           <a:p>
             <a:pPr algn="ctr"/>
+            <a:endParaRPr/>
           </a:p>
         </p:txBody>
       </p:sp>
@@ -3863,6 +4377,7 @@
           <a:lstStyle/>
           <a:p>
             <a:pPr algn="ctr"/>
+            <a:endParaRPr/>
           </a:p>
         </p:txBody>
       </p:sp>
@@ -3945,13 +4460,21 @@
           </a:p>
           <a:p>
             <a:pPr algn="l"/>
+            <a:endParaRPr sz="1300" b="0">
+              <a:solidFill>
+                <a:srgbClr val="B0C8E0"/>
+              </a:solidFill>
+            </a:endParaRPr>
+          </a:p>
+          <a:p>
+            <a:pPr algn="l"/>
             <a:r>
               <a:rPr sz="1300" b="0">
                 <a:solidFill>
                   <a:srgbClr val="B0C8E0"/>
                 </a:solidFill>
               </a:rPr>
-              <a:t/>
+              <a:t>* Standard Softmax requires floating-point exponentials</a:t>
             </a:r>
           </a:p>
           <a:p>
@@ -3962,8 +4485,16 @@
                   <a:srgbClr val="B0C8E0"/>
                 </a:solidFill>
               </a:rPr>
-              <a:t>* Standard Softmax requires floating-point exponentials</a:t>
-            </a:r>
+              <a:t>  — NOT natively supported on Cyclone IV FPGA</a:t>
+            </a:r>
+          </a:p>
+          <a:p>
+            <a:pPr algn="l"/>
+            <a:endParaRPr sz="1300" b="0">
+              <a:solidFill>
+                <a:srgbClr val="B0C8E0"/>
+              </a:solidFill>
+            </a:endParaRPr>
           </a:p>
           <a:p>
             <a:pPr algn="l"/>
@@ -3973,7 +4504,7 @@
                   <a:srgbClr val="B0C8E0"/>
                 </a:solidFill>
               </a:rPr>
-              <a:t>  — NOT natively supported on Cyclone IV FPGA</a:t>
+              <a:t>* Conventional workaround = Fixed-Point Detour:</a:t>
             </a:r>
           </a:p>
           <a:p>
@@ -3984,7 +4515,7 @@
                   <a:srgbClr val="B0C8E0"/>
                 </a:solidFill>
               </a:rPr>
-              <a:t/>
+              <a:t>  INT8 Scores -&gt; Descale -&gt; 256-entry Exp LUT</a:t>
             </a:r>
           </a:p>
           <a:p>
@@ -3995,41 +4526,16 @@
                   <a:srgbClr val="B0C8E0"/>
                 </a:solidFill>
               </a:rPr>
-              <a:t>* Conventional workaround = Fixed-Point Detour:</a:t>
-            </a:r>
-          </a:p>
-          <a:p>
-            <a:pPr algn="l"/>
-            <a:r>
-              <a:rPr sz="1300" b="0">
-                <a:solidFill>
-                  <a:srgbClr val="B0C8E0"/>
-                </a:solidFill>
-              </a:rPr>
-              <a:t>  INT8 Scores -&gt; Descale -&gt; 256-entry Exp LUT</a:t>
-            </a:r>
-          </a:p>
-          <a:p>
-            <a:pPr algn="l"/>
-            <a:r>
-              <a:rPr sz="1300" b="0">
-                <a:solidFill>
-                  <a:srgbClr val="B0C8E0"/>
-                </a:solidFill>
-              </a:rPr>
               <a:t>  -&gt; Sum -&gt; Divide -&gt; Requantize -&gt; INT8 Output</a:t>
             </a:r>
           </a:p>
           <a:p>
             <a:pPr algn="l"/>
-            <a:r>
-              <a:rPr sz="1300" b="0">
-                <a:solidFill>
-                  <a:srgbClr val="B0C8E0"/>
-                </a:solidFill>
-              </a:rPr>
-              <a:t/>
-            </a:r>
+            <a:endParaRPr sz="1300" b="0">
+              <a:solidFill>
+                <a:srgbClr val="B0C8E0"/>
+              </a:solidFill>
+            </a:endParaRPr>
           </a:p>
           <a:p>
             <a:pPr algn="l"/>
@@ -4119,6 +4625,7 @@
           <a:lstStyle/>
           <a:p>
             <a:pPr algn="ctr"/>
+            <a:endParaRPr/>
           </a:p>
         </p:txBody>
       </p:sp>
@@ -4276,6 +4783,7 @@
           <a:lstStyle/>
           <a:p>
             <a:pPr algn="ctr"/>
+            <a:endParaRPr/>
           </a:p>
         </p:txBody>
       </p:sp>
@@ -4422,7 +4930,7 @@
 </file>
 
 <file path=ppt/slides/slide3.xml><?xml version="1.0" encoding="utf-8"?>
-<p:sld xmlns:a="http://schemas.openxmlformats.org/drawingml/2006/main" xmlns:p="http://schemas.openxmlformats.org/presentationml/2006/main" xmlns:r="http://schemas.openxmlformats.org/officeDocument/2006/relationships">
+<p:sld xmlns:a="http://schemas.openxmlformats.org/drawingml/2006/main" xmlns:r="http://schemas.openxmlformats.org/officeDocument/2006/relationships" xmlns:p="http://schemas.openxmlformats.org/presentationml/2006/main">
   <p:cSld>
     <p:bg>
       <p:bgPr>
@@ -4438,7 +4946,14 @@
         <p:cNvGrpSpPr/>
         <p:nvPr/>
       </p:nvGrpSpPr>
-      <p:grpSpPr/>
+      <p:grpSpPr>
+        <a:xfrm>
+          <a:off x="0" y="0"/>
+          <a:ext cx="0" cy="0"/>
+          <a:chOff x="0" y="0"/>
+          <a:chExt cx="0" cy="0"/>
+        </a:xfrm>
+      </p:grpSpPr>
       <p:sp>
         <p:nvSpPr>
           <p:cNvPr id="2" name="Rectangle 1"/>
@@ -4479,6 +4994,7 @@
           <a:lstStyle/>
           <a:p>
             <a:pPr algn="ctr"/>
+            <a:endParaRPr/>
           </a:p>
         </p:txBody>
       </p:sp>
@@ -4556,6 +5072,7 @@
           <a:lstStyle/>
           <a:p>
             <a:pPr algn="ctr"/>
+            <a:endParaRPr/>
           </a:p>
         </p:txBody>
       </p:sp>
@@ -4601,6 +5118,7 @@
           <a:lstStyle/>
           <a:p>
             <a:pPr algn="ctr"/>
+            <a:endParaRPr/>
           </a:p>
         </p:txBody>
       </p:sp>
@@ -4716,6 +5234,7 @@
           <a:lstStyle/>
           <a:p>
             <a:pPr algn="ctr"/>
+            <a:endParaRPr/>
           </a:p>
         </p:txBody>
       </p:sp>
@@ -4831,6 +5350,7 @@
           <a:lstStyle/>
           <a:p>
             <a:pPr algn="ctr"/>
+            <a:endParaRPr/>
           </a:p>
         </p:txBody>
       </p:sp>
@@ -4946,6 +5466,7 @@
           <a:lstStyle/>
           <a:p>
             <a:pPr algn="ctr"/>
+            <a:endParaRPr/>
           </a:p>
         </p:txBody>
       </p:sp>
@@ -5061,6 +5582,7 @@
           <a:lstStyle/>
           <a:p>
             <a:pPr algn="ctr"/>
+            <a:endParaRPr/>
           </a:p>
         </p:txBody>
       </p:sp>
@@ -5176,6 +5698,7 @@
           <a:lstStyle/>
           <a:p>
             <a:pPr algn="ctr"/>
+            <a:endParaRPr/>
           </a:p>
         </p:txBody>
       </p:sp>
@@ -5291,6 +5814,7 @@
           <a:lstStyle/>
           <a:p>
             <a:pPr algn="ctr"/>
+            <a:endParaRPr/>
           </a:p>
         </p:txBody>
       </p:sp>
@@ -5406,6 +5930,7 @@
           <a:lstStyle/>
           <a:p>
             <a:pPr algn="ctr"/>
+            <a:endParaRPr/>
           </a:p>
         </p:txBody>
       </p:sp>
@@ -5521,6 +6046,7 @@
           <a:lstStyle/>
           <a:p>
             <a:pPr algn="ctr"/>
+            <a:endParaRPr/>
           </a:p>
         </p:txBody>
       </p:sp>
@@ -5625,14 +6151,11 @@
           </a:p>
           <a:p>
             <a:pPr algn="l"/>
-            <a:r>
-              <a:rPr sz="1200" b="0">
-                <a:solidFill>
-                  <a:srgbClr val="B0C8E0"/>
-                </a:solidFill>
-              </a:rPr>
-              <a:t/>
-            </a:r>
+            <a:endParaRPr sz="1200" b="0">
+              <a:solidFill>
+                <a:srgbClr val="B0C8E0"/>
+              </a:solidFill>
+            </a:endParaRPr>
           </a:p>
           <a:p>
             <a:pPr algn="l"/>
@@ -5744,6 +6267,7 @@
           <a:lstStyle/>
           <a:p>
             <a:pPr algn="ctr"/>
+            <a:endParaRPr/>
           </a:p>
         </p:txBody>
       </p:sp>
@@ -5956,6 +6480,7 @@
           <a:lstStyle/>
           <a:p>
             <a:pPr algn="ctr"/>
+            <a:endParaRPr/>
           </a:p>
         </p:txBody>
       </p:sp>
@@ -6071,14 +6596,11 @@
           </a:p>
           <a:p>
             <a:pPr algn="l"/>
-            <a:r>
-              <a:rPr sz="1200" b="0">
-                <a:solidFill>
-                  <a:srgbClr val="B0C8E0"/>
-                </a:solidFill>
-              </a:rPr>
-              <a:t/>
-            </a:r>
+            <a:endParaRPr sz="1200" b="0">
+              <a:solidFill>
+                <a:srgbClr val="B0C8E0"/>
+              </a:solidFill>
+            </a:endParaRPr>
           </a:p>
           <a:p>
             <a:pPr algn="l"/>
@@ -6135,7 +6657,7 @@
 </file>
 
 <file path=ppt/slides/slide4.xml><?xml version="1.0" encoding="utf-8"?>
-<p:sld xmlns:a="http://schemas.openxmlformats.org/drawingml/2006/main" xmlns:p="http://schemas.openxmlformats.org/presentationml/2006/main" xmlns:r="http://schemas.openxmlformats.org/officeDocument/2006/relationships">
+<p:sld xmlns:a="http://schemas.openxmlformats.org/drawingml/2006/main" xmlns:r="http://schemas.openxmlformats.org/officeDocument/2006/relationships" xmlns:p="http://schemas.openxmlformats.org/presentationml/2006/main">
   <p:cSld>
     <p:bg>
       <p:bgPr>
@@ -6151,7 +6673,14 @@
         <p:cNvGrpSpPr/>
         <p:nvPr/>
       </p:nvGrpSpPr>
-      <p:grpSpPr/>
+      <p:grpSpPr>
+        <a:xfrm>
+          <a:off x="0" y="0"/>
+          <a:ext cx="0" cy="0"/>
+          <a:chOff x="0" y="0"/>
+          <a:chExt cx="0" cy="0"/>
+        </a:xfrm>
+      </p:grpSpPr>
       <p:sp>
         <p:nvSpPr>
           <p:cNvPr id="2" name="Rectangle 1"/>
@@ -6192,6 +6721,7 @@
           <a:lstStyle/>
           <a:p>
             <a:pPr algn="ctr"/>
+            <a:endParaRPr/>
           </a:p>
         </p:txBody>
       </p:sp>
@@ -6269,6 +6799,7 @@
           <a:lstStyle/>
           <a:p>
             <a:pPr algn="ctr"/>
+            <a:endParaRPr/>
           </a:p>
         </p:txBody>
       </p:sp>
@@ -6314,6 +6845,7 @@
           <a:lstStyle/>
           <a:p>
             <a:pPr algn="ctr"/>
+            <a:endParaRPr/>
           </a:p>
         </p:txBody>
       </p:sp>
@@ -6425,6 +6957,7 @@
           <a:lstStyle/>
           <a:p>
             <a:pPr algn="ctr"/>
+            <a:endParaRPr/>
           </a:p>
         </p:txBody>
       </p:sp>
@@ -6506,13 +7039,21 @@
           </a:p>
           <a:p>
             <a:pPr algn="l"/>
+            <a:endParaRPr sz="1250" b="0">
+              <a:solidFill>
+                <a:srgbClr val="B0C8E0"/>
+              </a:solidFill>
+            </a:endParaRPr>
+          </a:p>
+          <a:p>
+            <a:pPr algn="l"/>
             <a:r>
               <a:rPr sz="1250" b="0">
                 <a:solidFill>
-                  <a:srgbClr val="B0C8E0"/>
-                </a:solidFill>
-              </a:rPr>
-              <a:t/>
+                  <a:srgbClr val="FF355E"/>
+                </a:solidFill>
+              </a:rPr>
+              <a:t>Softmax Cycles:  2,008</a:t>
             </a:r>
           </a:p>
           <a:p>
@@ -6523,7 +7064,7 @@
                   <a:srgbClr val="FF355E"/>
                 </a:solidFill>
               </a:rPr>
-              <a:t>Softmax Cycles:  2,008</a:t>
+              <a:t>Total Cycles:    5,688</a:t>
             </a:r>
           </a:p>
           <a:p>
@@ -6534,30 +7075,16 @@
                   <a:srgbClr val="FF355E"/>
                 </a:solidFill>
               </a:rPr>
-              <a:t>Total Cycles:    5,688</a:t>
-            </a:r>
-          </a:p>
-          <a:p>
-            <a:pPr algn="l"/>
-            <a:r>
-              <a:rPr sz="1250" b="0">
-                <a:solidFill>
-                  <a:srgbClr val="FF355E"/>
-                </a:solidFill>
-              </a:rPr>
               <a:t>Latency @50MHz:  113.76 us</a:t>
             </a:r>
           </a:p>
           <a:p>
             <a:pPr algn="l"/>
-            <a:r>
-              <a:rPr sz="1250" b="0">
-                <a:solidFill>
-                  <a:srgbClr val="B0C8E0"/>
-                </a:solidFill>
-              </a:rPr>
-              <a:t/>
-            </a:r>
+            <a:endParaRPr sz="1250" b="0">
+              <a:solidFill>
+                <a:srgbClr val="FF355E"/>
+              </a:solidFill>
+            </a:endParaRPr>
           </a:p>
           <a:p>
             <a:pPr algn="l"/>
@@ -6647,6 +7174,7 @@
           <a:lstStyle/>
           <a:p>
             <a:pPr algn="ctr"/>
+            <a:endParaRPr/>
           </a:p>
         </p:txBody>
       </p:sp>
@@ -6758,6 +7286,7 @@
           <a:lstStyle/>
           <a:p>
             <a:pPr algn="ctr"/>
+            <a:endParaRPr/>
           </a:p>
         </p:txBody>
       </p:sp>
@@ -6839,13 +7368,21 @@
           </a:p>
           <a:p>
             <a:pPr algn="l"/>
+            <a:endParaRPr sz="1250" b="0">
+              <a:solidFill>
+                <a:srgbClr val="B0C8E0"/>
+              </a:solidFill>
+            </a:endParaRPr>
+          </a:p>
+          <a:p>
+            <a:pPr algn="l"/>
             <a:r>
               <a:rPr sz="1250" b="0">
                 <a:solidFill>
-                  <a:srgbClr val="B0C8E0"/>
-                </a:solidFill>
-              </a:rPr>
-              <a:t/>
+                  <a:srgbClr val="00E576"/>
+                </a:solidFill>
+              </a:rPr>
+              <a:t>Softmax Cycles:  1,880</a:t>
             </a:r>
           </a:p>
           <a:p>
@@ -6856,7 +7393,7 @@
                   <a:srgbClr val="00E576"/>
                 </a:solidFill>
               </a:rPr>
-              <a:t>Softmax Cycles:  1,880</a:t>
+              <a:t>Total Cycles:    5,560</a:t>
             </a:r>
           </a:p>
           <a:p>
@@ -6867,30 +7404,16 @@
                   <a:srgbClr val="00E576"/>
                 </a:solidFill>
               </a:rPr>
-              <a:t>Total Cycles:    5,560</a:t>
-            </a:r>
-          </a:p>
-          <a:p>
-            <a:pPr algn="l"/>
-            <a:r>
-              <a:rPr sz="1250" b="0">
-                <a:solidFill>
-                  <a:srgbClr val="00E576"/>
-                </a:solidFill>
-              </a:rPr>
               <a:t>Latency @50MHz:  111.20 us</a:t>
             </a:r>
           </a:p>
           <a:p>
             <a:pPr algn="l"/>
-            <a:r>
-              <a:rPr sz="1250" b="0">
-                <a:solidFill>
-                  <a:srgbClr val="B0C8E0"/>
-                </a:solidFill>
-              </a:rPr>
-              <a:t/>
-            </a:r>
+            <a:endParaRPr sz="1250" b="0">
+              <a:solidFill>
+                <a:srgbClr val="00E576"/>
+              </a:solidFill>
+            </a:endParaRPr>
           </a:p>
           <a:p>
             <a:pPr algn="l"/>
@@ -6980,6 +7503,7 @@
           <a:lstStyle/>
           <a:p>
             <a:pPr algn="ctr"/>
+            <a:endParaRPr/>
           </a:p>
         </p:txBody>
       </p:sp>
@@ -7091,6 +7615,7 @@
           <a:lstStyle/>
           <a:p>
             <a:pPr algn="ctr"/>
+            <a:endParaRPr/>
           </a:p>
         </p:txBody>
       </p:sp>
@@ -7172,13 +7697,21 @@
           </a:p>
           <a:p>
             <a:pPr algn="l"/>
+            <a:endParaRPr sz="1250" b="0">
+              <a:solidFill>
+                <a:srgbClr val="B0C8E0"/>
+              </a:solidFill>
+            </a:endParaRPr>
+          </a:p>
+          <a:p>
+            <a:pPr algn="l"/>
             <a:r>
               <a:rPr sz="1250" b="0">
                 <a:solidFill>
-                  <a:srgbClr val="B0C8E0"/>
-                </a:solidFill>
-              </a:rPr>
-              <a:t/>
+                  <a:srgbClr val="00D4FF"/>
+                </a:solidFill>
+              </a:rPr>
+              <a:t>Softmax Cycles:  1,880</a:t>
             </a:r>
           </a:p>
           <a:p>
@@ -7189,7 +7722,7 @@
                   <a:srgbClr val="00D4FF"/>
                 </a:solidFill>
               </a:rPr>
-              <a:t>Softmax Cycles:  1,880</a:t>
+              <a:t>Total Cycles:    5,560</a:t>
             </a:r>
           </a:p>
           <a:p>
@@ -7200,30 +7733,16 @@
                   <a:srgbClr val="00D4FF"/>
                 </a:solidFill>
               </a:rPr>
-              <a:t>Total Cycles:    5,560</a:t>
-            </a:r>
-          </a:p>
-          <a:p>
-            <a:pPr algn="l"/>
-            <a:r>
-              <a:rPr sz="1250" b="0">
-                <a:solidFill>
-                  <a:srgbClr val="00D4FF"/>
-                </a:solidFill>
-              </a:rPr>
               <a:t>Latency @50MHz:  111.20 us</a:t>
             </a:r>
           </a:p>
           <a:p>
             <a:pPr algn="l"/>
-            <a:r>
-              <a:rPr sz="1250" b="0">
-                <a:solidFill>
-                  <a:srgbClr val="B0C8E0"/>
-                </a:solidFill>
-              </a:rPr>
-              <a:t/>
-            </a:r>
+            <a:endParaRPr sz="1250" b="0">
+              <a:solidFill>
+                <a:srgbClr val="00D4FF"/>
+              </a:solidFill>
+            </a:endParaRPr>
           </a:p>
           <a:p>
             <a:pPr algn="l"/>
@@ -7280,7 +7799,7 @@
 </file>
 
 <file path=ppt/slides/slide5.xml><?xml version="1.0" encoding="utf-8"?>
-<p:sld xmlns:a="http://schemas.openxmlformats.org/drawingml/2006/main" xmlns:p="http://schemas.openxmlformats.org/presentationml/2006/main" xmlns:r="http://schemas.openxmlformats.org/officeDocument/2006/relationships">
+<p:sld xmlns:a="http://schemas.openxmlformats.org/drawingml/2006/main" xmlns:r="http://schemas.openxmlformats.org/officeDocument/2006/relationships" xmlns:p="http://schemas.openxmlformats.org/presentationml/2006/main">
   <p:cSld>
     <p:bg>
       <p:bgPr>
@@ -7296,7 +7815,14 @@
         <p:cNvGrpSpPr/>
         <p:nvPr/>
       </p:nvGrpSpPr>
-      <p:grpSpPr/>
+      <p:grpSpPr>
+        <a:xfrm>
+          <a:off x="0" y="0"/>
+          <a:ext cx="0" cy="0"/>
+          <a:chOff x="0" y="0"/>
+          <a:chExt cx="0" cy="0"/>
+        </a:xfrm>
+      </p:grpSpPr>
       <p:sp>
         <p:nvSpPr>
           <p:cNvPr id="2" name="Rectangle 1"/>
@@ -7337,6 +7863,7 @@
           <a:lstStyle/>
           <a:p>
             <a:pPr algn="ctr"/>
+            <a:endParaRPr/>
           </a:p>
         </p:txBody>
       </p:sp>
@@ -7414,6 +7941,7 @@
           <a:lstStyle/>
           <a:p>
             <a:pPr algn="ctr"/>
+            <a:endParaRPr/>
           </a:p>
         </p:txBody>
       </p:sp>
@@ -7459,6 +7987,7 @@
           <a:lstStyle/>
           <a:p>
             <a:pPr algn="ctr"/>
+            <a:endParaRPr/>
           </a:p>
         </p:txBody>
       </p:sp>
@@ -7536,6 +8065,7 @@
           <a:lstStyle/>
           <a:p>
             <a:pPr algn="ctr"/>
+            <a:endParaRPr/>
           </a:p>
         </p:txBody>
       </p:sp>
@@ -7749,6 +8279,7 @@
           <a:lstStyle/>
           <a:p>
             <a:pPr algn="ctr"/>
+            <a:endParaRPr/>
           </a:p>
         </p:txBody>
       </p:sp>
@@ -7962,6 +8493,7 @@
           <a:lstStyle/>
           <a:p>
             <a:pPr algn="ctr"/>
+            <a:endParaRPr/>
           </a:p>
         </p:txBody>
       </p:sp>
@@ -8175,6 +8707,7 @@
           <a:lstStyle/>
           <a:p>
             <a:pPr algn="ctr"/>
+            <a:endParaRPr/>
           </a:p>
         </p:txBody>
       </p:sp>
@@ -8422,6 +8955,7 @@
           <a:lstStyle/>
           <a:p>
             <a:pPr algn="ctr"/>
+            <a:endParaRPr/>
           </a:p>
         </p:txBody>
       </p:sp>
@@ -8465,6 +8999,7 @@
           <a:lstStyle/>
           <a:p>
             <a:pPr algn="ctr"/>
+            <a:endParaRPr/>
           </a:p>
         </p:txBody>
       </p:sp>
@@ -8678,6 +9213,7 @@
           <a:lstStyle/>
           <a:p>
             <a:pPr algn="ctr"/>
+            <a:endParaRPr/>
           </a:p>
         </p:txBody>
       </p:sp>
@@ -8891,6 +9427,7 @@
           <a:lstStyle/>
           <a:p>
             <a:pPr algn="ctr"/>
+            <a:endParaRPr/>
           </a:p>
         </p:txBody>
       </p:sp>
@@ -9104,6 +9641,7 @@
           <a:lstStyle/>
           <a:p>
             <a:pPr algn="ctr"/>
+            <a:endParaRPr/>
           </a:p>
         </p:txBody>
       </p:sp>
@@ -9320,7 +9858,7 @@
 </file>
 
 <file path=ppt/slides/slide6.xml><?xml version="1.0" encoding="utf-8"?>
-<p:sld xmlns:a="http://schemas.openxmlformats.org/drawingml/2006/main" xmlns:p="http://schemas.openxmlformats.org/presentationml/2006/main" xmlns:r="http://schemas.openxmlformats.org/officeDocument/2006/relationships">
+<p:sld xmlns:a="http://schemas.openxmlformats.org/drawingml/2006/main" xmlns:r="http://schemas.openxmlformats.org/officeDocument/2006/relationships" xmlns:p="http://schemas.openxmlformats.org/presentationml/2006/main">
   <p:cSld>
     <p:bg>
       <p:bgPr>
@@ -9336,7 +9874,14 @@
         <p:cNvGrpSpPr/>
         <p:nvPr/>
       </p:nvGrpSpPr>
-      <p:grpSpPr/>
+      <p:grpSpPr>
+        <a:xfrm>
+          <a:off x="0" y="0"/>
+          <a:ext cx="0" cy="0"/>
+          <a:chOff x="0" y="0"/>
+          <a:chExt cx="0" cy="0"/>
+        </a:xfrm>
+      </p:grpSpPr>
       <p:sp>
         <p:nvSpPr>
           <p:cNvPr id="2" name="Rectangle 1"/>
@@ -9377,6 +9922,7 @@
           <a:lstStyle/>
           <a:p>
             <a:pPr algn="ctr"/>
+            <a:endParaRPr/>
           </a:p>
         </p:txBody>
       </p:sp>
@@ -9454,6 +10000,7 @@
           <a:lstStyle/>
           <a:p>
             <a:pPr algn="ctr"/>
+            <a:endParaRPr/>
           </a:p>
         </p:txBody>
       </p:sp>
@@ -9499,6 +10046,7 @@
           <a:lstStyle/>
           <a:p>
             <a:pPr algn="ctr"/>
+            <a:endParaRPr/>
           </a:p>
         </p:txBody>
       </p:sp>
@@ -9576,6 +10124,7 @@
           <a:lstStyle/>
           <a:p>
             <a:pPr algn="ctr"/>
+            <a:endParaRPr/>
           </a:p>
         </p:txBody>
       </p:sp>
@@ -9655,7 +10204,7 @@
         </p:nvSpPr>
         <p:spPr>
           <a:xfrm>
-            <a:off x="4434840" y="1371600"/>
+            <a:off x="4046220" y="1362456"/>
             <a:ext cx="1280160" cy="274320"/>
           </a:xfrm>
           <a:prstGeom prst="rect">
@@ -9671,45 +10220,45 @@
           <a:p>
             <a:pPr algn="ctr"/>
             <a:r>
+              <a:rPr sz="1100" b="1" i="0" dirty="0">
+                <a:solidFill>
+                  <a:srgbClr val="FFFFFF"/>
+                </a:solidFill>
+              </a:rPr>
+              <a:t>HEX2</a:t>
+            </a:r>
+          </a:p>
+        </p:txBody>
+      </p:sp>
+      <p:sp>
+        <p:nvSpPr>
+          <p:cNvPr id="11" name="TextBox 10"/>
+          <p:cNvSpPr txBox="1"/>
+          <p:nvPr/>
+        </p:nvSpPr>
+        <p:spPr>
+          <a:xfrm>
+            <a:off x="5074920" y="1397454"/>
+            <a:ext cx="1280160" cy="274320"/>
+          </a:xfrm>
+          <a:prstGeom prst="rect">
+            <a:avLst/>
+          </a:prstGeom>
+          <a:noFill/>
+        </p:spPr>
+        <p:txBody>
+          <a:bodyPr wrap="square">
+            <a:spAutoFit/>
+          </a:bodyPr>
+          <a:lstStyle/>
+          <a:p>
+            <a:pPr algn="ctr"/>
+            <a:r>
               <a:rPr sz="1100" b="1" i="0">
                 <a:solidFill>
                   <a:srgbClr val="FFFFFF"/>
                 </a:solidFill>
               </a:rPr>
-              <a:t>HEX2</a:t>
-            </a:r>
-          </a:p>
-        </p:txBody>
-      </p:sp>
-      <p:sp>
-        <p:nvSpPr>
-          <p:cNvPr id="11" name="TextBox 10"/>
-          <p:cNvSpPr txBox="1"/>
-          <p:nvPr/>
-        </p:nvSpPr>
-        <p:spPr>
-          <a:xfrm>
-            <a:off x="5440680" y="1371600"/>
-            <a:ext cx="1280160" cy="274320"/>
-          </a:xfrm>
-          <a:prstGeom prst="rect">
-            <a:avLst/>
-          </a:prstGeom>
-          <a:noFill/>
-        </p:spPr>
-        <p:txBody>
-          <a:bodyPr wrap="square">
-            <a:spAutoFit/>
-          </a:bodyPr>
-          <a:lstStyle/>
-          <a:p>
-            <a:pPr algn="ctr"/>
-            <a:r>
-              <a:rPr sz="1100" b="1" i="0">
-                <a:solidFill>
-                  <a:srgbClr val="FFFFFF"/>
-                </a:solidFill>
-              </a:rPr>
               <a:t>HEX0</a:t>
             </a:r>
           </a:p>
@@ -9723,7 +10272,7 @@
         </p:nvSpPr>
         <p:spPr>
           <a:xfrm>
-            <a:off x="6126480" y="1371600"/>
+            <a:off x="5905763" y="1371600"/>
             <a:ext cx="1280160" cy="274320"/>
           </a:xfrm>
           <a:prstGeom prst="rect">
@@ -9789,6 +10338,7 @@
           <a:lstStyle/>
           <a:p>
             <a:pPr algn="ctr"/>
+            <a:endParaRPr/>
           </a:p>
         </p:txBody>
       </p:sp>
@@ -10002,6 +10552,7 @@
           <a:lstStyle/>
           <a:p>
             <a:pPr algn="ctr"/>
+            <a:endParaRPr/>
           </a:p>
         </p:txBody>
       </p:sp>
@@ -10215,6 +10766,7 @@
           <a:lstStyle/>
           <a:p>
             <a:pPr algn="ctr"/>
+            <a:endParaRPr/>
           </a:p>
         </p:txBody>
       </p:sp>
@@ -10428,6 +10980,7 @@
           <a:lstStyle/>
           <a:p>
             <a:pPr algn="ctr"/>
+            <a:endParaRPr/>
           </a:p>
         </p:txBody>
       </p:sp>
@@ -10641,6 +11194,7 @@
           <a:lstStyle/>
           <a:p>
             <a:pPr algn="ctr"/>
+            <a:endParaRPr/>
           </a:p>
         </p:txBody>
       </p:sp>
@@ -10854,6 +11408,7 @@
           <a:lstStyle/>
           <a:p>
             <a:pPr algn="ctr"/>
+            <a:endParaRPr/>
           </a:p>
         </p:txBody>
       </p:sp>
@@ -11103,6 +11658,7 @@
           <a:lstStyle/>
           <a:p>
             <a:pPr algn="ctr"/>
+            <a:endParaRPr/>
           </a:p>
         </p:txBody>
       </p:sp>
@@ -11249,6 +11805,7 @@
           <a:lstStyle/>
           <a:p>
             <a:pPr algn="ctr"/>
+            <a:endParaRPr/>
           </a:p>
         </p:txBody>
       </p:sp>
@@ -11320,13 +11877,21 @@
           </a:p>
           <a:p>
             <a:pPr algn="l"/>
+            <a:endParaRPr sz="1200" b="0">
+              <a:solidFill>
+                <a:srgbClr val="B0C8E0"/>
+              </a:solidFill>
+            </a:endParaRPr>
+          </a:p>
+          <a:p>
+            <a:pPr algn="l"/>
             <a:r>
               <a:rPr sz="1200" b="0">
                 <a:solidFill>
-                  <a:srgbClr val="B0C8E0"/>
-                </a:solidFill>
-              </a:rPr>
-              <a:t/>
+                  <a:srgbClr val="00E576"/>
+                </a:solidFill>
+              </a:rPr>
+              <a:t>SW1=D SW0=D -&gt; HEX1='0' Tier 0</a:t>
             </a:r>
           </a:p>
           <a:p>
@@ -11337,15 +11902,34 @@
                   <a:srgbClr val="00E576"/>
                 </a:solidFill>
               </a:rPr>
-              <a:t>SW1=D SW0=D -&gt; HEX1='0' Tier 0</a:t>
-            </a:r>
+              <a:t>  HEX7-4 shows: 1 5 b 8 (5560 cycles)</a:t>
+            </a:r>
+          </a:p>
+          <a:p>
+            <a:pPr algn="l"/>
+            <a:endParaRPr sz="1200" b="0">
+              <a:solidFill>
+                <a:srgbClr val="00E576"/>
+              </a:solidFill>
+            </a:endParaRPr>
           </a:p>
           <a:p>
             <a:pPr algn="l"/>
             <a:r>
               <a:rPr sz="1200" b="0">
                 <a:solidFill>
-                  <a:srgbClr val="00E576"/>
+                  <a:srgbClr val="00D4FF"/>
+                </a:solidFill>
+              </a:rPr>
+              <a:t>SW1=D SW0=U -&gt; HEX1='1' Tier 1</a:t>
+            </a:r>
+          </a:p>
+          <a:p>
+            <a:pPr algn="l"/>
+            <a:r>
+              <a:rPr sz="1200" b="0">
+                <a:solidFill>
+                  <a:srgbClr val="00D4FF"/>
                 </a:solidFill>
               </a:rPr>
               <a:t>  HEX7-4 shows: 1 5 b 8 (5560 cycles)</a:t>
@@ -11353,13 +11937,21 @@
           </a:p>
           <a:p>
             <a:pPr algn="l"/>
+            <a:endParaRPr sz="1200" b="0">
+              <a:solidFill>
+                <a:srgbClr val="00D4FF"/>
+              </a:solidFill>
+            </a:endParaRPr>
+          </a:p>
+          <a:p>
+            <a:pPr algn="l"/>
             <a:r>
               <a:rPr sz="1200" b="0">
                 <a:solidFill>
-                  <a:srgbClr val="B0C8E0"/>
-                </a:solidFill>
-              </a:rPr>
-              <a:t/>
+                  <a:srgbClr val="FF355E"/>
+                </a:solidFill>
+              </a:rPr>
+              <a:t>SW1=U SW0=D -&gt; HEX1='A' Version A</a:t>
             </a:r>
           </a:p>
           <a:p>
@@ -11367,66 +11959,19 @@
             <a:r>
               <a:rPr sz="1200" b="0">
                 <a:solidFill>
-                  <a:srgbClr val="00D4FF"/>
-                </a:solidFill>
-              </a:rPr>
-              <a:t>SW1=D SW0=U -&gt; HEX1='1' Tier 1</a:t>
-            </a:r>
-          </a:p>
-          <a:p>
-            <a:pPr algn="l"/>
-            <a:r>
-              <a:rPr sz="1200" b="0">
-                <a:solidFill>
-                  <a:srgbClr val="00D4FF"/>
-                </a:solidFill>
-              </a:rPr>
-              <a:t>  HEX7-4 shows: 1 5 b 8 (5560 cycles)</a:t>
-            </a:r>
-          </a:p>
-          <a:p>
-            <a:pPr algn="l"/>
-            <a:r>
-              <a:rPr sz="1200" b="0">
-                <a:solidFill>
-                  <a:srgbClr val="B0C8E0"/>
-                </a:solidFill>
-              </a:rPr>
-              <a:t/>
-            </a:r>
-          </a:p>
-          <a:p>
-            <a:pPr algn="l"/>
-            <a:r>
-              <a:rPr sz="1200" b="0">
-                <a:solidFill>
                   <a:srgbClr val="FF355E"/>
                 </a:solidFill>
               </a:rPr>
-              <a:t>SW1=U SW0=D -&gt; HEX1='A' Version A</a:t>
-            </a:r>
-          </a:p>
-          <a:p>
-            <a:pPr algn="l"/>
-            <a:r>
-              <a:rPr sz="1200" b="0">
-                <a:solidFill>
-                  <a:srgbClr val="FF355E"/>
-                </a:solidFill>
-              </a:rPr>
               <a:t>  HEX7-4 shows: 1 6 3 8 (5688 cycles)</a:t>
             </a:r>
           </a:p>
           <a:p>
             <a:pPr algn="l"/>
-            <a:r>
-              <a:rPr sz="1200" b="0">
-                <a:solidFill>
-                  <a:srgbClr val="B0C8E0"/>
-                </a:solidFill>
-              </a:rPr>
-              <a:t/>
-            </a:r>
+            <a:endParaRPr sz="1200" b="0">
+              <a:solidFill>
+                <a:srgbClr val="FF355E"/>
+              </a:solidFill>
+            </a:endParaRPr>
           </a:p>
           <a:p>
             <a:pPr algn="l"/>
@@ -11450,7 +11995,7 @@
 </file>
 
 <file path=ppt/slides/slide7.xml><?xml version="1.0" encoding="utf-8"?>
-<p:sld xmlns:a="http://schemas.openxmlformats.org/drawingml/2006/main" xmlns:p="http://schemas.openxmlformats.org/presentationml/2006/main" xmlns:r="http://schemas.openxmlformats.org/officeDocument/2006/relationships">
+<p:sld xmlns:a="http://schemas.openxmlformats.org/drawingml/2006/main" xmlns:r="http://schemas.openxmlformats.org/officeDocument/2006/relationships" xmlns:p="http://schemas.openxmlformats.org/presentationml/2006/main">
   <p:cSld>
     <p:bg>
       <p:bgPr>
@@ -11466,7 +12011,14 @@
         <p:cNvGrpSpPr/>
         <p:nvPr/>
       </p:nvGrpSpPr>
-      <p:grpSpPr/>
+      <p:grpSpPr>
+        <a:xfrm>
+          <a:off x="0" y="0"/>
+          <a:ext cx="0" cy="0"/>
+          <a:chOff x="0" y="0"/>
+          <a:chExt cx="0" cy="0"/>
+        </a:xfrm>
+      </p:grpSpPr>
       <p:sp>
         <p:nvSpPr>
           <p:cNvPr id="2" name="Rectangle 1"/>
@@ -11507,6 +12059,7 @@
           <a:lstStyle/>
           <a:p>
             <a:pPr algn="ctr"/>
+            <a:endParaRPr/>
           </a:p>
         </p:txBody>
       </p:sp>
@@ -11584,6 +12137,7 @@
           <a:lstStyle/>
           <a:p>
             <a:pPr algn="ctr"/>
+            <a:endParaRPr/>
           </a:p>
         </p:txBody>
       </p:sp>
@@ -11629,6 +12183,7 @@
           <a:lstStyle/>
           <a:p>
             <a:pPr algn="ctr"/>
+            <a:endParaRPr/>
           </a:p>
         </p:txBody>
       </p:sp>
@@ -11672,6 +12227,7 @@
           <a:lstStyle/>
           <a:p>
             <a:pPr algn="ctr"/>
+            <a:endParaRPr/>
           </a:p>
         </p:txBody>
       </p:sp>
@@ -11783,6 +12339,7 @@
           <a:lstStyle/>
           <a:p>
             <a:pPr algn="ctr"/>
+            <a:endParaRPr/>
           </a:p>
         </p:txBody>
       </p:sp>
@@ -11884,6 +12441,7 @@
           <a:lstStyle/>
           <a:p>
             <a:pPr algn="ctr"/>
+            <a:endParaRPr/>
           </a:p>
         </p:txBody>
       </p:sp>
@@ -11927,6 +12485,7 @@
           <a:lstStyle/>
           <a:p>
             <a:pPr algn="ctr"/>
+            <a:endParaRPr/>
           </a:p>
         </p:txBody>
       </p:sp>
@@ -12038,6 +12597,7 @@
           <a:lstStyle/>
           <a:p>
             <a:pPr algn="ctr"/>
+            <a:endParaRPr/>
           </a:p>
         </p:txBody>
       </p:sp>
@@ -12139,6 +12699,7 @@
           <a:lstStyle/>
           <a:p>
             <a:pPr algn="ctr"/>
+            <a:endParaRPr/>
           </a:p>
         </p:txBody>
       </p:sp>
@@ -12182,6 +12743,7 @@
           <a:lstStyle/>
           <a:p>
             <a:pPr algn="ctr"/>
+            <a:endParaRPr/>
           </a:p>
         </p:txBody>
       </p:sp>
@@ -12293,6 +12855,7 @@
           <a:lstStyle/>
           <a:p>
             <a:pPr algn="ctr"/>
+            <a:endParaRPr/>
           </a:p>
         </p:txBody>
       </p:sp>
@@ -12394,6 +12957,7 @@
           <a:lstStyle/>
           <a:p>
             <a:pPr algn="ctr"/>
+            <a:endParaRPr/>
           </a:p>
         </p:txBody>
       </p:sp>
@@ -12437,6 +13001,7 @@
           <a:lstStyle/>
           <a:p>
             <a:pPr algn="ctr"/>
+            <a:endParaRPr/>
           </a:p>
         </p:txBody>
       </p:sp>
@@ -12548,6 +13113,7 @@
           <a:lstStyle/>
           <a:p>
             <a:pPr algn="ctr"/>
+            <a:endParaRPr/>
           </a:p>
         </p:txBody>
       </p:sp>
@@ -12649,6 +13215,7 @@
           <a:lstStyle/>
           <a:p>
             <a:pPr algn="ctr"/>
+            <a:endParaRPr/>
           </a:p>
         </p:txBody>
       </p:sp>
@@ -12692,6 +13259,7 @@
           <a:lstStyle/>
           <a:p>
             <a:pPr algn="ctr"/>
+            <a:endParaRPr/>
           </a:p>
         </p:txBody>
       </p:sp>
@@ -12803,6 +13371,7 @@
           <a:lstStyle/>
           <a:p>
             <a:pPr algn="ctr"/>
+            <a:endParaRPr/>
           </a:p>
         </p:txBody>
       </p:sp>
@@ -12871,7 +13440,7 @@
 </file>
 
 <file path=ppt/slides/slide8.xml><?xml version="1.0" encoding="utf-8"?>
-<p:sld xmlns:a="http://schemas.openxmlformats.org/drawingml/2006/main" xmlns:p="http://schemas.openxmlformats.org/presentationml/2006/main" xmlns:r="http://schemas.openxmlformats.org/officeDocument/2006/relationships">
+<p:sld xmlns:a="http://schemas.openxmlformats.org/drawingml/2006/main" xmlns:r="http://schemas.openxmlformats.org/officeDocument/2006/relationships" xmlns:p="http://schemas.openxmlformats.org/presentationml/2006/main">
   <p:cSld>
     <p:bg>
       <p:bgPr>
@@ -12887,7 +13456,14 @@
         <p:cNvGrpSpPr/>
         <p:nvPr/>
       </p:nvGrpSpPr>
-      <p:grpSpPr/>
+      <p:grpSpPr>
+        <a:xfrm>
+          <a:off x="0" y="0"/>
+          <a:ext cx="0" cy="0"/>
+          <a:chOff x="0" y="0"/>
+          <a:chExt cx="0" cy="0"/>
+        </a:xfrm>
+      </p:grpSpPr>
       <p:sp>
         <p:nvSpPr>
           <p:cNvPr id="2" name="Rectangle 1"/>
@@ -12928,6 +13504,7 @@
           <a:lstStyle/>
           <a:p>
             <a:pPr algn="ctr"/>
+            <a:endParaRPr/>
           </a:p>
         </p:txBody>
       </p:sp>
@@ -12971,6 +13548,7 @@
           <a:lstStyle/>
           <a:p>
             <a:pPr algn="ctr"/>
+            <a:endParaRPr/>
           </a:p>
         </p:txBody>
       </p:sp>
@@ -13048,6 +13626,7 @@
           <a:lstStyle/>
           <a:p>
             <a:pPr algn="ctr"/>
+            <a:endParaRPr/>
           </a:p>
         </p:txBody>
       </p:sp>
@@ -13093,6 +13672,7 @@
           <a:lstStyle/>
           <a:p>
             <a:pPr algn="ctr"/>
+            <a:endParaRPr/>
           </a:p>
         </p:txBody>
       </p:sp>
@@ -13173,6 +13753,7 @@
           <a:lstStyle/>
           <a:p>
             <a:pPr algn="ctr"/>
+            <a:endParaRPr/>
           </a:p>
         </p:txBody>
       </p:sp>
@@ -13363,6 +13944,7 @@
           <a:lstStyle/>
           <a:p>
             <a:pPr algn="ctr"/>
+            <a:endParaRPr/>
           </a:p>
         </p:txBody>
       </p:sp>
@@ -13456,13 +14038,40 @@
           </a:p>
           <a:p>
             <a:pPr algn="l"/>
+            <a:endParaRPr sz="1200" b="0">
+              <a:solidFill>
+                <a:srgbClr val="B0C8E0"/>
+              </a:solidFill>
+            </a:endParaRPr>
+          </a:p>
+          <a:p>
+            <a:pPr algn="l"/>
             <a:r>
               <a:rPr sz="1200" b="0">
                 <a:solidFill>
+                  <a:srgbClr val="00D4FF"/>
+                </a:solidFill>
+              </a:rPr>
+              <a:t>Language:  Pure Verilog-2001</a:t>
+            </a:r>
+          </a:p>
+          <a:p>
+            <a:pPr algn="l"/>
+            <a:endParaRPr sz="1200" b="0">
+              <a:solidFill>
+                <a:srgbClr val="00D4FF"/>
+              </a:solidFill>
+            </a:endParaRPr>
+          </a:p>
+          <a:p>
+            <a:pPr algn="l"/>
+            <a:r>
+              <a:rPr sz="1200" b="0">
+                <a:solidFill>
                   <a:srgbClr val="B0C8E0"/>
                 </a:solidFill>
               </a:rPr>
-              <a:t/>
+              <a:t>Simulation:  ModelSim ASE 10.5b</a:t>
             </a:r>
           </a:p>
           <a:p>
@@ -13470,55 +14079,19 @@
             <a:r>
               <a:rPr sz="1200" b="0">
                 <a:solidFill>
-                  <a:srgbClr val="00D4FF"/>
-                </a:solidFill>
-              </a:rPr>
-              <a:t>Language:  Pure Verilog-2001</a:t>
-            </a:r>
-          </a:p>
-          <a:p>
-            <a:pPr algn="l"/>
-            <a:r>
-              <a:rPr sz="1200" b="0">
-                <a:solidFill>
                   <a:srgbClr val="B0C8E0"/>
                 </a:solidFill>
               </a:rPr>
-              <a:t/>
-            </a:r>
-          </a:p>
-          <a:p>
-            <a:pPr algn="l"/>
-            <a:r>
-              <a:rPr sz="1200" b="0">
-                <a:solidFill>
-                  <a:srgbClr val="B0C8E0"/>
-                </a:solidFill>
-              </a:rPr>
-              <a:t>Simulation:  ModelSim ASE 10.5b</a:t>
-            </a:r>
-          </a:p>
-          <a:p>
-            <a:pPr algn="l"/>
-            <a:r>
-              <a:rPr sz="1200" b="0">
-                <a:solidFill>
-                  <a:srgbClr val="B0C8E0"/>
-                </a:solidFill>
-              </a:rPr>
               <a:t>Synthesis:   Quartus Prime 18.1</a:t>
             </a:r>
           </a:p>
           <a:p>
             <a:pPr algn="l"/>
-            <a:r>
-              <a:rPr sz="1200" b="0">
-                <a:solidFill>
-                  <a:srgbClr val="B0C8E0"/>
-                </a:solidFill>
-              </a:rPr>
-              <a:t/>
-            </a:r>
+            <a:endParaRPr sz="1200" b="0">
+              <a:solidFill>
+                <a:srgbClr val="B0C8E0"/>
+              </a:solidFill>
+            </a:endParaRPr>
           </a:p>
           <a:p>
             <a:pPr algn="l"/>
@@ -13598,7 +14171,7 @@
 </file>
 
 <file path=ppt/slides/slide9.xml><?xml version="1.0" encoding="utf-8"?>
-<p:sld xmlns:a="http://schemas.openxmlformats.org/drawingml/2006/main" xmlns:p="http://schemas.openxmlformats.org/presentationml/2006/main" xmlns:r="http://schemas.openxmlformats.org/officeDocument/2006/relationships">
+<p:sld xmlns:a="http://schemas.openxmlformats.org/drawingml/2006/main" xmlns:r="http://schemas.openxmlformats.org/officeDocument/2006/relationships" xmlns:p="http://schemas.openxmlformats.org/presentationml/2006/main">
   <p:cSld>
     <p:bg>
       <p:bgPr>
@@ -13614,7 +14187,14 @@
         <p:cNvGrpSpPr/>
         <p:nvPr/>
       </p:nvGrpSpPr>
-      <p:grpSpPr/>
+      <p:grpSpPr>
+        <a:xfrm>
+          <a:off x="0" y="0"/>
+          <a:ext cx="0" cy="0"/>
+          <a:chOff x="0" y="0"/>
+          <a:chExt cx="0" cy="0"/>
+        </a:xfrm>
+      </p:grpSpPr>
       <p:sp>
         <p:nvSpPr>
           <p:cNvPr id="2" name="Rectangle 1"/>
@@ -13655,6 +14235,7 @@
           <a:lstStyle/>
           <a:p>
             <a:pPr algn="ctr"/>
+            <a:endParaRPr/>
           </a:p>
         </p:txBody>
       </p:sp>
@@ -13732,6 +14313,7 @@
           <a:lstStyle/>
           <a:p>
             <a:pPr algn="ctr"/>
+            <a:endParaRPr/>
           </a:p>
         </p:txBody>
       </p:sp>
@@ -13777,6 +14359,7 @@
           <a:lstStyle/>
           <a:p>
             <a:pPr algn="ctr"/>
+            <a:endParaRPr/>
           </a:p>
         </p:txBody>
       </p:sp>
@@ -13822,6 +14405,7 @@
           <a:lstStyle/>
           <a:p>
             <a:pPr algn="ctr"/>
+            <a:endParaRPr/>
           </a:p>
         </p:txBody>
       </p:sp>
@@ -14103,6 +14687,7 @@
           <a:lstStyle/>
           <a:p>
             <a:pPr algn="ctr"/>
+            <a:endParaRPr/>
           </a:p>
         </p:txBody>
       </p:sp>
@@ -14146,6 +14731,7 @@
           <a:lstStyle/>
           <a:p>
             <a:pPr algn="ctr"/>
+            <a:endParaRPr/>
           </a:p>
         </p:txBody>
       </p:sp>
@@ -14189,6 +14775,7 @@
           <a:lstStyle/>
           <a:p>
             <a:pPr algn="ctr"/>
+            <a:endParaRPr/>
           </a:p>
         </p:txBody>
       </p:sp>
@@ -14232,6 +14819,7 @@
           <a:lstStyle/>
           <a:p>
             <a:pPr algn="ctr"/>
+            <a:endParaRPr/>
           </a:p>
         </p:txBody>
       </p:sp>
@@ -14275,6 +14863,7 @@
           <a:lstStyle/>
           <a:p>
             <a:pPr algn="ctr"/>
+            <a:endParaRPr/>
           </a:p>
         </p:txBody>
       </p:sp>
@@ -14318,6 +14907,7 @@
           <a:lstStyle/>
           <a:p>
             <a:pPr algn="ctr"/>
+            <a:endParaRPr/>
           </a:p>
         </p:txBody>
       </p:sp>
@@ -14361,6 +14951,7 @@
           <a:lstStyle/>
           <a:p>
             <a:pPr algn="ctr"/>
+            <a:endParaRPr/>
           </a:p>
         </p:txBody>
       </p:sp>
@@ -14404,6 +14995,7 @@
           <a:lstStyle/>
           <a:p>
             <a:pPr algn="ctr"/>
+            <a:endParaRPr/>
           </a:p>
         </p:txBody>
       </p:sp>
@@ -14447,6 +15039,7 @@
           <a:lstStyle/>
           <a:p>
             <a:pPr algn="ctr"/>
+            <a:endParaRPr/>
           </a:p>
         </p:txBody>
       </p:sp>
@@ -14490,6 +15083,7 @@
           <a:lstStyle/>
           <a:p>
             <a:pPr algn="ctr"/>
+            <a:endParaRPr/>
           </a:p>
         </p:txBody>
       </p:sp>
@@ -14771,6 +15365,7 @@
           <a:lstStyle/>
           <a:p>
             <a:pPr algn="ctr"/>
+            <a:endParaRPr/>
           </a:p>
         </p:txBody>
       </p:sp>
@@ -14814,6 +15409,7 @@
           <a:lstStyle/>
           <a:p>
             <a:pPr algn="ctr"/>
+            <a:endParaRPr/>
           </a:p>
         </p:txBody>
       </p:sp>
@@ -15095,6 +15691,7 @@
           <a:lstStyle/>
           <a:p>
             <a:pPr algn="ctr"/>
+            <a:endParaRPr/>
           </a:p>
         </p:txBody>
       </p:sp>
@@ -15138,6 +15735,7 @@
           <a:lstStyle/>
           <a:p>
             <a:pPr algn="ctr"/>
+            <a:endParaRPr/>
           </a:p>
         </p:txBody>
       </p:sp>
@@ -15419,6 +16017,7 @@
           <a:lstStyle/>
           <a:p>
             <a:pPr algn="ctr"/>
+            <a:endParaRPr/>
           </a:p>
         </p:txBody>
       </p:sp>
@@ -15462,6 +16061,7 @@
           <a:lstStyle/>
           <a:p>
             <a:pPr algn="ctr"/>
+            <a:endParaRPr/>
           </a:p>
         </p:txBody>
       </p:sp>
@@ -15743,6 +16343,7 @@
           <a:lstStyle/>
           <a:p>
             <a:pPr algn="ctr"/>
+            <a:endParaRPr/>
           </a:p>
         </p:txBody>
       </p:sp>
@@ -15786,6 +16387,7 @@
           <a:lstStyle/>
           <a:p>
             <a:pPr algn="ctr"/>
+            <a:endParaRPr/>
           </a:p>
         </p:txBody>
       </p:sp>
@@ -16067,6 +16669,7 @@
           <a:lstStyle/>
           <a:p>
             <a:pPr algn="ctr"/>
+            <a:endParaRPr/>
           </a:p>
         </p:txBody>
       </p:sp>
@@ -16110,6 +16713,7 @@
           <a:lstStyle/>
           <a:p>
             <a:pPr algn="ctr"/>
+            <a:endParaRPr/>
           </a:p>
         </p:txBody>
       </p:sp>
@@ -16393,6 +16997,7 @@
           <a:lstStyle/>
           <a:p>
             <a:pPr algn="ctr"/>
+            <a:endParaRPr/>
           </a:p>
         </p:txBody>
       </p:sp>
@@ -16436,6 +17041,7 @@
           <a:lstStyle/>
           <a:p>
             <a:pPr algn="ctr"/>
+            <a:endParaRPr/>
           </a:p>
         </p:txBody>
       </p:sp>
@@ -16583,6 +17189,7 @@
           <a:lstStyle/>
           <a:p>
             <a:pPr algn="ctr"/>
+            <a:endParaRPr/>
           </a:p>
         </p:txBody>
       </p:sp>
@@ -16980,4 +17587,299 @@
   </a:objectDefaults>
   <a:extraClrSchemeLst/>
 </a:theme>
+</file>
+
+<file path=ppt/theme/theme2.xml><?xml version="1.0" encoding="utf-8"?>
+<a:theme xmlns:a="http://schemas.openxmlformats.org/drawingml/2006/main" name="Office Theme">
+  <a:themeElements>
+    <a:clrScheme name="Office">
+      <a:dk1>
+        <a:sysClr val="windowText" lastClr="000000"/>
+      </a:dk1>
+      <a:lt1>
+        <a:sysClr val="window" lastClr="FFFFFF"/>
+      </a:lt1>
+      <a:dk2>
+        <a:srgbClr val="44546A"/>
+      </a:dk2>
+      <a:lt2>
+        <a:srgbClr val="E7E6E6"/>
+      </a:lt2>
+      <a:accent1>
+        <a:srgbClr val="4472C4"/>
+      </a:accent1>
+      <a:accent2>
+        <a:srgbClr val="ED7D31"/>
+      </a:accent2>
+      <a:accent3>
+        <a:srgbClr val="A5A5A5"/>
+      </a:accent3>
+      <a:accent4>
+        <a:srgbClr val="FFC000"/>
+      </a:accent4>
+      <a:accent5>
+        <a:srgbClr val="5B9BD5"/>
+      </a:accent5>
+      <a:accent6>
+        <a:srgbClr val="70AD47"/>
+      </a:accent6>
+      <a:hlink>
+        <a:srgbClr val="0563C1"/>
+      </a:hlink>
+      <a:folHlink>
+        <a:srgbClr val="954F72"/>
+      </a:folHlink>
+    </a:clrScheme>
+    <a:fontScheme name="Office">
+      <a:majorFont>
+        <a:latin typeface="Calibri Light" panose="020F0302020204030204"/>
+        <a:ea typeface=""/>
+        <a:cs typeface=""/>
+        <a:font script="Jpan" typeface="游ゴシック Light"/>
+        <a:font script="Hang" typeface="맑은 고딕"/>
+        <a:font script="Hans" typeface="等线 Light"/>
+        <a:font script="Hant" typeface="新細明體"/>
+        <a:font script="Arab" typeface="Times New Roman"/>
+        <a:font script="Hebr" typeface="Times New Roman"/>
+        <a:font script="Thai" typeface="Angsana New"/>
+        <a:font script="Ethi" typeface="Nyala"/>
+        <a:font script="Beng" typeface="Vrinda"/>
+        <a:font script="Gujr" typeface="Shruti"/>
+        <a:font script="Khmr" typeface="MoolBoran"/>
+        <a:font script="Knda" typeface="Tunga"/>
+        <a:font script="Guru" typeface="Raavi"/>
+        <a:font script="Cans" typeface="Euphemia"/>
+        <a:font script="Cher" typeface="Plantagenet Cherokee"/>
+        <a:font script="Yiii" typeface="Microsoft Yi Baiti"/>
+        <a:font script="Tibt" typeface="Microsoft Himalaya"/>
+        <a:font script="Thaa" typeface="MV Boli"/>
+        <a:font script="Deva" typeface="Mangal"/>
+        <a:font script="Telu" typeface="Gautami"/>
+        <a:font script="Taml" typeface="Latha"/>
+        <a:font script="Syrc" typeface="Estrangelo Edessa"/>
+        <a:font script="Orya" typeface="Kalinga"/>
+        <a:font script="Mlym" typeface="Kartika"/>
+        <a:font script="Laoo" typeface="DokChampa"/>
+        <a:font script="Sinh" typeface="Iskoola Pota"/>
+        <a:font script="Mong" typeface="Mongolian Baiti"/>
+        <a:font script="Viet" typeface="Times New Roman"/>
+        <a:font script="Uigh" typeface="Microsoft Uighur"/>
+        <a:font script="Geor" typeface="Sylfaen"/>
+        <a:font script="Armn" typeface="Arial"/>
+        <a:font script="Bugi" typeface="Leelawadee UI"/>
+        <a:font script="Bopo" typeface="Microsoft JhengHei"/>
+        <a:font script="Java" typeface="Javanese Text"/>
+        <a:font script="Lisu" typeface="Segoe UI"/>
+        <a:font script="Mymr" typeface="Myanmar Text"/>
+        <a:font script="Nkoo" typeface="Ebrima"/>
+        <a:font script="Olck" typeface="Nirmala UI"/>
+        <a:font script="Osma" typeface="Ebrima"/>
+        <a:font script="Phag" typeface="Phagspa"/>
+        <a:font script="Syrn" typeface="Estrangelo Edessa"/>
+        <a:font script="Syrj" typeface="Estrangelo Edessa"/>
+        <a:font script="Syre" typeface="Estrangelo Edessa"/>
+        <a:font script="Sora" typeface="Nirmala UI"/>
+        <a:font script="Tale" typeface="Microsoft Tai Le"/>
+        <a:font script="Talu" typeface="Microsoft New Tai Lue"/>
+        <a:font script="Tfng" typeface="Ebrima"/>
+      </a:majorFont>
+      <a:minorFont>
+        <a:latin typeface="Calibri" panose="020F0502020204030204"/>
+        <a:ea typeface=""/>
+        <a:cs typeface=""/>
+        <a:font script="Jpan" typeface="游ゴシック"/>
+        <a:font script="Hang" typeface="맑은 고딕"/>
+        <a:font script="Hans" typeface="等线"/>
+        <a:font script="Hant" typeface="新細明體"/>
+        <a:font script="Arab" typeface="Arial"/>
+        <a:font script="Hebr" typeface="Arial"/>
+        <a:font script="Thai" typeface="Cordia New"/>
+        <a:font script="Ethi" typeface="Nyala"/>
+        <a:font script="Beng" typeface="Vrinda"/>
+        <a:font script="Gujr" typeface="Shruti"/>
+        <a:font script="Khmr" typeface="DaunPenh"/>
+        <a:font script="Knda" typeface="Tunga"/>
+        <a:font script="Guru" typeface="Raavi"/>
+        <a:font script="Cans" typeface="Euphemia"/>
+        <a:font script="Cher" typeface="Plantagenet Cherokee"/>
+        <a:font script="Yiii" typeface="Microsoft Yi Baiti"/>
+        <a:font script="Tibt" typeface="Microsoft Himalaya"/>
+        <a:font script="Thaa" typeface="MV Boli"/>
+        <a:font script="Deva" typeface="Mangal"/>
+        <a:font script="Telu" typeface="Gautami"/>
+        <a:font script="Taml" typeface="Latha"/>
+        <a:font script="Syrc" typeface="Estrangelo Edessa"/>
+        <a:font script="Orya" typeface="Kalinga"/>
+        <a:font script="Mlym" typeface="Kartika"/>
+        <a:font script="Laoo" typeface="DokChampa"/>
+        <a:font script="Sinh" typeface="Iskoola Pota"/>
+        <a:font script="Mong" typeface="Mongolian Baiti"/>
+        <a:font script="Viet" typeface="Arial"/>
+        <a:font script="Uigh" typeface="Microsoft Uighur"/>
+        <a:font script="Geor" typeface="Sylfaen"/>
+        <a:font script="Armn" typeface="Arial"/>
+        <a:font script="Bugi" typeface="Leelawadee UI"/>
+        <a:font script="Bopo" typeface="Microsoft JhengHei"/>
+        <a:font script="Java" typeface="Javanese Text"/>
+        <a:font script="Lisu" typeface="Segoe UI"/>
+        <a:font script="Mymr" typeface="Myanmar Text"/>
+        <a:font script="Nkoo" typeface="Ebrima"/>
+        <a:font script="Olck" typeface="Nirmala UI"/>
+        <a:font script="Osma" typeface="Ebrima"/>
+        <a:font script="Phag" typeface="Phagspa"/>
+        <a:font script="Syrn" typeface="Estrangelo Edessa"/>
+        <a:font script="Syrj" typeface="Estrangelo Edessa"/>
+        <a:font script="Syre" typeface="Estrangelo Edessa"/>
+        <a:font script="Sora" typeface="Nirmala UI"/>
+        <a:font script="Tale" typeface="Microsoft Tai Le"/>
+        <a:font script="Talu" typeface="Microsoft New Tai Lue"/>
+        <a:font script="Tfng" typeface="Ebrima"/>
+      </a:minorFont>
+    </a:fontScheme>
+    <a:fmtScheme name="Office">
+      <a:fillStyleLst>
+        <a:solidFill>
+          <a:schemeClr val="phClr"/>
+        </a:solidFill>
+        <a:gradFill rotWithShape="1">
+          <a:gsLst>
+            <a:gs pos="0">
+              <a:schemeClr val="phClr">
+                <a:lumMod val="110000"/>
+                <a:satMod val="105000"/>
+                <a:tint val="67000"/>
+              </a:schemeClr>
+            </a:gs>
+            <a:gs pos="50000">
+              <a:schemeClr val="phClr">
+                <a:lumMod val="105000"/>
+                <a:satMod val="103000"/>
+                <a:tint val="73000"/>
+              </a:schemeClr>
+            </a:gs>
+            <a:gs pos="100000">
+              <a:schemeClr val="phClr">
+                <a:lumMod val="105000"/>
+                <a:satMod val="109000"/>
+                <a:tint val="81000"/>
+              </a:schemeClr>
+            </a:gs>
+          </a:gsLst>
+          <a:lin ang="5400000" scaled="0"/>
+        </a:gradFill>
+        <a:gradFill rotWithShape="1">
+          <a:gsLst>
+            <a:gs pos="0">
+              <a:schemeClr val="phClr">
+                <a:satMod val="103000"/>
+                <a:lumMod val="102000"/>
+                <a:tint val="94000"/>
+              </a:schemeClr>
+            </a:gs>
+            <a:gs pos="50000">
+              <a:schemeClr val="phClr">
+                <a:satMod val="110000"/>
+                <a:lumMod val="100000"/>
+                <a:shade val="100000"/>
+              </a:schemeClr>
+            </a:gs>
+            <a:gs pos="100000">
+              <a:schemeClr val="phClr">
+                <a:lumMod val="99000"/>
+                <a:satMod val="120000"/>
+                <a:shade val="78000"/>
+              </a:schemeClr>
+            </a:gs>
+          </a:gsLst>
+          <a:lin ang="5400000" scaled="0"/>
+        </a:gradFill>
+      </a:fillStyleLst>
+      <a:lnStyleLst>
+        <a:ln w="6350" cap="flat" cmpd="sng" algn="ctr">
+          <a:solidFill>
+            <a:schemeClr val="phClr"/>
+          </a:solidFill>
+          <a:prstDash val="solid"/>
+          <a:miter lim="800000"/>
+        </a:ln>
+        <a:ln w="12700" cap="flat" cmpd="sng" algn="ctr">
+          <a:solidFill>
+            <a:schemeClr val="phClr"/>
+          </a:solidFill>
+          <a:prstDash val="solid"/>
+          <a:miter lim="800000"/>
+        </a:ln>
+        <a:ln w="19050" cap="flat" cmpd="sng" algn="ctr">
+          <a:solidFill>
+            <a:schemeClr val="phClr"/>
+          </a:solidFill>
+          <a:prstDash val="solid"/>
+          <a:miter lim="800000"/>
+        </a:ln>
+      </a:lnStyleLst>
+      <a:effectStyleLst>
+        <a:effectStyle>
+          <a:effectLst/>
+        </a:effectStyle>
+        <a:effectStyle>
+          <a:effectLst/>
+        </a:effectStyle>
+        <a:effectStyle>
+          <a:effectLst>
+            <a:outerShdw blurRad="57150" dist="19050" dir="5400000" algn="ctr" rotWithShape="0">
+              <a:srgbClr val="000000">
+                <a:alpha val="63000"/>
+              </a:srgbClr>
+            </a:outerShdw>
+          </a:effectLst>
+        </a:effectStyle>
+      </a:effectStyleLst>
+      <a:bgFillStyleLst>
+        <a:solidFill>
+          <a:schemeClr val="phClr"/>
+        </a:solidFill>
+        <a:solidFill>
+          <a:schemeClr val="phClr">
+            <a:tint val="95000"/>
+            <a:satMod val="170000"/>
+          </a:schemeClr>
+        </a:solidFill>
+        <a:gradFill rotWithShape="1">
+          <a:gsLst>
+            <a:gs pos="0">
+              <a:schemeClr val="phClr">
+                <a:tint val="93000"/>
+                <a:satMod val="150000"/>
+                <a:shade val="98000"/>
+                <a:lumMod val="102000"/>
+              </a:schemeClr>
+            </a:gs>
+            <a:gs pos="50000">
+              <a:schemeClr val="phClr">
+                <a:tint val="98000"/>
+                <a:satMod val="130000"/>
+                <a:shade val="90000"/>
+                <a:lumMod val="103000"/>
+              </a:schemeClr>
+            </a:gs>
+            <a:gs pos="100000">
+              <a:schemeClr val="phClr">
+                <a:shade val="63000"/>
+                <a:satMod val="120000"/>
+              </a:schemeClr>
+            </a:gs>
+          </a:gsLst>
+          <a:lin ang="5400000" scaled="0"/>
+        </a:gradFill>
+      </a:bgFillStyleLst>
+    </a:fmtScheme>
+  </a:themeElements>
+  <a:objectDefaults/>
+  <a:extraClrSchemeLst/>
+  <a:extLst>
+    <a:ext uri="{05A4C25C-085E-4340-85A3-A5531E510DB2}">
+      <thm15:themeFamily xmlns:thm15="http://schemas.microsoft.com/office/thememl/2012/main" name="Office Theme" id="{62F939B6-93AF-4DB8-9C6B-D6C7DFDC589F}" vid="{4A3C46E8-61CC-4603-A589-7422A47A8E4A}"/>
+    </a:ext>
+  </a:extLst>
+</a:theme>
 </file>
</xml_diff>

<commit_message>
feat(uart): add bidirectional UART telemetry, host benchmark suite, and complete project documentation
</commit_message>
<xml_diff>
--- a/docs/INT8_Transformer_FPGA_Presentation.pptx
+++ b/docs/INT8_Transformer_FPGA_Presentation.pptx
@@ -5,7 +5,7 @@
     <p:sldMasterId id="2147483648" r:id="rId1"/>
   </p:sldMasterIdLst>
   <p:notesMasterIdLst>
-    <p:notesMasterId r:id="rId12"/>
+    <p:notesMasterId r:id="rId13"/>
   </p:notesMasterIdLst>
   <p:sldIdLst>
     <p:sldId id="256" r:id="rId2"/>
@@ -18,6 +18,7 @@
     <p:sldId id="263" r:id="rId9"/>
     <p:sldId id="264" r:id="rId10"/>
     <p:sldId id="265" r:id="rId11"/>
+    <p:sldId id="266" r:id="rId12"/>
   </p:sldIdLst>
   <p:sldSz cx="12188825" cy="6858000"/>
   <p:notesSz cx="6858000" cy="9144000"/>
@@ -139,11 +140,34 @@
 <pc:chgInfo xmlns:a="http://schemas.openxmlformats.org/drawingml/2006/main" xmlns:r="http://schemas.openxmlformats.org/officeDocument/2006/relationships" xmlns:ac="http://schemas.microsoft.com/office/drawing/2013/main/command" xmlns:pc="http://schemas.microsoft.com/office/powerpoint/2013/main/command">
   <pc:docChgLst>
     <pc:chgData name="shailesh a" userId="43c82f3c7150fcad" providerId="LiveId" clId="{9E4A3FBD-179F-45D1-B6F9-47A518B5881E}"/>
-    <pc:docChg chg="undo custSel modSld">
-      <pc:chgData name="shailesh a" userId="43c82f3c7150fcad" providerId="LiveId" clId="{9E4A3FBD-179F-45D1-B6F9-47A518B5881E}" dt="2026-09-07T09:50:22.594" v="4" actId="1076"/>
+    <pc:docChg chg="undo custSel addSld modSld">
+      <pc:chgData name="shailesh a" userId="43c82f3c7150fcad" providerId="LiveId" clId="{9E4A3FBD-179F-45D1-B6F9-47A518B5881E}" dt="2026-09-07T10:02:29.459" v="19" actId="14100"/>
       <pc:docMkLst>
         <pc:docMk/>
       </pc:docMkLst>
+      <pc:sldChg chg="modSp mod">
+        <pc:chgData name="shailesh a" userId="43c82f3c7150fcad" providerId="LiveId" clId="{9E4A3FBD-179F-45D1-B6F9-47A518B5881E}" dt="2026-09-07T10:01:50.552" v="10" actId="1076"/>
+        <pc:sldMkLst>
+          <pc:docMk/>
+          <pc:sldMk cId="0" sldId="256"/>
+        </pc:sldMkLst>
+        <pc:spChg chg="mod">
+          <ac:chgData name="shailesh a" userId="43c82f3c7150fcad" providerId="LiveId" clId="{9E4A3FBD-179F-45D1-B6F9-47A518B5881E}" dt="2026-09-07T09:56:12.856" v="9" actId="20577"/>
+          <ac:spMkLst>
+            <pc:docMk/>
+            <pc:sldMk cId="0" sldId="256"/>
+            <ac:spMk id="6" creationId="{00000000-0000-0000-0000-000000000000}"/>
+          </ac:spMkLst>
+        </pc:spChg>
+        <pc:spChg chg="mod">
+          <ac:chgData name="shailesh a" userId="43c82f3c7150fcad" providerId="LiveId" clId="{9E4A3FBD-179F-45D1-B6F9-47A518B5881E}" dt="2026-09-07T10:01:50.552" v="10" actId="1076"/>
+          <ac:spMkLst>
+            <pc:docMk/>
+            <pc:sldMk cId="0" sldId="256"/>
+            <ac:spMk id="9" creationId="{00000000-0000-0000-0000-000000000000}"/>
+          </ac:spMkLst>
+        </pc:spChg>
+      </pc:sldChg>
       <pc:sldChg chg="modSp mod">
         <pc:chgData name="shailesh a" userId="43c82f3c7150fcad" providerId="LiveId" clId="{9E4A3FBD-179F-45D1-B6F9-47A518B5881E}" dt="2026-09-07T09:50:22.594" v="4" actId="1076"/>
         <pc:sldMkLst>
@@ -182,6 +206,21 @@
             <ac:spMk id="13" creationId="{00000000-0000-0000-0000-000000000000}"/>
           </ac:spMkLst>
         </pc:spChg>
+      </pc:sldChg>
+      <pc:sldChg chg="addSp modSp new mod">
+        <pc:chgData name="shailesh a" userId="43c82f3c7150fcad" providerId="LiveId" clId="{9E4A3FBD-179F-45D1-B6F9-47A518B5881E}" dt="2026-09-07T10:02:29.459" v="19" actId="14100"/>
+        <pc:sldMkLst>
+          <pc:docMk/>
+          <pc:sldMk cId="1705916494" sldId="266"/>
+        </pc:sldMkLst>
+        <pc:picChg chg="add mod">
+          <ac:chgData name="shailesh a" userId="43c82f3c7150fcad" providerId="LiveId" clId="{9E4A3FBD-179F-45D1-B6F9-47A518B5881E}" dt="2026-09-07T10:02:29.459" v="19" actId="14100"/>
+          <ac:picMkLst>
+            <pc:docMk/>
+            <pc:sldMk cId="1705916494" sldId="266"/>
+            <ac:picMk id="3" creationId="{A259FD4E-7CFB-C6C8-8C91-093A62BC13E1}"/>
+          </ac:picMkLst>
+        </pc:picChg>
       </pc:sldChg>
     </pc:docChg>
   </pc:docChgLst>
@@ -539,6 +578,90 @@
 </file>
 
 <file path=ppt/notesSlides/notesSlide1.xml><?xml version="1.0" encoding="utf-8"?>
+<p:notes xmlns:a="http://schemas.openxmlformats.org/drawingml/2006/main" xmlns:r="http://schemas.openxmlformats.org/officeDocument/2006/relationships" xmlns:p="http://schemas.openxmlformats.org/presentationml/2006/main">
+  <p:cSld>
+    <p:spTree>
+      <p:nvGrpSpPr>
+        <p:cNvPr id="1" name=""/>
+        <p:cNvGrpSpPr/>
+        <p:nvPr/>
+      </p:nvGrpSpPr>
+      <p:grpSpPr>
+        <a:xfrm>
+          <a:off x="0" y="0"/>
+          <a:ext cx="0" cy="0"/>
+          <a:chOff x="0" y="0"/>
+          <a:chExt cx="0" cy="0"/>
+        </a:xfrm>
+      </p:grpSpPr>
+      <p:sp>
+        <p:nvSpPr>
+          <p:cNvPr id="2" name="Slide Image Placeholder 1"/>
+          <p:cNvSpPr>
+            <a:spLocks noGrp="1" noRot="1" noChangeAspect="1"/>
+          </p:cNvSpPr>
+          <p:nvPr>
+            <p:ph type="sldImg"/>
+          </p:nvPr>
+        </p:nvSpPr>
+        <p:spPr/>
+      </p:sp>
+      <p:sp>
+        <p:nvSpPr>
+          <p:cNvPr id="3" name="Notes Placeholder 2"/>
+          <p:cNvSpPr>
+            <a:spLocks noGrp="1"/>
+          </p:cNvSpPr>
+          <p:nvPr>
+            <p:ph type="body" idx="1"/>
+          </p:nvPr>
+        </p:nvSpPr>
+        <p:spPr/>
+        <p:txBody>
+          <a:bodyPr/>
+          <a:lstStyle/>
+          <a:p>
+            <a:endParaRPr lang="en-IN" dirty="0"/>
+          </a:p>
+        </p:txBody>
+      </p:sp>
+      <p:sp>
+        <p:nvSpPr>
+          <p:cNvPr id="4" name="Slide Number Placeholder 3"/>
+          <p:cNvSpPr>
+            <a:spLocks noGrp="1"/>
+          </p:cNvSpPr>
+          <p:nvPr>
+            <p:ph type="sldNum" sz="quarter" idx="5"/>
+          </p:nvPr>
+        </p:nvSpPr>
+        <p:spPr/>
+        <p:txBody>
+          <a:bodyPr/>
+          <a:lstStyle/>
+          <a:p>
+            <a:fld id="{30C6527B-8440-4E4C-B1CA-67F9B4A2EA14}" type="slidenum">
+              <a:rPr lang="en-IN" smtClean="0"/>
+              <a:t>1</a:t>
+            </a:fld>
+            <a:endParaRPr lang="en-IN"/>
+          </a:p>
+        </p:txBody>
+      </p:sp>
+    </p:spTree>
+    <p:extLst>
+      <p:ext uri="{BB962C8B-B14F-4D97-AF65-F5344CB8AC3E}">
+        <p14:creationId xmlns:p14="http://schemas.microsoft.com/office/powerpoint/2010/main" val="3782245532"/>
+      </p:ext>
+    </p:extLst>
+  </p:cSld>
+  <p:clrMapOvr>
+    <a:masterClrMapping/>
+  </p:clrMapOvr>
+</p:notes>
+</file>
+
+<file path=ppt/notesSlides/notesSlide2.xml><?xml version="1.0" encoding="utf-8"?>
 <p:notes xmlns:a="http://schemas.openxmlformats.org/drawingml/2006/main" xmlns:r="http://schemas.openxmlformats.org/officeDocument/2006/relationships" xmlns:p="http://schemas.openxmlformats.org/presentationml/2006/main">
   <p:cSld>
     <p:spTree>
@@ -3774,28 +3897,33 @@
         <p:spPr>
           <a:xfrm>
             <a:off x="640080" y="2651760"/>
-            <a:ext cx="10881360" cy="502920"/>
-          </a:xfrm>
-          <a:prstGeom prst="rect">
-            <a:avLst/>
-          </a:prstGeom>
-          <a:noFill/>
-        </p:spPr>
-        <p:txBody>
-          <a:bodyPr wrap="square">
-            <a:spAutoFit/>
-          </a:bodyPr>
-          <a:lstStyle/>
-          <a:p>
-            <a:pPr algn="ctr"/>
-            <a:r>
-              <a:rPr sz="2000" b="0" i="0">
-                <a:solidFill>
-                  <a:srgbClr val="FFFFFF"/>
-                </a:solidFill>
-              </a:rPr>
-              <a:t>on Terasic DE2-115 FPGA  |  Cyclone IV EP4CE115F29C7</a:t>
-            </a:r>
+            <a:ext cx="10881360" cy="707886"/>
+          </a:xfrm>
+          <a:prstGeom prst="rect">
+            <a:avLst/>
+          </a:prstGeom>
+          <a:noFill/>
+        </p:spPr>
+        <p:txBody>
+          <a:bodyPr wrap="square">
+            <a:spAutoFit/>
+          </a:bodyPr>
+          <a:lstStyle/>
+          <a:p>
+            <a:pPr algn="ctr"/>
+            <a:endParaRPr lang="en-IN" sz="2000" b="0" i="0" dirty="0">
+              <a:solidFill>
+                <a:srgbClr val="FFFFFF"/>
+              </a:solidFill>
+            </a:endParaRPr>
+          </a:p>
+          <a:p>
+            <a:pPr algn="ctr"/>
+            <a:endParaRPr sz="2000" b="0" i="0" dirty="0">
+              <a:solidFill>
+                <a:srgbClr val="FFFFFF"/>
+              </a:solidFill>
+            </a:endParaRPr>
           </a:p>
         </p:txBody>
       </p:sp>
@@ -3885,23 +4013,23 @@
         </p:nvSpPr>
         <p:spPr>
           <a:xfrm>
-            <a:off x="3200400" y="3886200"/>
-            <a:ext cx="5760720" cy="1097280"/>
-          </a:xfrm>
-          <a:prstGeom prst="rect">
-            <a:avLst/>
-          </a:prstGeom>
-          <a:noFill/>
-        </p:spPr>
-        <p:txBody>
-          <a:bodyPr wrap="square">
-            <a:spAutoFit/>
-          </a:bodyPr>
-          <a:lstStyle/>
-          <a:p>
-            <a:pPr algn="l"/>
-            <a:r>
-              <a:rPr sz="1400" b="0">
+            <a:off x="4343400" y="3813048"/>
+            <a:ext cx="5760720" cy="523220"/>
+          </a:xfrm>
+          <a:prstGeom prst="rect">
+            <a:avLst/>
+          </a:prstGeom>
+          <a:noFill/>
+        </p:spPr>
+        <p:txBody>
+          <a:bodyPr wrap="square">
+            <a:spAutoFit/>
+          </a:bodyPr>
+          <a:lstStyle/>
+          <a:p>
+            <a:pPr algn="l"/>
+            <a:r>
+              <a:rPr sz="1400" b="0" dirty="0">
                 <a:solidFill>
                   <a:srgbClr val="00E576"/>
                 </a:solidFill>
@@ -3912,18 +4040,7 @@
           <a:p>
             <a:pPr algn="l"/>
             <a:r>
-              <a:rPr sz="1400" b="0">
-                <a:solidFill>
-                  <a:srgbClr val="00E576"/>
-                </a:solidFill>
-              </a:rPr>
-              <a:t>Tier 1 — 16-LUT Refinement (Proposed)</a:t>
-            </a:r>
-          </a:p>
-          <a:p>
-            <a:pPr algn="l"/>
-            <a:r>
-              <a:rPr sz="1400" b="0">
+              <a:rPr sz="1400" b="0" dirty="0">
                 <a:solidFill>
                   <a:srgbClr val="B0C8E0"/>
                 </a:solidFill>
@@ -4181,6 +4298,66 @@
         </p:spPr>
       </p:pic>
     </p:spTree>
+  </p:cSld>
+  <p:clrMapOvr>
+    <a:masterClrMapping/>
+  </p:clrMapOvr>
+</p:sld>
+</file>
+
+<file path=ppt/slides/slide11.xml><?xml version="1.0" encoding="utf-8"?>
+<p:sld xmlns:a="http://schemas.openxmlformats.org/drawingml/2006/main" xmlns:r="http://schemas.openxmlformats.org/officeDocument/2006/relationships" xmlns:p="http://schemas.openxmlformats.org/presentationml/2006/main">
+  <p:cSld>
+    <p:spTree>
+      <p:nvGrpSpPr>
+        <p:cNvPr id="1" name=""/>
+        <p:cNvGrpSpPr/>
+        <p:nvPr/>
+      </p:nvGrpSpPr>
+      <p:grpSpPr>
+        <a:xfrm>
+          <a:off x="0" y="0"/>
+          <a:ext cx="0" cy="0"/>
+          <a:chOff x="0" y="0"/>
+          <a:chExt cx="0" cy="0"/>
+        </a:xfrm>
+      </p:grpSpPr>
+      <p:pic>
+        <p:nvPicPr>
+          <p:cNvPr id="3" name="Picture 2">
+            <a:extLst>
+              <a:ext uri="{FF2B5EF4-FFF2-40B4-BE49-F238E27FC236}">
+                <a16:creationId xmlns:a16="http://schemas.microsoft.com/office/drawing/2014/main" id="{A259FD4E-7CFB-C6C8-8C91-093A62BC13E1}"/>
+              </a:ext>
+            </a:extLst>
+          </p:cNvPr>
+          <p:cNvPicPr>
+            <a:picLocks noChangeAspect="1"/>
+          </p:cNvPicPr>
+          <p:nvPr/>
+        </p:nvPicPr>
+        <p:blipFill>
+          <a:blip r:embed="rId2"/>
+          <a:stretch>
+            <a:fillRect/>
+          </a:stretch>
+        </p:blipFill>
+        <p:spPr>
+          <a:xfrm>
+            <a:off x="55179" y="-110359"/>
+            <a:ext cx="12133646" cy="6968359"/>
+          </a:xfrm>
+          <a:prstGeom prst="rect">
+            <a:avLst/>
+          </a:prstGeom>
+        </p:spPr>
+      </p:pic>
+    </p:spTree>
+    <p:extLst>
+      <p:ext uri="{BB962C8B-B14F-4D97-AF65-F5344CB8AC3E}">
+        <p14:creationId xmlns:p14="http://schemas.microsoft.com/office/powerpoint/2010/main" val="1705916494"/>
+      </p:ext>
+    </p:extLst>
   </p:cSld>
   <p:clrMapOvr>
     <a:masterClrMapping/>

</xml_diff>

<commit_message>
docs: add Future Work & Extensions roadmap to README, Knowledge Base, and presentation PPT
</commit_message>
<xml_diff>
--- a/docs/INT8_Transformer_FPGA_Presentation.pptx
+++ b/docs/INT8_Transformer_FPGA_Presentation.pptx
@@ -19,6 +19,7 @@
     <p:sldId id="264" r:id="rId10"/>
     <p:sldId id="265" r:id="rId11"/>
     <p:sldId id="266" r:id="rId12"/>
+    <p:sldId id="267" r:id="rId19"/>
   </p:sldIdLst>
   <p:sldSz cx="12188825" cy="6858000"/>
   <p:notesSz cx="6858000" cy="9144000"/>
@@ -4358,6 +4359,1002 @@
         <p14:creationId xmlns:p14="http://schemas.microsoft.com/office/powerpoint/2010/main" val="1705916494"/>
       </p:ext>
     </p:extLst>
+  </p:cSld>
+  <p:clrMapOvr>
+    <a:masterClrMapping/>
+  </p:clrMapOvr>
+</p:sld>
+</file>
+
+<file path=ppt/slides/slide12.xml><?xml version="1.0" encoding="utf-8"?>
+<p:sld xmlns:a="http://schemas.openxmlformats.org/drawingml/2006/main" xmlns:p="http://schemas.openxmlformats.org/presentationml/2006/main" xmlns:r="http://schemas.openxmlformats.org/officeDocument/2006/relationships">
+  <p:cSld>
+    <p:spTree>
+      <p:nvGrpSpPr>
+        <p:cNvPr id="1" name=""/>
+        <p:cNvGrpSpPr/>
+        <p:nvPr/>
+      </p:nvGrpSpPr>
+      <p:grpSpPr/>
+      <p:sp>
+        <p:nvSpPr>
+          <p:cNvPr id="2" name="Rectangle 1"/>
+          <p:cNvSpPr/>
+          <p:nvPr/>
+        </p:nvSpPr>
+        <p:spPr>
+          <a:xfrm>
+            <a:off x="0" y="0"/>
+            <a:ext cx="12188825" cy="6858000"/>
+          </a:xfrm>
+          <a:prstGeom prst="rect">
+            <a:avLst/>
+          </a:prstGeom>
+          <a:solidFill>
+            <a:srgbClr val="0B1120"/>
+          </a:solidFill>
+          <a:ln>
+            <a:solidFill>
+              <a:srgbClr val="0B1120"/>
+            </a:solidFill>
+          </a:ln>
+        </p:spPr>
+        <p:style>
+          <a:lnRef idx="1">
+            <a:schemeClr val="accent1"/>
+          </a:lnRef>
+          <a:fillRef idx="3">
+            <a:schemeClr val="accent1"/>
+          </a:fillRef>
+          <a:effectRef idx="2">
+            <a:schemeClr val="accent1"/>
+          </a:effectRef>
+          <a:fontRef idx="minor">
+            <a:schemeClr val="lt1"/>
+          </a:fontRef>
+        </p:style>
+        <p:txBody>
+          <a:bodyPr rtlCol="0" anchor="ctr"/>
+          <a:lstStyle/>
+          <a:p>
+            <a:pPr algn="ctr"/>
+          </a:p>
+        </p:txBody>
+      </p:sp>
+      <p:sp>
+        <p:nvSpPr>
+          <p:cNvPr id="3" name="Rectangle 2"/>
+          <p:cNvSpPr/>
+          <p:nvPr/>
+        </p:nvSpPr>
+        <p:spPr>
+          <a:xfrm>
+            <a:off x="0" y="0"/>
+            <a:ext cx="12188825" cy="73152"/>
+          </a:xfrm>
+          <a:prstGeom prst="rect">
+            <a:avLst/>
+          </a:prstGeom>
+          <a:solidFill>
+            <a:srgbClr val="00D4B2"/>
+          </a:solidFill>
+          <a:ln>
+            <a:solidFill>
+              <a:srgbClr val="00D4B2"/>
+            </a:solidFill>
+          </a:ln>
+        </p:spPr>
+        <p:style>
+          <a:lnRef idx="1">
+            <a:schemeClr val="accent1"/>
+          </a:lnRef>
+          <a:fillRef idx="3">
+            <a:schemeClr val="accent1"/>
+          </a:fillRef>
+          <a:effectRef idx="2">
+            <a:schemeClr val="accent1"/>
+          </a:effectRef>
+          <a:fontRef idx="minor">
+            <a:schemeClr val="lt1"/>
+          </a:fontRef>
+        </p:style>
+        <p:txBody>
+          <a:bodyPr rtlCol="0" anchor="ctr"/>
+          <a:lstStyle/>
+          <a:p>
+            <a:pPr algn="ctr"/>
+          </a:p>
+        </p:txBody>
+      </p:sp>
+      <p:sp>
+        <p:nvSpPr>
+          <p:cNvPr id="4" name="TextBox 3"/>
+          <p:cNvSpPr txBox="1"/>
+          <p:nvPr/>
+        </p:nvSpPr>
+        <p:spPr>
+          <a:xfrm>
+            <a:off x="365760" y="182880"/>
+            <a:ext cx="10972800" cy="548640"/>
+          </a:xfrm>
+          <a:prstGeom prst="rect">
+            <a:avLst/>
+          </a:prstGeom>
+          <a:noFill/>
+        </p:spPr>
+        <p:txBody>
+          <a:bodyPr wrap="square">
+            <a:spAutoFit/>
+          </a:bodyPr>
+          <a:lstStyle/>
+          <a:p>
+            <a:pPr>
+              <a:defRPr sz="2400" b="1">
+                <a:solidFill>
+                  <a:srgbClr val="FFFFFF"/>
+                </a:solidFill>
+              </a:defRPr>
+            </a:pPr>
+            <a:r>
+              <a:t>Future Scope &amp; Research Roadmap</a:t>
+            </a:r>
+          </a:p>
+        </p:txBody>
+      </p:sp>
+      <p:sp>
+        <p:nvSpPr>
+          <p:cNvPr id="5" name="Rectangle 4"/>
+          <p:cNvSpPr/>
+          <p:nvPr/>
+        </p:nvSpPr>
+        <p:spPr>
+          <a:xfrm>
+            <a:off x="365760" y="777240"/>
+            <a:ext cx="11430000" cy="18288"/>
+          </a:xfrm>
+          <a:prstGeom prst="rect">
+            <a:avLst/>
+          </a:prstGeom>
+          <a:solidFill>
+            <a:srgbClr val="1E293B"/>
+          </a:solidFill>
+          <a:ln>
+            <a:solidFill>
+              <a:srgbClr val="1E293B"/>
+            </a:solidFill>
+          </a:ln>
+        </p:spPr>
+        <p:style>
+          <a:lnRef idx="1">
+            <a:schemeClr val="accent1"/>
+          </a:lnRef>
+          <a:fillRef idx="3">
+            <a:schemeClr val="accent1"/>
+          </a:fillRef>
+          <a:effectRef idx="2">
+            <a:schemeClr val="accent1"/>
+          </a:effectRef>
+          <a:fontRef idx="minor">
+            <a:schemeClr val="lt1"/>
+          </a:fontRef>
+        </p:style>
+        <p:txBody>
+          <a:bodyPr rtlCol="0" anchor="ctr"/>
+          <a:lstStyle/>
+          <a:p>
+            <a:pPr algn="ctr"/>
+          </a:p>
+        </p:txBody>
+      </p:sp>
+      <p:sp>
+        <p:nvSpPr>
+          <p:cNvPr id="6" name="Rounded Rectangle 5"/>
+          <p:cNvSpPr/>
+          <p:nvPr/>
+        </p:nvSpPr>
+        <p:spPr>
+          <a:xfrm>
+            <a:off x="365760" y="960120"/>
+            <a:ext cx="5486400" cy="2468880"/>
+          </a:xfrm>
+          <a:prstGeom prst="roundRect">
+            <a:avLst/>
+          </a:prstGeom>
+          <a:solidFill>
+            <a:srgbClr val="131D32"/>
+          </a:solidFill>
+          <a:ln>
+            <a:solidFill>
+              <a:srgbClr val="2D3C5A"/>
+            </a:solidFill>
+          </a:ln>
+        </p:spPr>
+        <p:style>
+          <a:lnRef idx="1">
+            <a:schemeClr val="accent1"/>
+          </a:lnRef>
+          <a:fillRef idx="3">
+            <a:schemeClr val="accent1"/>
+          </a:fillRef>
+          <a:effectRef idx="2">
+            <a:schemeClr val="accent1"/>
+          </a:effectRef>
+          <a:fontRef idx="minor">
+            <a:schemeClr val="lt1"/>
+          </a:fontRef>
+        </p:style>
+        <p:txBody>
+          <a:bodyPr rtlCol="0" anchor="ctr"/>
+          <a:lstStyle/>
+          <a:p>
+            <a:pPr algn="ctr"/>
+          </a:p>
+        </p:txBody>
+      </p:sp>
+      <p:sp>
+        <p:nvSpPr>
+          <p:cNvPr id="7" name="Rounded Rectangle 6"/>
+          <p:cNvSpPr/>
+          <p:nvPr/>
+        </p:nvSpPr>
+        <p:spPr>
+          <a:xfrm>
+            <a:off x="548640" y="1143000"/>
+            <a:ext cx="411480" cy="411480"/>
+          </a:xfrm>
+          <a:prstGeom prst="roundRect">
+            <a:avLst/>
+          </a:prstGeom>
+          <a:solidFill>
+            <a:srgbClr val="00D4B2"/>
+          </a:solidFill>
+          <a:ln>
+            <a:solidFill>
+              <a:srgbClr val="00D4B2"/>
+            </a:solidFill>
+          </a:ln>
+        </p:spPr>
+        <p:style>
+          <a:lnRef idx="1">
+            <a:schemeClr val="accent1"/>
+          </a:lnRef>
+          <a:fillRef idx="3">
+            <a:schemeClr val="accent1"/>
+          </a:fillRef>
+          <a:effectRef idx="2">
+            <a:schemeClr val="accent1"/>
+          </a:effectRef>
+          <a:fontRef idx="minor">
+            <a:schemeClr val="lt1"/>
+          </a:fontRef>
+        </p:style>
+        <p:txBody>
+          <a:bodyPr rtlCol="0" anchor="ctr"/>
+          <a:lstStyle/>
+          <a:p>
+            <a:pPr algn="ctr">
+              <a:defRPr sz="1400" b="1">
+                <a:solidFill>
+                  <a:srgbClr val="0B1120"/>
+                </a:solidFill>
+              </a:defRPr>
+            </a:pPr>
+            <a:r>
+              <a:t>1</a:t>
+            </a:r>
+          </a:p>
+        </p:txBody>
+      </p:sp>
+      <p:sp>
+        <p:nvSpPr>
+          <p:cNvPr id="8" name="TextBox 7"/>
+          <p:cNvSpPr txBox="1"/>
+          <p:nvPr/>
+        </p:nvSpPr>
+        <p:spPr>
+          <a:xfrm>
+            <a:off x="1051560" y="1124712"/>
+            <a:ext cx="4663440" cy="457200"/>
+          </a:xfrm>
+          <a:prstGeom prst="rect">
+            <a:avLst/>
+          </a:prstGeom>
+          <a:noFill/>
+        </p:spPr>
+        <p:txBody>
+          <a:bodyPr wrap="none">
+            <a:spAutoFit/>
+          </a:bodyPr>
+          <a:lstStyle/>
+          <a:p>
+            <a:pPr>
+              <a:defRPr sz="1500" b="1">
+                <a:solidFill>
+                  <a:srgbClr val="FFFFFF"/>
+                </a:solidFill>
+              </a:defRPr>
+            </a:pPr>
+            <a:r>
+              <a:t>On-Chip Voice Frontend (WM8731)</a:t>
+            </a:r>
+          </a:p>
+        </p:txBody>
+      </p:sp>
+      <p:sp>
+        <p:nvSpPr>
+          <p:cNvPr id="9" name="TextBox 8"/>
+          <p:cNvSpPr txBox="1"/>
+          <p:nvPr/>
+        </p:nvSpPr>
+        <p:spPr>
+          <a:xfrm>
+            <a:off x="594360" y="1645920"/>
+            <a:ext cx="5029200" cy="1691640"/>
+          </a:xfrm>
+          <a:prstGeom prst="rect">
+            <a:avLst/>
+          </a:prstGeom>
+          <a:noFill/>
+        </p:spPr>
+        <p:txBody>
+          <a:bodyPr wrap="square">
+            <a:spAutoFit/>
+          </a:bodyPr>
+          <a:lstStyle/>
+          <a:p>
+            <a:pPr>
+              <a:spcAft>
+                <a:spcPts val="600"/>
+              </a:spcAft>
+              <a:defRPr sz="1100">
+                <a:solidFill>
+                  <a:srgbClr val="CBD5E1"/>
+                </a:solidFill>
+              </a:defRPr>
+            </a:pPr>
+            <a:r>
+              <a:t>[&gt;]  Direct I2S / I2C interface to DE2-115 Wolfson WM8731 audio CODEC.</a:t>
+            </a:r>
+          </a:p>
+          <a:p>
+            <a:pPr>
+              <a:spcAft>
+                <a:spcPts val="600"/>
+              </a:spcAft>
+              <a:defRPr sz="1100">
+                <a:solidFill>
+                  <a:srgbClr val="CBD5E1"/>
+                </a:solidFill>
+              </a:defRPr>
+            </a:pPr>
+            <a:r>
+              <a:t>[&gt;]  Hardware MFCC / Mel-Spectrogram pipeline directly in Verilog.</a:t>
+            </a:r>
+          </a:p>
+          <a:p>
+            <a:pPr>
+              <a:spcAft>
+                <a:spcPts val="600"/>
+              </a:spcAft>
+              <a:defRPr sz="1100">
+                <a:solidFill>
+                  <a:srgbClr val="CBD5E1"/>
+                </a:solidFill>
+              </a:defRPr>
+            </a:pPr>
+            <a:r>
+              <a:t>[&gt;]  Enables 100% autonomous, hostless hardware voice assistant (no PC needed).</a:t>
+            </a:r>
+          </a:p>
+        </p:txBody>
+      </p:sp>
+      <p:sp>
+        <p:nvSpPr>
+          <p:cNvPr id="10" name="Rounded Rectangle 9"/>
+          <p:cNvSpPr/>
+          <p:nvPr/>
+        </p:nvSpPr>
+        <p:spPr>
+          <a:xfrm>
+            <a:off x="6309360" y="960120"/>
+            <a:ext cx="5486400" cy="2468880"/>
+          </a:xfrm>
+          <a:prstGeom prst="roundRect">
+            <a:avLst/>
+          </a:prstGeom>
+          <a:solidFill>
+            <a:srgbClr val="131D32"/>
+          </a:solidFill>
+          <a:ln>
+            <a:solidFill>
+              <a:srgbClr val="2D3C5A"/>
+            </a:solidFill>
+          </a:ln>
+        </p:spPr>
+        <p:style>
+          <a:lnRef idx="1">
+            <a:schemeClr val="accent1"/>
+          </a:lnRef>
+          <a:fillRef idx="3">
+            <a:schemeClr val="accent1"/>
+          </a:fillRef>
+          <a:effectRef idx="2">
+            <a:schemeClr val="accent1"/>
+          </a:effectRef>
+          <a:fontRef idx="minor">
+            <a:schemeClr val="lt1"/>
+          </a:fontRef>
+        </p:style>
+        <p:txBody>
+          <a:bodyPr rtlCol="0" anchor="ctr"/>
+          <a:lstStyle/>
+          <a:p>
+            <a:pPr algn="ctr"/>
+          </a:p>
+        </p:txBody>
+      </p:sp>
+      <p:sp>
+        <p:nvSpPr>
+          <p:cNvPr id="11" name="Rounded Rectangle 10"/>
+          <p:cNvSpPr/>
+          <p:nvPr/>
+        </p:nvSpPr>
+        <p:spPr>
+          <a:xfrm>
+            <a:off x="6492240" y="1143000"/>
+            <a:ext cx="411480" cy="411480"/>
+          </a:xfrm>
+          <a:prstGeom prst="roundRect">
+            <a:avLst/>
+          </a:prstGeom>
+          <a:solidFill>
+            <a:srgbClr val="00D4B2"/>
+          </a:solidFill>
+          <a:ln>
+            <a:solidFill>
+              <a:srgbClr val="00D4B2"/>
+            </a:solidFill>
+          </a:ln>
+        </p:spPr>
+        <p:style>
+          <a:lnRef idx="1">
+            <a:schemeClr val="accent1"/>
+          </a:lnRef>
+          <a:fillRef idx="3">
+            <a:schemeClr val="accent1"/>
+          </a:fillRef>
+          <a:effectRef idx="2">
+            <a:schemeClr val="accent1"/>
+          </a:effectRef>
+          <a:fontRef idx="minor">
+            <a:schemeClr val="lt1"/>
+          </a:fontRef>
+        </p:style>
+        <p:txBody>
+          <a:bodyPr rtlCol="0" anchor="ctr"/>
+          <a:lstStyle/>
+          <a:p>
+            <a:pPr algn="ctr">
+              <a:defRPr sz="1400" b="1">
+                <a:solidFill>
+                  <a:srgbClr val="0B1120"/>
+                </a:solidFill>
+              </a:defRPr>
+            </a:pPr>
+            <a:r>
+              <a:t>2</a:t>
+            </a:r>
+          </a:p>
+        </p:txBody>
+      </p:sp>
+      <p:sp>
+        <p:nvSpPr>
+          <p:cNvPr id="12" name="TextBox 11"/>
+          <p:cNvSpPr txBox="1"/>
+          <p:nvPr/>
+        </p:nvSpPr>
+        <p:spPr>
+          <a:xfrm>
+            <a:off x="6995160" y="1124712"/>
+            <a:ext cx="4663440" cy="457200"/>
+          </a:xfrm>
+          <a:prstGeom prst="rect">
+            <a:avLst/>
+          </a:prstGeom>
+          <a:noFill/>
+        </p:spPr>
+        <p:txBody>
+          <a:bodyPr wrap="none">
+            <a:spAutoFit/>
+          </a:bodyPr>
+          <a:lstStyle/>
+          <a:p>
+            <a:pPr>
+              <a:defRPr sz="1500" b="1">
+                <a:solidFill>
+                  <a:srgbClr val="FFFFFF"/>
+                </a:solidFill>
+              </a:defRPr>
+            </a:pPr>
+            <a:r>
+              <a:t>Multi-Head Self-Attention (MHSA)</a:t>
+            </a:r>
+          </a:p>
+        </p:txBody>
+      </p:sp>
+      <p:sp>
+        <p:nvSpPr>
+          <p:cNvPr id="13" name="TextBox 12"/>
+          <p:cNvSpPr txBox="1"/>
+          <p:nvPr/>
+        </p:nvSpPr>
+        <p:spPr>
+          <a:xfrm>
+            <a:off x="6537960" y="1645920"/>
+            <a:ext cx="5029200" cy="1691640"/>
+          </a:xfrm>
+          <a:prstGeom prst="rect">
+            <a:avLst/>
+          </a:prstGeom>
+          <a:noFill/>
+        </p:spPr>
+        <p:txBody>
+          <a:bodyPr wrap="square">
+            <a:spAutoFit/>
+          </a:bodyPr>
+          <a:lstStyle/>
+          <a:p>
+            <a:pPr>
+              <a:spcAft>
+                <a:spcPts val="600"/>
+              </a:spcAft>
+              <a:defRPr sz="1100">
+                <a:solidFill>
+                  <a:srgbClr val="CBD5E1"/>
+                </a:solidFill>
+              </a:defRPr>
+            </a:pPr>
+            <a:r>
+              <a:t>[&gt;]  Scale from single-head (H=1) to 4-head / 8-head parallel attention engines.</a:t>
+            </a:r>
+          </a:p>
+          <a:p>
+            <a:pPr>
+              <a:spcAft>
+                <a:spcPts val="600"/>
+              </a:spcAft>
+              <a:defRPr sz="1100">
+                <a:solidFill>
+                  <a:srgbClr val="CBD5E1"/>
+                </a:solidFill>
+              </a:defRPr>
+            </a:pPr>
+            <a:r>
+              <a:t>[&gt;]  Pipeline multi-layer encoder blocks using onboard 2 MB IS61WV SRAM.</a:t>
+            </a:r>
+          </a:p>
+          <a:p>
+            <a:pPr>
+              <a:spcAft>
+                <a:spcPts val="600"/>
+              </a:spcAft>
+              <a:defRPr sz="1100">
+                <a:solidFill>
+                  <a:srgbClr val="CBD5E1"/>
+                </a:solidFill>
+              </a:defRPr>
+            </a:pPr>
+            <a:r>
+              <a:t>[&gt;]  Enables complex multi-turn dialog and richer sentence intent understanding.</a:t>
+            </a:r>
+          </a:p>
+        </p:txBody>
+      </p:sp>
+      <p:sp>
+        <p:nvSpPr>
+          <p:cNvPr id="14" name="Rounded Rectangle 13"/>
+          <p:cNvSpPr/>
+          <p:nvPr/>
+        </p:nvSpPr>
+        <p:spPr>
+          <a:xfrm>
+            <a:off x="365760" y="3703320"/>
+            <a:ext cx="5486400" cy="2468880"/>
+          </a:xfrm>
+          <a:prstGeom prst="roundRect">
+            <a:avLst/>
+          </a:prstGeom>
+          <a:solidFill>
+            <a:srgbClr val="131D32"/>
+          </a:solidFill>
+          <a:ln>
+            <a:solidFill>
+              <a:srgbClr val="2D3C5A"/>
+            </a:solidFill>
+          </a:ln>
+        </p:spPr>
+        <p:style>
+          <a:lnRef idx="1">
+            <a:schemeClr val="accent1"/>
+          </a:lnRef>
+          <a:fillRef idx="3">
+            <a:schemeClr val="accent1"/>
+          </a:fillRef>
+          <a:effectRef idx="2">
+            <a:schemeClr val="accent1"/>
+          </a:effectRef>
+          <a:fontRef idx="minor">
+            <a:schemeClr val="lt1"/>
+          </a:fontRef>
+        </p:style>
+        <p:txBody>
+          <a:bodyPr rtlCol="0" anchor="ctr"/>
+          <a:lstStyle/>
+          <a:p>
+            <a:pPr algn="ctr"/>
+          </a:p>
+        </p:txBody>
+      </p:sp>
+      <p:sp>
+        <p:nvSpPr>
+          <p:cNvPr id="15" name="Rounded Rectangle 14"/>
+          <p:cNvSpPr/>
+          <p:nvPr/>
+        </p:nvSpPr>
+        <p:spPr>
+          <a:xfrm>
+            <a:off x="548640" y="3886200"/>
+            <a:ext cx="411480" cy="411480"/>
+          </a:xfrm>
+          <a:prstGeom prst="roundRect">
+            <a:avLst/>
+          </a:prstGeom>
+          <a:solidFill>
+            <a:srgbClr val="00D4B2"/>
+          </a:solidFill>
+          <a:ln>
+            <a:solidFill>
+              <a:srgbClr val="00D4B2"/>
+            </a:solidFill>
+          </a:ln>
+        </p:spPr>
+        <p:style>
+          <a:lnRef idx="1">
+            <a:schemeClr val="accent1"/>
+          </a:lnRef>
+          <a:fillRef idx="3">
+            <a:schemeClr val="accent1"/>
+          </a:fillRef>
+          <a:effectRef idx="2">
+            <a:schemeClr val="accent1"/>
+          </a:effectRef>
+          <a:fontRef idx="minor">
+            <a:schemeClr val="lt1"/>
+          </a:fontRef>
+        </p:style>
+        <p:txBody>
+          <a:bodyPr rtlCol="0" anchor="ctr"/>
+          <a:lstStyle/>
+          <a:p>
+            <a:pPr algn="ctr">
+              <a:defRPr sz="1400" b="1">
+                <a:solidFill>
+                  <a:srgbClr val="0B1120"/>
+                </a:solidFill>
+              </a:defRPr>
+            </a:pPr>
+            <a:r>
+              <a:t>3</a:t>
+            </a:r>
+          </a:p>
+        </p:txBody>
+      </p:sp>
+      <p:sp>
+        <p:nvSpPr>
+          <p:cNvPr id="16" name="TextBox 15"/>
+          <p:cNvSpPr txBox="1"/>
+          <p:nvPr/>
+        </p:nvSpPr>
+        <p:spPr>
+          <a:xfrm>
+            <a:off x="1051560" y="3867912"/>
+            <a:ext cx="4663440" cy="457200"/>
+          </a:xfrm>
+          <a:prstGeom prst="rect">
+            <a:avLst/>
+          </a:prstGeom>
+          <a:noFill/>
+        </p:spPr>
+        <p:txBody>
+          <a:bodyPr wrap="none">
+            <a:spAutoFit/>
+          </a:bodyPr>
+          <a:lstStyle/>
+          <a:p>
+            <a:pPr>
+              <a:defRPr sz="1500" b="1">
+                <a:solidFill>
+                  <a:srgbClr val="FFFFFF"/>
+                </a:solidFill>
+              </a:defRPr>
+            </a:pPr>
+            <a:r>
+              <a:t>2D Systolic Array MAC Acceleration</a:t>
+            </a:r>
+          </a:p>
+        </p:txBody>
+      </p:sp>
+      <p:sp>
+        <p:nvSpPr>
+          <p:cNvPr id="17" name="TextBox 16"/>
+          <p:cNvSpPr txBox="1"/>
+          <p:nvPr/>
+        </p:nvSpPr>
+        <p:spPr>
+          <a:xfrm>
+            <a:off x="594360" y="4389120"/>
+            <a:ext cx="5029200" cy="1691640"/>
+          </a:xfrm>
+          <a:prstGeom prst="rect">
+            <a:avLst/>
+          </a:prstGeom>
+          <a:noFill/>
+        </p:spPr>
+        <p:txBody>
+          <a:bodyPr wrap="square">
+            <a:spAutoFit/>
+          </a:bodyPr>
+          <a:lstStyle/>
+          <a:p>
+            <a:pPr>
+              <a:spcAft>
+                <a:spcPts val="600"/>
+              </a:spcAft>
+              <a:defRPr sz="1100">
+                <a:solidFill>
+                  <a:srgbClr val="CBD5E1"/>
+                </a:solidFill>
+              </a:defRPr>
+            </a:pPr>
+            <a:r>
+              <a:t>[&gt;]  Upgrade time-multiplexed MAC array to 2D systolic matrix architecture.</a:t>
+            </a:r>
+          </a:p>
+          <a:p>
+            <a:pPr>
+              <a:spcAft>
+                <a:spcPts val="600"/>
+              </a:spcAft>
+              <a:defRPr sz="1100">
+                <a:solidFill>
+                  <a:srgbClr val="CBD5E1"/>
+                </a:solidFill>
+              </a:defRPr>
+            </a:pPr>
+            <a:r>
+              <a:t>[&gt;]  Concurrent token dot-products overlap attention and feed-forward stages.</a:t>
+            </a:r>
+          </a:p>
+          <a:p>
+            <a:pPr>
+              <a:spcAft>
+                <a:spcPts val="600"/>
+              </a:spcAft>
+              <a:defRPr sz="1100">
+                <a:solidFill>
+                  <a:srgbClr val="CBD5E1"/>
+                </a:solidFill>
+              </a:defRPr>
+            </a:pPr>
+            <a:r>
+              <a:t>[&gt;]  Targeting sub-50 us total latency (over 2.2x throughput increase).</a:t>
+            </a:r>
+          </a:p>
+        </p:txBody>
+      </p:sp>
+      <p:sp>
+        <p:nvSpPr>
+          <p:cNvPr id="18" name="Rounded Rectangle 17"/>
+          <p:cNvSpPr/>
+          <p:nvPr/>
+        </p:nvSpPr>
+        <p:spPr>
+          <a:xfrm>
+            <a:off x="6309360" y="3703320"/>
+            <a:ext cx="5486400" cy="2468880"/>
+          </a:xfrm>
+          <a:prstGeom prst="roundRect">
+            <a:avLst/>
+          </a:prstGeom>
+          <a:solidFill>
+            <a:srgbClr val="131D32"/>
+          </a:solidFill>
+          <a:ln>
+            <a:solidFill>
+              <a:srgbClr val="2D3C5A"/>
+            </a:solidFill>
+          </a:ln>
+        </p:spPr>
+        <p:style>
+          <a:lnRef idx="1">
+            <a:schemeClr val="accent1"/>
+          </a:lnRef>
+          <a:fillRef idx="3">
+            <a:schemeClr val="accent1"/>
+          </a:fillRef>
+          <a:effectRef idx="2">
+            <a:schemeClr val="accent1"/>
+          </a:effectRef>
+          <a:fontRef idx="minor">
+            <a:schemeClr val="lt1"/>
+          </a:fontRef>
+        </p:style>
+        <p:txBody>
+          <a:bodyPr rtlCol="0" anchor="ctr"/>
+          <a:lstStyle/>
+          <a:p>
+            <a:pPr algn="ctr"/>
+          </a:p>
+        </p:txBody>
+      </p:sp>
+      <p:sp>
+        <p:nvSpPr>
+          <p:cNvPr id="19" name="Rounded Rectangle 18"/>
+          <p:cNvSpPr/>
+          <p:nvPr/>
+        </p:nvSpPr>
+        <p:spPr>
+          <a:xfrm>
+            <a:off x="6492240" y="3886200"/>
+            <a:ext cx="411480" cy="411480"/>
+          </a:xfrm>
+          <a:prstGeom prst="roundRect">
+            <a:avLst/>
+          </a:prstGeom>
+          <a:solidFill>
+            <a:srgbClr val="00D4B2"/>
+          </a:solidFill>
+          <a:ln>
+            <a:solidFill>
+              <a:srgbClr val="00D4B2"/>
+            </a:solidFill>
+          </a:ln>
+        </p:spPr>
+        <p:style>
+          <a:lnRef idx="1">
+            <a:schemeClr val="accent1"/>
+          </a:lnRef>
+          <a:fillRef idx="3">
+            <a:schemeClr val="accent1"/>
+          </a:fillRef>
+          <a:effectRef idx="2">
+            <a:schemeClr val="accent1"/>
+          </a:effectRef>
+          <a:fontRef idx="minor">
+            <a:schemeClr val="lt1"/>
+          </a:fontRef>
+        </p:style>
+        <p:txBody>
+          <a:bodyPr rtlCol="0" anchor="ctr"/>
+          <a:lstStyle/>
+          <a:p>
+            <a:pPr algn="ctr">
+              <a:defRPr sz="1400" b="1">
+                <a:solidFill>
+                  <a:srgbClr val="0B1120"/>
+                </a:solidFill>
+              </a:defRPr>
+            </a:pPr>
+            <a:r>
+              <a:t>4</a:t>
+            </a:r>
+          </a:p>
+        </p:txBody>
+      </p:sp>
+      <p:sp>
+        <p:nvSpPr>
+          <p:cNvPr id="20" name="TextBox 19"/>
+          <p:cNvSpPr txBox="1"/>
+          <p:nvPr/>
+        </p:nvSpPr>
+        <p:spPr>
+          <a:xfrm>
+            <a:off x="6995160" y="3867912"/>
+            <a:ext cx="4663440" cy="457200"/>
+          </a:xfrm>
+          <a:prstGeom prst="rect">
+            <a:avLst/>
+          </a:prstGeom>
+          <a:noFill/>
+        </p:spPr>
+        <p:txBody>
+          <a:bodyPr wrap="none">
+            <a:spAutoFit/>
+          </a:bodyPr>
+          <a:lstStyle/>
+          <a:p>
+            <a:pPr>
+              <a:defRPr sz="1500" b="1">
+                <a:solidFill>
+                  <a:srgbClr val="FFFFFF"/>
+                </a:solidFill>
+              </a:defRPr>
+            </a:pPr>
+            <a:r>
+              <a:t>Sub-Byte (INT4 / FP8) Mixed Precision</a:t>
+            </a:r>
+          </a:p>
+        </p:txBody>
+      </p:sp>
+      <p:sp>
+        <p:nvSpPr>
+          <p:cNvPr id="21" name="TextBox 20"/>
+          <p:cNvSpPr txBox="1"/>
+          <p:nvPr/>
+        </p:nvSpPr>
+        <p:spPr>
+          <a:xfrm>
+            <a:off x="6537960" y="4389120"/>
+            <a:ext cx="5029200" cy="1691640"/>
+          </a:xfrm>
+          <a:prstGeom prst="rect">
+            <a:avLst/>
+          </a:prstGeom>
+          <a:noFill/>
+        </p:spPr>
+        <p:txBody>
+          <a:bodyPr wrap="square">
+            <a:spAutoFit/>
+          </a:bodyPr>
+          <a:lstStyle/>
+          <a:p>
+            <a:pPr>
+              <a:spcAft>
+                <a:spcPts val="600"/>
+              </a:spcAft>
+              <a:defRPr sz="1100">
+                <a:solidFill>
+                  <a:srgbClr val="CBD5E1"/>
+                </a:solidFill>
+              </a:defRPr>
+            </a:pPr>
+            <a:r>
+              <a:t>[&gt;]  Implement INT4 weight quantization with INT8 activation datapath.</a:t>
+            </a:r>
+          </a:p>
+          <a:p>
+            <a:pPr>
+              <a:spcAft>
+                <a:spcPts val="600"/>
+              </a:spcAft>
+              <a:defRPr sz="1100">
+                <a:solidFill>
+                  <a:srgbClr val="CBD5E1"/>
+                </a:solidFill>
+              </a:defRPr>
+            </a:pPr>
+            <a:r>
+              <a:t>[&gt;]  Halves on-chip BRAM footprint, fitting larger transformer vocabularies.</a:t>
+            </a:r>
+          </a:p>
+          <a:p>
+            <a:pPr>
+              <a:spcAft>
+                <a:spcPts val="600"/>
+              </a:spcAft>
+              <a:defRPr sz="1100">
+                <a:solidFill>
+                  <a:srgbClr val="CBD5E1"/>
+                </a:solidFill>
+              </a:defRPr>
+            </a:pPr>
+            <a:r>
+              <a:t>[&gt;]  Maintains high classification fidelity with zero accuracy loss.</a:t>
+            </a:r>
+          </a:p>
+        </p:txBody>
+      </p:sp>
+    </p:spTree>
   </p:cSld>
   <p:clrMapOvr>
     <a:masterClrMapping/>

</xml_diff>